<commit_message>
docs: align pitch with luma solo demo
</commit_message>
<xml_diff>
--- a/outputs/019e23f1-a7b1-79c1-92f4-adc2fd8a0855/presentations/silverlink-hackathon-pitch/output/silverlink-winner-level-pitch-speaker-notes.pptx
+++ b/outputs/019e23f1-a7b1-79c1-92f4-adc2fd8a0855/presentations/silverlink-hackathon-pitch/output/silverlink-winner-level-pitch-speaker-notes.pptx
@@ -2,22 +2,22 @@
 <file path=ppt/presentation.xml><?xml version="1.0" encoding="utf-8"?>
 <p:presentation xmlns:p="http://schemas.openxmlformats.org/presentationml/2006/main">
   <p:sldMasterIdLst>
-    <p:sldMasterId xmlns:r="http://schemas.openxmlformats.org/officeDocument/2006/relationships" id="2147483648" r:id="R59d98d32677e4fee"/>
+    <p:sldMasterId xmlns:r="http://schemas.openxmlformats.org/officeDocument/2006/relationships" id="2147483648" r:id="Rb01f23852e184a1b"/>
   </p:sldMasterIdLst>
   <p:notesMasterIdLst>
-    <p:notesMasterId xmlns:r="http://schemas.openxmlformats.org/officeDocument/2006/relationships" r:id="R5d35cf6f40bc4481"/>
+    <p:notesMasterId xmlns:r="http://schemas.openxmlformats.org/officeDocument/2006/relationships" r:id="Rbc6ccf50499d4eaa"/>
   </p:notesMasterIdLst>
   <p:sldIdLst>
-    <p:sldId xmlns:r="http://schemas.openxmlformats.org/officeDocument/2006/relationships" id="256" r:id="Rba5207bcc5fc4bf9"/>
-    <p:sldId xmlns:r="http://schemas.openxmlformats.org/officeDocument/2006/relationships" id="257" r:id="R3afa01143fcb4166"/>
-    <p:sldId xmlns:r="http://schemas.openxmlformats.org/officeDocument/2006/relationships" id="258" r:id="R360a8d7fad5e457f"/>
-    <p:sldId xmlns:r="http://schemas.openxmlformats.org/officeDocument/2006/relationships" id="259" r:id="R07130f220e7643e6"/>
-    <p:sldId xmlns:r="http://schemas.openxmlformats.org/officeDocument/2006/relationships" id="260" r:id="R8523f641785b4d15"/>
-    <p:sldId xmlns:r="http://schemas.openxmlformats.org/officeDocument/2006/relationships" id="261" r:id="Rc7b74784a42841a5"/>
-    <p:sldId xmlns:r="http://schemas.openxmlformats.org/officeDocument/2006/relationships" id="262" r:id="R8ab3e7741c3a4c98"/>
-    <p:sldId xmlns:r="http://schemas.openxmlformats.org/officeDocument/2006/relationships" id="263" r:id="R99e30bfcbb1a43d5"/>
-    <p:sldId xmlns:r="http://schemas.openxmlformats.org/officeDocument/2006/relationships" id="264" r:id="Rca3611475d3c4c2b"/>
-    <p:sldId xmlns:r="http://schemas.openxmlformats.org/officeDocument/2006/relationships" id="265" r:id="R7fba0c1d82f84dbc"/>
+    <p:sldId xmlns:r="http://schemas.openxmlformats.org/officeDocument/2006/relationships" id="256" r:id="R2f0b0977b0414817"/>
+    <p:sldId xmlns:r="http://schemas.openxmlformats.org/officeDocument/2006/relationships" id="257" r:id="R458a4573cbf64ea9"/>
+    <p:sldId xmlns:r="http://schemas.openxmlformats.org/officeDocument/2006/relationships" id="258" r:id="R6be95e703a594662"/>
+    <p:sldId xmlns:r="http://schemas.openxmlformats.org/officeDocument/2006/relationships" id="259" r:id="Rb3ec4463a20f4c51"/>
+    <p:sldId xmlns:r="http://schemas.openxmlformats.org/officeDocument/2006/relationships" id="260" r:id="R8680706c79c348c8"/>
+    <p:sldId xmlns:r="http://schemas.openxmlformats.org/officeDocument/2006/relationships" id="261" r:id="Rbcde4595359e49b5"/>
+    <p:sldId xmlns:r="http://schemas.openxmlformats.org/officeDocument/2006/relationships" id="262" r:id="R956eeb12c7a04d6f"/>
+    <p:sldId xmlns:r="http://schemas.openxmlformats.org/officeDocument/2006/relationships" id="263" r:id="R869862eb54c94a2e"/>
+    <p:sldId xmlns:r="http://schemas.openxmlformats.org/officeDocument/2006/relationships" id="264" r:id="Rb4125d1eac0741f4"/>
+    <p:sldId xmlns:r="http://schemas.openxmlformats.org/officeDocument/2006/relationships" id="265" r:id="Re380be9a05df4ad8"/>
   </p:sldIdLst>
   <p:sldSz cx="12192000" cy="6858000"/>
   <p:notesSz cx="6858000" cy="9144000"/>
@@ -987,35 +987,35 @@
           <a:p xmlns:a="http://schemas.openxmlformats.org/drawingml/2006/main">
             <a:r>
               <a:rPr lang="en-US" sz="1200"/>
-              <a:t>28s | Demo</a:t>
+              <a:t>28s | Luma solo demo</a:t>
             </a:r>
             <a:endParaRPr lang="en-US"/>
           </a:p>
           <a:p xmlns:a="http://schemas.openxmlformats.org/drawingml/2006/main">
             <a:r>
               <a:rPr lang="en-US" sz="1200"/>
-              <a:t>Here is the demo. The older adult does not open a complex app. A medicine box is on the table.</a:t>
+              <a:t>I am participating solo, so I chose a narrow, safe, executable slice.</a:t>
             </a:r>
             <a:endParaRPr lang="en-US"/>
           </a:p>
           <a:p xmlns:a="http://schemas.openxmlformats.org/drawingml/2006/main">
             <a:r>
               <a:rPr lang="en-US" sz="1200"/>
-              <a:t>SilverLink notices the quiet signal and says in Japanese: お薬を一緒に確認しましょうか。</a:t>
+              <a:t>In two minutes, judges can see the orb, Gemini vision, Google Cloud voice, a semantic event, and a human handoff.</a:t>
             </a:r>
             <a:endParaRPr lang="en-US"/>
           </a:p>
           <a:p xmlns:a="http://schemas.openxmlformats.org/drawingml/2006/main">
             <a:r>
               <a:rPr lang="en-US" sz="1200"/>
-              <a:t>Then Gemini reads what can be safely read, creates a large-text card, and prepares a family or pharmacist summary.</a:t>
+              <a:t>That is the whole point: small enough to be reliable, but complete enough to prove the agent loop.</a:t>
             </a:r>
             <a:endParaRPr lang="en-US"/>
           </a:p>
           <a:p xmlns:a="http://schemas.openxmlformats.org/drawingml/2006/main">
             <a:r>
               <a:rPr lang="en-US" sz="1200"/>
-              <a:t>Cue: switch to live app here if presenting live.</a:t>
+              <a:t>Cue: solo is a scope-control strength.</a:t>
             </a:r>
             <a:endParaRPr lang="en-US"/>
           </a:p>
@@ -1187,35 +1187,42 @@
           <a:p xmlns:a="http://schemas.openxmlformats.org/drawingml/2006/main">
             <a:r>
               <a:rPr lang="en-US" sz="1200"/>
-              <a:t>24s | Why Gemini</a:t>
+              <a:t>24s | Why Google Cloud + Gemini</a:t>
             </a:r>
             <a:endParaRPr lang="en-US"/>
           </a:p>
           <a:p xmlns:a="http://schemas.openxmlformats.org/drawingml/2006/main">
             <a:r>
               <a:rPr lang="en-US" sz="1200"/>
-              <a:t>Gemini is not used as a chatbot.</a:t>
+              <a:t>For this event, Google Cloud integration is not optional. It is a judging requirement.</a:t>
             </a:r>
             <a:endParaRPr lang="en-US"/>
           </a:p>
           <a:p xmlns:a="http://schemas.openxmlformats.org/drawingml/2006/main">
             <a:r>
               <a:rPr lang="en-US" sz="1200"/>
-              <a:t>It is the perception and reasoning layer behind the ambient agent.</a:t>
+              <a:t>SilverLink makes Google Cloud visible in the demo.</a:t>
             </a:r>
             <a:endParaRPr lang="en-US"/>
           </a:p>
           <a:p xmlns:a="http://schemas.openxmlformats.org/drawingml/2006/main">
             <a:r>
               <a:rPr lang="en-US" sz="1200"/>
-              <a:t>Vision understands medicine boxes and documents. Voice creates low-friction conversation. Structured output keeps cards and summaries stable.</a:t>
+              <a:t>Gemini handles vision, reasoning, and structured output. Google Cloud Text-to-Speech gives the Japanese voice a warmer tone.</a:t>
             </a:r>
             <a:endParaRPr lang="en-US"/>
           </a:p>
           <a:p xmlns:a="http://schemas.openxmlformats.org/drawingml/2006/main">
             <a:r>
               <a:rPr lang="en-US" sz="1200"/>
-              <a:t>Cue: not chatbot; perception and reasoning layer.</a:t>
+              <a:t>Cloud Run and Live tokens are the next delivery track, but today the visible proof is Gemini plus cloud voice.</a:t>
+            </a:r>
+            <a:endParaRPr lang="en-US"/>
+          </a:p>
+          <a:p xmlns:a="http://schemas.openxmlformats.org/drawingml/2006/main">
+            <a:r>
+              <a:rPr lang="en-US" sz="1200"/>
+              <a:t>Cue: say Google Cloud out loud.</a:t>
             </a:r>
             <a:endParaRPr lang="en-US"/>
           </a:p>
@@ -1470,7 +1477,7 @@
   </p:cSld>
   <p:clrMap bg1="lt1" tx1="dk1" bg2="lt2" tx2="dk2" accent1="accent1" accent2="accent2" accent3="accent3" accent4="accent4" accent5="accent5" accent6="accent6" hlink="hlink" folHlink="folHlink"/>
   <p:sldLayoutIdLst>
-    <p:sldLayoutId xmlns:r="http://schemas.openxmlformats.org/officeDocument/2006/relationships" id="2147483649" r:id="Rd6252ed96f1d4b01"/>
+    <p:sldLayoutId xmlns:r="http://schemas.openxmlformats.org/officeDocument/2006/relationships" id="2147483649" r:id="R74649aead7ca42ab"/>
   </p:sldLayoutIdLst>
   <p:txStyles>
     <p:titleStyle>
@@ -1769,7 +1776,7 @@
           <p:cNvPr id="1" name="">
             <a:extLst xmlns:a="http://schemas.openxmlformats.org/drawingml/2006/main">
               <a:ext uri="{FF2B5EF4-FFF2-40B4-BE49-F238E27FC236}">
-                <a16:creationId xmlns:a16="http://schemas.microsoft.com/office/drawing/2014/main" id="{734FDF5D-AC76-4C64-B286-A1D53F60DF98}"/>
+                <a16:creationId xmlns:a16="http://schemas.microsoft.com/office/drawing/2014/main" id="{889BBABD-3D44-4583-8358-F31EC5263F86}"/>
               </a:ext>
             </a:extLst>
           </p:cNvPr>
@@ -1804,7 +1811,7 @@
           <p:cNvPr id="2" name="">
             <a:extLst xmlns:a="http://schemas.openxmlformats.org/drawingml/2006/main">
               <a:ext uri="{FF2B5EF4-FFF2-40B4-BE49-F238E27FC236}">
-                <a16:creationId xmlns:a16="http://schemas.microsoft.com/office/drawing/2014/main" id="{D778C081-242C-4C7C-8914-B5D76E1D82D3}"/>
+                <a16:creationId xmlns:a16="http://schemas.microsoft.com/office/drawing/2014/main" id="{9EF37A2C-ED95-4ADA-B652-9BB43D9464EA}"/>
               </a:ext>
             </a:extLst>
           </p:cNvPr>
@@ -1839,7 +1846,7 @@
           <p:cNvPr id="3" name="">
             <a:extLst xmlns:a="http://schemas.openxmlformats.org/drawingml/2006/main">
               <a:ext uri="{FF2B5EF4-FFF2-40B4-BE49-F238E27FC236}">
-                <a16:creationId xmlns:a16="http://schemas.microsoft.com/office/drawing/2014/main" id="{7FDA3A99-850A-421C-B24B-BB5D58A1D4CA}"/>
+                <a16:creationId xmlns:a16="http://schemas.microsoft.com/office/drawing/2014/main" id="{8EED4932-1FEA-4F49-BF38-81F5347A79BB}"/>
               </a:ext>
             </a:extLst>
           </p:cNvPr>
@@ -1874,7 +1881,7 @@
           <p:cNvPr id="4" name="">
             <a:extLst xmlns:a="http://schemas.openxmlformats.org/drawingml/2006/main">
               <a:ext uri="{FF2B5EF4-FFF2-40B4-BE49-F238E27FC236}">
-                <a16:creationId xmlns:a16="http://schemas.microsoft.com/office/drawing/2014/main" id="{27C4282D-760B-438F-8E50-10669BF668C1}"/>
+                <a16:creationId xmlns:a16="http://schemas.microsoft.com/office/drawing/2014/main" id="{2069316F-C2DF-43C2-9922-3FEB44DB2247}"/>
               </a:ext>
             </a:extLst>
           </p:cNvPr>
@@ -1909,7 +1916,7 @@
           <p:cNvPr id="5" name="">
             <a:extLst xmlns:a="http://schemas.openxmlformats.org/drawingml/2006/main">
               <a:ext uri="{FF2B5EF4-FFF2-40B4-BE49-F238E27FC236}">
-                <a16:creationId xmlns:a16="http://schemas.microsoft.com/office/drawing/2014/main" id="{6D21CEBA-1002-4B37-AFC5-4B907A72EE27}"/>
+                <a16:creationId xmlns:a16="http://schemas.microsoft.com/office/drawing/2014/main" id="{43204A8B-9715-4B24-9EC2-D30CED974CBA}"/>
               </a:ext>
             </a:extLst>
           </p:cNvPr>
@@ -1944,7 +1951,7 @@
           <p:cNvPr id="6" name="">
             <a:extLst xmlns:a="http://schemas.openxmlformats.org/drawingml/2006/main">
               <a:ext uri="{FF2B5EF4-FFF2-40B4-BE49-F238E27FC236}">
-                <a16:creationId xmlns:a16="http://schemas.microsoft.com/office/drawing/2014/main" id="{3A617127-5CE8-478B-8A5A-1E4568721149}"/>
+                <a16:creationId xmlns:a16="http://schemas.microsoft.com/office/drawing/2014/main" id="{0819A9C2-A52C-4343-A3B4-8DAA580D670D}"/>
               </a:ext>
             </a:extLst>
           </p:cNvPr>
@@ -2008,7 +2015,7 @@
           <p:cNvPr id="7" name="">
             <a:extLst xmlns:a="http://schemas.openxmlformats.org/drawingml/2006/main">
               <a:ext uri="{FF2B5EF4-FFF2-40B4-BE49-F238E27FC236}">
-                <a16:creationId xmlns:a16="http://schemas.microsoft.com/office/drawing/2014/main" id="{DDC36904-6681-4601-B9DA-C5B5E246323A}"/>
+                <a16:creationId xmlns:a16="http://schemas.microsoft.com/office/drawing/2014/main" id="{1BB1F713-F446-400C-A5AD-3F7F67C20529}"/>
               </a:ext>
             </a:extLst>
           </p:cNvPr>
@@ -2072,7 +2079,7 @@
           <p:cNvPr id="8" name="">
             <a:extLst xmlns:a="http://schemas.openxmlformats.org/drawingml/2006/main">
               <a:ext uri="{FF2B5EF4-FFF2-40B4-BE49-F238E27FC236}">
-                <a16:creationId xmlns:a16="http://schemas.microsoft.com/office/drawing/2014/main" id="{3B854EBD-453B-4B26-B034-F4A7A8ED044E}"/>
+                <a16:creationId xmlns:a16="http://schemas.microsoft.com/office/drawing/2014/main" id="{2F6A7338-4FFA-44E5-B4D2-05EE4CBAB366}"/>
               </a:ext>
             </a:extLst>
           </p:cNvPr>
@@ -2136,7 +2143,7 @@
           <p:cNvPr id="9" name="">
             <a:extLst xmlns:a="http://schemas.openxmlformats.org/drawingml/2006/main">
               <a:ext uri="{FF2B5EF4-FFF2-40B4-BE49-F238E27FC236}">
-                <a16:creationId xmlns:a16="http://schemas.microsoft.com/office/drawing/2014/main" id="{66F3B471-1291-4F41-94F0-610AAA3B64AE}"/>
+                <a16:creationId xmlns:a16="http://schemas.microsoft.com/office/drawing/2014/main" id="{AEC7ACF9-781C-4884-9B1F-929CE109785D}"/>
               </a:ext>
             </a:extLst>
           </p:cNvPr>
@@ -2200,7 +2207,7 @@
           <p:cNvPr id="10" name="">
             <a:extLst xmlns:a="http://schemas.openxmlformats.org/drawingml/2006/main">
               <a:ext uri="{FF2B5EF4-FFF2-40B4-BE49-F238E27FC236}">
-                <a16:creationId xmlns:a16="http://schemas.microsoft.com/office/drawing/2014/main" id="{4D9CF397-684A-4780-B381-7EA5112ED0B4}"/>
+                <a16:creationId xmlns:a16="http://schemas.microsoft.com/office/drawing/2014/main" id="{58B6FA4F-DAB6-4DD3-951B-222980938129}"/>
               </a:ext>
             </a:extLst>
           </p:cNvPr>
@@ -2237,7 +2244,7 @@
           <p:cNvPr id="11" name="">
             <a:extLst xmlns:a="http://schemas.openxmlformats.org/drawingml/2006/main">
               <a:ext uri="{FF2B5EF4-FFF2-40B4-BE49-F238E27FC236}">
-                <a16:creationId xmlns:a16="http://schemas.microsoft.com/office/drawing/2014/main" id="{D8300E33-2935-484D-A81F-41BEE53F26D7}"/>
+                <a16:creationId xmlns:a16="http://schemas.microsoft.com/office/drawing/2014/main" id="{890481C6-731D-47EB-B72C-31A656ACC54E}"/>
               </a:ext>
             </a:extLst>
           </p:cNvPr>
@@ -2272,7 +2279,7 @@
           <p:cNvPr id="12" name="">
             <a:extLst xmlns:a="http://schemas.openxmlformats.org/drawingml/2006/main">
               <a:ext uri="{FF2B5EF4-FFF2-40B4-BE49-F238E27FC236}">
-                <a16:creationId xmlns:a16="http://schemas.microsoft.com/office/drawing/2014/main" id="{FF9DD5C7-4BFD-4790-B4E8-D88B95447CA5}"/>
+                <a16:creationId xmlns:a16="http://schemas.microsoft.com/office/drawing/2014/main" id="{94034441-33FA-4AAF-B713-B403C3759D7D}"/>
               </a:ext>
             </a:extLst>
           </p:cNvPr>
@@ -2309,7 +2316,7 @@
           <p:cNvPr id="13" name="">
             <a:extLst xmlns:a="http://schemas.openxmlformats.org/drawingml/2006/main">
               <a:ext uri="{FF2B5EF4-FFF2-40B4-BE49-F238E27FC236}">
-                <a16:creationId xmlns:a16="http://schemas.microsoft.com/office/drawing/2014/main" id="{5FA6E8FF-9C8D-4F1A-9EC5-661CD8CC8710}"/>
+                <a16:creationId xmlns:a16="http://schemas.microsoft.com/office/drawing/2014/main" id="{9CDA8600-5E34-40FE-AB1E-99622D516494}"/>
               </a:ext>
             </a:extLst>
           </p:cNvPr>
@@ -2373,7 +2380,7 @@
           <p:cNvPr id="14" name="">
             <a:extLst xmlns:a="http://schemas.openxmlformats.org/drawingml/2006/main">
               <a:ext uri="{FF2B5EF4-FFF2-40B4-BE49-F238E27FC236}">
-                <a16:creationId xmlns:a16="http://schemas.microsoft.com/office/drawing/2014/main" id="{1C9A960F-6333-4BB9-8DD4-1C2C62BE5BF9}"/>
+                <a16:creationId xmlns:a16="http://schemas.microsoft.com/office/drawing/2014/main" id="{61045578-8355-44AE-9B1C-353DFFC1A4EF}"/>
               </a:ext>
             </a:extLst>
           </p:cNvPr>
@@ -2437,7 +2444,7 @@
           <p:cNvPr id="15" name="">
             <a:extLst xmlns:a="http://schemas.openxmlformats.org/drawingml/2006/main">
               <a:ext uri="{FF2B5EF4-FFF2-40B4-BE49-F238E27FC236}">
-                <a16:creationId xmlns:a16="http://schemas.microsoft.com/office/drawing/2014/main" id="{D35C9EC2-B77E-4DC7-B834-3EFDC5E73900}"/>
+                <a16:creationId xmlns:a16="http://schemas.microsoft.com/office/drawing/2014/main" id="{201520E2-6E40-48DE-B300-0B96178458B3}"/>
               </a:ext>
             </a:extLst>
           </p:cNvPr>
@@ -2472,7 +2479,7 @@
           <p:cNvPr id="16" name="">
             <a:extLst xmlns:a="http://schemas.openxmlformats.org/drawingml/2006/main">
               <a:ext uri="{FF2B5EF4-FFF2-40B4-BE49-F238E27FC236}">
-                <a16:creationId xmlns:a16="http://schemas.microsoft.com/office/drawing/2014/main" id="{083504EC-7156-4AD7-ACBA-66A96CB217AC}"/>
+                <a16:creationId xmlns:a16="http://schemas.microsoft.com/office/drawing/2014/main" id="{C02790C0-5436-411B-A1C6-A53D5A80C8A0}"/>
               </a:ext>
             </a:extLst>
           </p:cNvPr>
@@ -2536,7 +2543,7 @@
           <p:cNvPr id="17" name="">
             <a:extLst xmlns:a="http://schemas.openxmlformats.org/drawingml/2006/main">
               <a:ext uri="{FF2B5EF4-FFF2-40B4-BE49-F238E27FC236}">
-                <a16:creationId xmlns:a16="http://schemas.microsoft.com/office/drawing/2014/main" id="{25D46FC5-462A-4255-9CDD-19DDFFCC7E6E}"/>
+                <a16:creationId xmlns:a16="http://schemas.microsoft.com/office/drawing/2014/main" id="{F8D138E8-60FF-4022-B171-1D8B18CEF4C3}"/>
               </a:ext>
             </a:extLst>
           </p:cNvPr>
@@ -2571,7 +2578,7 @@
           <p:cNvPr id="18" name="">
             <a:extLst xmlns:a="http://schemas.openxmlformats.org/drawingml/2006/main">
               <a:ext uri="{FF2B5EF4-FFF2-40B4-BE49-F238E27FC236}">
-                <a16:creationId xmlns:a16="http://schemas.microsoft.com/office/drawing/2014/main" id="{E46FA5EE-7DCB-4FEC-906D-7FF1940B55C2}"/>
+                <a16:creationId xmlns:a16="http://schemas.microsoft.com/office/drawing/2014/main" id="{9C3DC64A-FD9D-49E1-B642-D68A91374E98}"/>
               </a:ext>
             </a:extLst>
           </p:cNvPr>
@@ -2635,7 +2642,7 @@
           <p:cNvPr id="19" name="">
             <a:extLst xmlns:a="http://schemas.openxmlformats.org/drawingml/2006/main">
               <a:ext uri="{FF2B5EF4-FFF2-40B4-BE49-F238E27FC236}">
-                <a16:creationId xmlns:a16="http://schemas.microsoft.com/office/drawing/2014/main" id="{C31B75C6-334D-4AB8-A1F8-76427AB20DF5}"/>
+                <a16:creationId xmlns:a16="http://schemas.microsoft.com/office/drawing/2014/main" id="{15CFD268-2ACF-4225-BC39-F7896FE59E5F}"/>
               </a:ext>
             </a:extLst>
           </p:cNvPr>
@@ -2670,7 +2677,7 @@
           <p:cNvPr id="20" name="">
             <a:extLst xmlns:a="http://schemas.openxmlformats.org/drawingml/2006/main">
               <a:ext uri="{FF2B5EF4-FFF2-40B4-BE49-F238E27FC236}">
-                <a16:creationId xmlns:a16="http://schemas.microsoft.com/office/drawing/2014/main" id="{F18CE3CB-30C5-437A-A854-09F58D16244A}"/>
+                <a16:creationId xmlns:a16="http://schemas.microsoft.com/office/drawing/2014/main" id="{DA0BFE14-1ABD-4FB2-BE3A-BF249FAB835D}"/>
               </a:ext>
             </a:extLst>
           </p:cNvPr>
@@ -2734,7 +2741,7 @@
           <p:cNvPr id="21" name="">
             <a:extLst xmlns:a="http://schemas.openxmlformats.org/drawingml/2006/main">
               <a:ext uri="{FF2B5EF4-FFF2-40B4-BE49-F238E27FC236}">
-                <a16:creationId xmlns:a16="http://schemas.microsoft.com/office/drawing/2014/main" id="{15F8CC3E-E57D-4661-9B24-0B908EAE650C}"/>
+                <a16:creationId xmlns:a16="http://schemas.microsoft.com/office/drawing/2014/main" id="{A5102806-1829-4E1C-A3E5-7A5668E0D052}"/>
               </a:ext>
             </a:extLst>
           </p:cNvPr>
@@ -2769,7 +2776,7 @@
           <p:cNvPr id="22" name="">
             <a:extLst xmlns:a="http://schemas.openxmlformats.org/drawingml/2006/main">
               <a:ext uri="{FF2B5EF4-FFF2-40B4-BE49-F238E27FC236}">
-                <a16:creationId xmlns:a16="http://schemas.microsoft.com/office/drawing/2014/main" id="{C78D3197-8D8E-436F-A590-B6556C3D4A52}"/>
+                <a16:creationId xmlns:a16="http://schemas.microsoft.com/office/drawing/2014/main" id="{874EA450-7E0A-4040-BED4-10BACE29F367}"/>
               </a:ext>
             </a:extLst>
           </p:cNvPr>
@@ -2833,7 +2840,7 @@
           <p:cNvPr id="23" name="">
             <a:extLst xmlns:a="http://schemas.openxmlformats.org/drawingml/2006/main">
               <a:ext uri="{FF2B5EF4-FFF2-40B4-BE49-F238E27FC236}">
-                <a16:creationId xmlns:a16="http://schemas.microsoft.com/office/drawing/2014/main" id="{775641A9-C7C5-48CB-8B8D-0F1E0AD9A1CF}"/>
+                <a16:creationId xmlns:a16="http://schemas.microsoft.com/office/drawing/2014/main" id="{C9BE55F3-694B-47B7-B646-187D33BD820D}"/>
               </a:ext>
             </a:extLst>
           </p:cNvPr>
@@ -2897,7 +2904,7 @@
           <p:cNvPr id="24" name="">
             <a:extLst xmlns:a="http://schemas.openxmlformats.org/drawingml/2006/main">
               <a:ext uri="{FF2B5EF4-FFF2-40B4-BE49-F238E27FC236}">
-                <a16:creationId xmlns:a16="http://schemas.microsoft.com/office/drawing/2014/main" id="{92F1B430-F812-4688-97F0-11A64E45E79B}"/>
+                <a16:creationId xmlns:a16="http://schemas.microsoft.com/office/drawing/2014/main" id="{04CFB1B0-E6AC-493B-8B7C-8FD15D774306}"/>
               </a:ext>
             </a:extLst>
           </p:cNvPr>
@@ -2961,7 +2968,7 @@
           <p:cNvPr id="25" name="">
             <a:extLst xmlns:a="http://schemas.openxmlformats.org/drawingml/2006/main">
               <a:ext uri="{FF2B5EF4-FFF2-40B4-BE49-F238E27FC236}">
-                <a16:creationId xmlns:a16="http://schemas.microsoft.com/office/drawing/2014/main" id="{44878892-251F-462F-97C0-A480C8E02D07}"/>
+                <a16:creationId xmlns:a16="http://schemas.microsoft.com/office/drawing/2014/main" id="{657481C5-1240-47EE-9A7E-F6E747D1F4E3}"/>
               </a:ext>
             </a:extLst>
           </p:cNvPr>
@@ -3023,7 +3030,7 @@
     </p:spTree>
     <p:extLst>
       <p:ext uri="{BB962C8B-B14F-4D97-AF65-F5344CB8AC3E}">
-        <p14:creationId xmlns:p14="http://schemas.microsoft.com/office/powerpoint/2010/main" val="1727079996"/>
+        <p14:creationId xmlns:p14="http://schemas.microsoft.com/office/powerpoint/2010/main" val="45454742"/>
       </p:ext>
     </p:extLst>
   </p:cSld>
@@ -3047,7 +3054,7 @@
           <p:cNvPr id="1" name="">
             <a:extLst xmlns:a="http://schemas.openxmlformats.org/drawingml/2006/main">
               <a:ext uri="{FF2B5EF4-FFF2-40B4-BE49-F238E27FC236}">
-                <a16:creationId xmlns:a16="http://schemas.microsoft.com/office/drawing/2014/main" id="{A12B0083-7D41-4F37-92FC-969D53D45207}"/>
+                <a16:creationId xmlns:a16="http://schemas.microsoft.com/office/drawing/2014/main" id="{3461E129-CC80-4529-A214-C09EE50CDE1F}"/>
               </a:ext>
             </a:extLst>
           </p:cNvPr>
@@ -3082,7 +3089,7 @@
           <p:cNvPr id="2" name="">
             <a:extLst xmlns:a="http://schemas.openxmlformats.org/drawingml/2006/main">
               <a:ext uri="{FF2B5EF4-FFF2-40B4-BE49-F238E27FC236}">
-                <a16:creationId xmlns:a16="http://schemas.microsoft.com/office/drawing/2014/main" id="{A953242F-D6BF-4C6A-A28B-3C6A2EABE5D2}"/>
+                <a16:creationId xmlns:a16="http://schemas.microsoft.com/office/drawing/2014/main" id="{30A59688-68A4-40B6-A3D2-6E3A5E8D0216}"/>
               </a:ext>
             </a:extLst>
           </p:cNvPr>
@@ -3117,7 +3124,7 @@
           <p:cNvPr id="3" name="">
             <a:extLst xmlns:a="http://schemas.openxmlformats.org/drawingml/2006/main">
               <a:ext uri="{FF2B5EF4-FFF2-40B4-BE49-F238E27FC236}">
-                <a16:creationId xmlns:a16="http://schemas.microsoft.com/office/drawing/2014/main" id="{2EB36559-1F74-475B-BC7C-4724E4659628}"/>
+                <a16:creationId xmlns:a16="http://schemas.microsoft.com/office/drawing/2014/main" id="{F2AB39EE-6875-498A-83C9-418FA6814B34}"/>
               </a:ext>
             </a:extLst>
           </p:cNvPr>
@@ -3152,7 +3159,7 @@
           <p:cNvPr id="4" name="">
             <a:extLst xmlns:a="http://schemas.openxmlformats.org/drawingml/2006/main">
               <a:ext uri="{FF2B5EF4-FFF2-40B4-BE49-F238E27FC236}">
-                <a16:creationId xmlns:a16="http://schemas.microsoft.com/office/drawing/2014/main" id="{B365AF29-D76C-4C27-8DC5-08EED87FF858}"/>
+                <a16:creationId xmlns:a16="http://schemas.microsoft.com/office/drawing/2014/main" id="{36B09831-8E04-4727-B0D0-D1AB8BD98143}"/>
               </a:ext>
             </a:extLst>
           </p:cNvPr>
@@ -3187,7 +3194,7 @@
           <p:cNvPr id="5" name="">
             <a:extLst xmlns:a="http://schemas.openxmlformats.org/drawingml/2006/main">
               <a:ext uri="{FF2B5EF4-FFF2-40B4-BE49-F238E27FC236}">
-                <a16:creationId xmlns:a16="http://schemas.microsoft.com/office/drawing/2014/main" id="{8BCD261E-8D3E-47AA-80D4-CC87E368978E}"/>
+                <a16:creationId xmlns:a16="http://schemas.microsoft.com/office/drawing/2014/main" id="{79523133-98CC-482E-8614-4D1AFB5437B0}"/>
               </a:ext>
             </a:extLst>
           </p:cNvPr>
@@ -3222,7 +3229,7 @@
           <p:cNvPr id="6" name="">
             <a:extLst xmlns:a="http://schemas.openxmlformats.org/drawingml/2006/main">
               <a:ext uri="{FF2B5EF4-FFF2-40B4-BE49-F238E27FC236}">
-                <a16:creationId xmlns:a16="http://schemas.microsoft.com/office/drawing/2014/main" id="{C2695E5A-AF9B-4552-9ACD-F190107F7CC8}"/>
+                <a16:creationId xmlns:a16="http://schemas.microsoft.com/office/drawing/2014/main" id="{DE93D69D-3CCB-4DF4-AC78-D43A7F89F862}"/>
               </a:ext>
             </a:extLst>
           </p:cNvPr>
@@ -3286,7 +3293,7 @@
           <p:cNvPr id="7" name="">
             <a:extLst xmlns:a="http://schemas.openxmlformats.org/drawingml/2006/main">
               <a:ext uri="{FF2B5EF4-FFF2-40B4-BE49-F238E27FC236}">
-                <a16:creationId xmlns:a16="http://schemas.microsoft.com/office/drawing/2014/main" id="{3895624E-3C0C-410D-AA7F-68A829C74953}"/>
+                <a16:creationId xmlns:a16="http://schemas.microsoft.com/office/drawing/2014/main" id="{62BEA1CE-D1C2-49FA-B3DE-BC39C27D1C63}"/>
               </a:ext>
             </a:extLst>
           </p:cNvPr>
@@ -3350,7 +3357,7 @@
           <p:cNvPr id="8" name="">
             <a:extLst xmlns:a="http://schemas.openxmlformats.org/drawingml/2006/main">
               <a:ext uri="{FF2B5EF4-FFF2-40B4-BE49-F238E27FC236}">
-                <a16:creationId xmlns:a16="http://schemas.microsoft.com/office/drawing/2014/main" id="{629C897C-CC54-4CF9-B0F4-41620EF714CD}"/>
+                <a16:creationId xmlns:a16="http://schemas.microsoft.com/office/drawing/2014/main" id="{2F970E76-D524-4F53-8570-4FE448F2CF18}"/>
               </a:ext>
             </a:extLst>
           </p:cNvPr>
@@ -3414,7 +3421,7 @@
           <p:cNvPr id="9" name="">
             <a:extLst xmlns:a="http://schemas.openxmlformats.org/drawingml/2006/main">
               <a:ext uri="{FF2B5EF4-FFF2-40B4-BE49-F238E27FC236}">
-                <a16:creationId xmlns:a16="http://schemas.microsoft.com/office/drawing/2014/main" id="{5A9D4C8E-CA98-40A0-A9BD-5B5FA3ABCEEE}"/>
+                <a16:creationId xmlns:a16="http://schemas.microsoft.com/office/drawing/2014/main" id="{1B2FD812-2FCA-45A2-B82B-54585292B073}"/>
               </a:ext>
             </a:extLst>
           </p:cNvPr>
@@ -3478,7 +3485,7 @@
           <p:cNvPr id="10" name="">
             <a:extLst xmlns:a="http://schemas.openxmlformats.org/drawingml/2006/main">
               <a:ext uri="{FF2B5EF4-FFF2-40B4-BE49-F238E27FC236}">
-                <a16:creationId xmlns:a16="http://schemas.microsoft.com/office/drawing/2014/main" id="{DB38CBA5-E92F-497D-BD71-1295FAB756FC}"/>
+                <a16:creationId xmlns:a16="http://schemas.microsoft.com/office/drawing/2014/main" id="{3F5ADC90-6F20-4219-85A2-18370A0CFC12}"/>
               </a:ext>
             </a:extLst>
           </p:cNvPr>
@@ -3515,7 +3522,7 @@
           <p:cNvPr id="11" name="">
             <a:extLst xmlns:a="http://schemas.openxmlformats.org/drawingml/2006/main">
               <a:ext uri="{FF2B5EF4-FFF2-40B4-BE49-F238E27FC236}">
-                <a16:creationId xmlns:a16="http://schemas.microsoft.com/office/drawing/2014/main" id="{D738641F-EDE6-4B1F-8AF7-B6E37D30B5E4}"/>
+                <a16:creationId xmlns:a16="http://schemas.microsoft.com/office/drawing/2014/main" id="{1528AECC-F054-43BA-87B7-923FC281D2F4}"/>
               </a:ext>
             </a:extLst>
           </p:cNvPr>
@@ -3550,7 +3557,7 @@
           <p:cNvPr id="12" name="">
             <a:extLst xmlns:a="http://schemas.openxmlformats.org/drawingml/2006/main">
               <a:ext uri="{FF2B5EF4-FFF2-40B4-BE49-F238E27FC236}">
-                <a16:creationId xmlns:a16="http://schemas.microsoft.com/office/drawing/2014/main" id="{CD33DA70-61C5-487B-AAEC-4B7701B5D998}"/>
+                <a16:creationId xmlns:a16="http://schemas.microsoft.com/office/drawing/2014/main" id="{DD5DDDD0-1F12-4DEB-89C7-A585EB40EA2C}"/>
               </a:ext>
             </a:extLst>
           </p:cNvPr>
@@ -3587,7 +3594,7 @@
           <p:cNvPr id="13" name="">
             <a:extLst xmlns:a="http://schemas.openxmlformats.org/drawingml/2006/main">
               <a:ext uri="{FF2B5EF4-FFF2-40B4-BE49-F238E27FC236}">
-                <a16:creationId xmlns:a16="http://schemas.microsoft.com/office/drawing/2014/main" id="{ED186B04-60C4-4862-BA51-7071900C8D82}"/>
+                <a16:creationId xmlns:a16="http://schemas.microsoft.com/office/drawing/2014/main" id="{545EED4C-FA0F-4307-A01B-459E8A7D4C58}"/>
               </a:ext>
             </a:extLst>
           </p:cNvPr>
@@ -3622,7 +3629,7 @@
           <p:cNvPr id="14" name="">
             <a:extLst xmlns:a="http://schemas.openxmlformats.org/drawingml/2006/main">
               <a:ext uri="{FF2B5EF4-FFF2-40B4-BE49-F238E27FC236}">
-                <a16:creationId xmlns:a16="http://schemas.microsoft.com/office/drawing/2014/main" id="{E7EAC56D-3A85-424C-9AAF-452D3DB76F16}"/>
+                <a16:creationId xmlns:a16="http://schemas.microsoft.com/office/drawing/2014/main" id="{A1B7EEBA-1DE9-4CD1-AFB2-FDCF3E8BC2BB}"/>
               </a:ext>
             </a:extLst>
           </p:cNvPr>
@@ -3686,7 +3693,7 @@
           <p:cNvPr id="15" name="">
             <a:extLst xmlns:a="http://schemas.openxmlformats.org/drawingml/2006/main">
               <a:ext uri="{FF2B5EF4-FFF2-40B4-BE49-F238E27FC236}">
-                <a16:creationId xmlns:a16="http://schemas.microsoft.com/office/drawing/2014/main" id="{D567D33C-8636-4BA8-B12A-6B6C8F705568}"/>
+                <a16:creationId xmlns:a16="http://schemas.microsoft.com/office/drawing/2014/main" id="{9160FCD8-DBA0-42D1-833D-6EF463F34489}"/>
               </a:ext>
             </a:extLst>
           </p:cNvPr>
@@ -3750,7 +3757,7 @@
           <p:cNvPr id="16" name="">
             <a:extLst xmlns:a="http://schemas.openxmlformats.org/drawingml/2006/main">
               <a:ext uri="{FF2B5EF4-FFF2-40B4-BE49-F238E27FC236}">
-                <a16:creationId xmlns:a16="http://schemas.microsoft.com/office/drawing/2014/main" id="{0C27A287-D694-45E1-99E8-F3FFF8103153}"/>
+                <a16:creationId xmlns:a16="http://schemas.microsoft.com/office/drawing/2014/main" id="{8F4E6F68-801B-42D7-BA67-320B255FB860}"/>
               </a:ext>
             </a:extLst>
           </p:cNvPr>
@@ -3785,7 +3792,7 @@
           <p:cNvPr id="17" name="">
             <a:extLst xmlns:a="http://schemas.openxmlformats.org/drawingml/2006/main">
               <a:ext uri="{FF2B5EF4-FFF2-40B4-BE49-F238E27FC236}">
-                <a16:creationId xmlns:a16="http://schemas.microsoft.com/office/drawing/2014/main" id="{A229DF86-3BBA-4ECB-AF6F-43AB6FD0D9E8}"/>
+                <a16:creationId xmlns:a16="http://schemas.microsoft.com/office/drawing/2014/main" id="{053A3C2E-E2C9-41EE-B926-7725D8030764}"/>
               </a:ext>
             </a:extLst>
           </p:cNvPr>
@@ -3849,7 +3856,7 @@
           <p:cNvPr id="18" name="">
             <a:extLst xmlns:a="http://schemas.openxmlformats.org/drawingml/2006/main">
               <a:ext uri="{FF2B5EF4-FFF2-40B4-BE49-F238E27FC236}">
-                <a16:creationId xmlns:a16="http://schemas.microsoft.com/office/drawing/2014/main" id="{4AAA553D-41EA-43A1-B6E6-E0CD6CC7334F}"/>
+                <a16:creationId xmlns:a16="http://schemas.microsoft.com/office/drawing/2014/main" id="{E0B41C8D-8D6B-43D4-BB93-B26C80A5F89D}"/>
               </a:ext>
             </a:extLst>
           </p:cNvPr>
@@ -3884,7 +3891,7 @@
           <p:cNvPr id="19" name="">
             <a:extLst xmlns:a="http://schemas.openxmlformats.org/drawingml/2006/main">
               <a:ext uri="{FF2B5EF4-FFF2-40B4-BE49-F238E27FC236}">
-                <a16:creationId xmlns:a16="http://schemas.microsoft.com/office/drawing/2014/main" id="{463EF66E-DFD7-426C-8B2D-AA8C6298FB8D}"/>
+                <a16:creationId xmlns:a16="http://schemas.microsoft.com/office/drawing/2014/main" id="{4D99B25B-46AC-4F4D-85D7-B5E45DE102BE}"/>
               </a:ext>
             </a:extLst>
           </p:cNvPr>
@@ -3948,7 +3955,7 @@
           <p:cNvPr id="20" name="">
             <a:extLst xmlns:a="http://schemas.openxmlformats.org/drawingml/2006/main">
               <a:ext uri="{FF2B5EF4-FFF2-40B4-BE49-F238E27FC236}">
-                <a16:creationId xmlns:a16="http://schemas.microsoft.com/office/drawing/2014/main" id="{5DA3E241-A3A2-4BBD-B874-FC5FF5E7DE78}"/>
+                <a16:creationId xmlns:a16="http://schemas.microsoft.com/office/drawing/2014/main" id="{4AEBED32-F760-4881-98A4-8A216975D5D7}"/>
               </a:ext>
             </a:extLst>
           </p:cNvPr>
@@ -4012,7 +4019,7 @@
           <p:cNvPr id="21" name="">
             <a:extLst xmlns:a="http://schemas.openxmlformats.org/drawingml/2006/main">
               <a:ext uri="{FF2B5EF4-FFF2-40B4-BE49-F238E27FC236}">
-                <a16:creationId xmlns:a16="http://schemas.microsoft.com/office/drawing/2014/main" id="{E394082F-47B6-4931-814B-37FB8032E49A}"/>
+                <a16:creationId xmlns:a16="http://schemas.microsoft.com/office/drawing/2014/main" id="{5E0C0371-F03D-46A5-A006-46EEBF6A5F69}"/>
               </a:ext>
             </a:extLst>
           </p:cNvPr>
@@ -4074,7 +4081,7 @@
     </p:spTree>
     <p:extLst>
       <p:ext uri="{BB962C8B-B14F-4D97-AF65-F5344CB8AC3E}">
-        <p14:creationId xmlns:p14="http://schemas.microsoft.com/office/powerpoint/2010/main" val="1157439135"/>
+        <p14:creationId xmlns:p14="http://schemas.microsoft.com/office/powerpoint/2010/main" val="1304748589"/>
       </p:ext>
     </p:extLst>
   </p:cSld>
@@ -4098,7 +4105,7 @@
           <p:cNvPr id="1" name="">
             <a:extLst xmlns:a="http://schemas.openxmlformats.org/drawingml/2006/main">
               <a:ext uri="{FF2B5EF4-FFF2-40B4-BE49-F238E27FC236}">
-                <a16:creationId xmlns:a16="http://schemas.microsoft.com/office/drawing/2014/main" id="{E11AEB44-8516-41A0-B265-C2192F86AA87}"/>
+                <a16:creationId xmlns:a16="http://schemas.microsoft.com/office/drawing/2014/main" id="{2897C8AE-36BC-4753-9D77-1F3C162B04BF}"/>
               </a:ext>
             </a:extLst>
           </p:cNvPr>
@@ -4133,7 +4140,7 @@
           <p:cNvPr id="2" name="">
             <a:extLst xmlns:a="http://schemas.openxmlformats.org/drawingml/2006/main">
               <a:ext uri="{FF2B5EF4-FFF2-40B4-BE49-F238E27FC236}">
-                <a16:creationId xmlns:a16="http://schemas.microsoft.com/office/drawing/2014/main" id="{B2E83A39-8667-423F-8F5A-DDEDD1C0B7BF}"/>
+                <a16:creationId xmlns:a16="http://schemas.microsoft.com/office/drawing/2014/main" id="{5AA7F8BF-C0D4-42BC-B0C4-9CC3ED3CCB88}"/>
               </a:ext>
             </a:extLst>
           </p:cNvPr>
@@ -4168,7 +4175,7 @@
           <p:cNvPr id="3" name="">
             <a:extLst xmlns:a="http://schemas.openxmlformats.org/drawingml/2006/main">
               <a:ext uri="{FF2B5EF4-FFF2-40B4-BE49-F238E27FC236}">
-                <a16:creationId xmlns:a16="http://schemas.microsoft.com/office/drawing/2014/main" id="{C8A60BED-C1E2-4068-9084-1EAD5F5DDF8B}"/>
+                <a16:creationId xmlns:a16="http://schemas.microsoft.com/office/drawing/2014/main" id="{9AF8A129-64C5-44F3-85DF-56667290C454}"/>
               </a:ext>
             </a:extLst>
           </p:cNvPr>
@@ -4203,7 +4210,7 @@
           <p:cNvPr id="4" name="">
             <a:extLst xmlns:a="http://schemas.openxmlformats.org/drawingml/2006/main">
               <a:ext uri="{FF2B5EF4-FFF2-40B4-BE49-F238E27FC236}">
-                <a16:creationId xmlns:a16="http://schemas.microsoft.com/office/drawing/2014/main" id="{48B2AEA8-3704-4159-9821-00A6840E99D1}"/>
+                <a16:creationId xmlns:a16="http://schemas.microsoft.com/office/drawing/2014/main" id="{98489630-EDA7-4C63-84DF-8E7E313CD884}"/>
               </a:ext>
             </a:extLst>
           </p:cNvPr>
@@ -4238,7 +4245,7 @@
           <p:cNvPr id="5" name="">
             <a:extLst xmlns:a="http://schemas.openxmlformats.org/drawingml/2006/main">
               <a:ext uri="{FF2B5EF4-FFF2-40B4-BE49-F238E27FC236}">
-                <a16:creationId xmlns:a16="http://schemas.microsoft.com/office/drawing/2014/main" id="{D8858B2A-E964-4B36-9017-7BE975BDD27D}"/>
+                <a16:creationId xmlns:a16="http://schemas.microsoft.com/office/drawing/2014/main" id="{81A9187B-D6D8-4893-BA26-5AC9EFB552FA}"/>
               </a:ext>
             </a:extLst>
           </p:cNvPr>
@@ -4273,7 +4280,7 @@
           <p:cNvPr id="6" name="">
             <a:extLst xmlns:a="http://schemas.openxmlformats.org/drawingml/2006/main">
               <a:ext uri="{FF2B5EF4-FFF2-40B4-BE49-F238E27FC236}">
-                <a16:creationId xmlns:a16="http://schemas.microsoft.com/office/drawing/2014/main" id="{713049E6-1758-4890-A1DB-064CC2D2DC9C}"/>
+                <a16:creationId xmlns:a16="http://schemas.microsoft.com/office/drawing/2014/main" id="{1979CAFD-12DE-4636-9BF7-B366910E6E7A}"/>
               </a:ext>
             </a:extLst>
           </p:cNvPr>
@@ -4337,7 +4344,7 @@
           <p:cNvPr id="7" name="">
             <a:extLst xmlns:a="http://schemas.openxmlformats.org/drawingml/2006/main">
               <a:ext uri="{FF2B5EF4-FFF2-40B4-BE49-F238E27FC236}">
-                <a16:creationId xmlns:a16="http://schemas.microsoft.com/office/drawing/2014/main" id="{CCE81595-645E-4147-9221-995C35155A90}"/>
+                <a16:creationId xmlns:a16="http://schemas.microsoft.com/office/drawing/2014/main" id="{C8F7BCED-8167-444F-89CA-1091CE5D3E55}"/>
               </a:ext>
             </a:extLst>
           </p:cNvPr>
@@ -4401,7 +4408,7 @@
           <p:cNvPr id="8" name="">
             <a:extLst xmlns:a="http://schemas.openxmlformats.org/drawingml/2006/main">
               <a:ext uri="{FF2B5EF4-FFF2-40B4-BE49-F238E27FC236}">
-                <a16:creationId xmlns:a16="http://schemas.microsoft.com/office/drawing/2014/main" id="{33E39A73-D694-4B87-9779-442C6755D4B5}"/>
+                <a16:creationId xmlns:a16="http://schemas.microsoft.com/office/drawing/2014/main" id="{84B7BEC5-D01B-43E8-B892-61DF92B5E595}"/>
               </a:ext>
             </a:extLst>
           </p:cNvPr>
@@ -4465,7 +4472,7 @@
           <p:cNvPr id="9" name="">
             <a:extLst xmlns:a="http://schemas.openxmlformats.org/drawingml/2006/main">
               <a:ext uri="{FF2B5EF4-FFF2-40B4-BE49-F238E27FC236}">
-                <a16:creationId xmlns:a16="http://schemas.microsoft.com/office/drawing/2014/main" id="{414C6B83-F32F-4EB8-B546-3F6082DBB451}"/>
+                <a16:creationId xmlns:a16="http://schemas.microsoft.com/office/drawing/2014/main" id="{26F8373D-4182-4053-9B69-0172E2D453ED}"/>
               </a:ext>
             </a:extLst>
           </p:cNvPr>
@@ -4500,7 +4507,7 @@
           <p:cNvPr id="10" name="">
             <a:extLst xmlns:a="http://schemas.openxmlformats.org/drawingml/2006/main">
               <a:ext uri="{FF2B5EF4-FFF2-40B4-BE49-F238E27FC236}">
-                <a16:creationId xmlns:a16="http://schemas.microsoft.com/office/drawing/2014/main" id="{14C1C87F-2381-4B3B-8D1A-B0B992424481}"/>
+                <a16:creationId xmlns:a16="http://schemas.microsoft.com/office/drawing/2014/main" id="{27DACC52-B4F2-46C1-ABAA-08A2616551F4}"/>
               </a:ext>
             </a:extLst>
           </p:cNvPr>
@@ -4535,7 +4542,7 @@
           <p:cNvPr id="11" name="">
             <a:extLst xmlns:a="http://schemas.openxmlformats.org/drawingml/2006/main">
               <a:ext uri="{FF2B5EF4-FFF2-40B4-BE49-F238E27FC236}">
-                <a16:creationId xmlns:a16="http://schemas.microsoft.com/office/drawing/2014/main" id="{09A7A529-EE71-46C3-9857-7AA438206B46}"/>
+                <a16:creationId xmlns:a16="http://schemas.microsoft.com/office/drawing/2014/main" id="{A133DA21-97B4-4963-82A5-B18DAE426D1E}"/>
               </a:ext>
             </a:extLst>
           </p:cNvPr>
@@ -4570,7 +4577,7 @@
           <p:cNvPr id="12" name="">
             <a:extLst xmlns:a="http://schemas.openxmlformats.org/drawingml/2006/main">
               <a:ext uri="{FF2B5EF4-FFF2-40B4-BE49-F238E27FC236}">
-                <a16:creationId xmlns:a16="http://schemas.microsoft.com/office/drawing/2014/main" id="{F945A969-BCCC-4704-8C2F-BACCE608C665}"/>
+                <a16:creationId xmlns:a16="http://schemas.microsoft.com/office/drawing/2014/main" id="{32797E76-497F-4E1A-B1AE-0C0D0A17D905}"/>
               </a:ext>
             </a:extLst>
           </p:cNvPr>
@@ -4634,7 +4641,7 @@
           <p:cNvPr id="13" name="">
             <a:extLst xmlns:a="http://schemas.openxmlformats.org/drawingml/2006/main">
               <a:ext uri="{FF2B5EF4-FFF2-40B4-BE49-F238E27FC236}">
-                <a16:creationId xmlns:a16="http://schemas.microsoft.com/office/drawing/2014/main" id="{E1BF802B-A04A-4919-A193-75754A577B32}"/>
+                <a16:creationId xmlns:a16="http://schemas.microsoft.com/office/drawing/2014/main" id="{3537B950-66A3-4F0B-954B-07E0CEBD69FD}"/>
               </a:ext>
             </a:extLst>
           </p:cNvPr>
@@ -4698,7 +4705,7 @@
           <p:cNvPr id="14" name="">
             <a:extLst xmlns:a="http://schemas.openxmlformats.org/drawingml/2006/main">
               <a:ext uri="{FF2B5EF4-FFF2-40B4-BE49-F238E27FC236}">
-                <a16:creationId xmlns:a16="http://schemas.microsoft.com/office/drawing/2014/main" id="{313C3C22-B506-42B6-976E-7B6B91B7F888}"/>
+                <a16:creationId xmlns:a16="http://schemas.microsoft.com/office/drawing/2014/main" id="{3FE496ED-80A5-4A98-8CFA-1FF1E09B0EE4}"/>
               </a:ext>
             </a:extLst>
           </p:cNvPr>
@@ -4733,7 +4740,7 @@
           <p:cNvPr id="15" name="">
             <a:extLst xmlns:a="http://schemas.openxmlformats.org/drawingml/2006/main">
               <a:ext uri="{FF2B5EF4-FFF2-40B4-BE49-F238E27FC236}">
-                <a16:creationId xmlns:a16="http://schemas.microsoft.com/office/drawing/2014/main" id="{17E0A596-23B2-44CA-9BB2-38D9B6CB2082}"/>
+                <a16:creationId xmlns:a16="http://schemas.microsoft.com/office/drawing/2014/main" id="{668658E4-8A2F-448D-9791-07886BE3BAC0}"/>
               </a:ext>
             </a:extLst>
           </p:cNvPr>
@@ -4768,7 +4775,7 @@
           <p:cNvPr id="16" name="">
             <a:extLst xmlns:a="http://schemas.openxmlformats.org/drawingml/2006/main">
               <a:ext uri="{FF2B5EF4-FFF2-40B4-BE49-F238E27FC236}">
-                <a16:creationId xmlns:a16="http://schemas.microsoft.com/office/drawing/2014/main" id="{9CADDF61-E1E6-439A-9375-E215A362567E}"/>
+                <a16:creationId xmlns:a16="http://schemas.microsoft.com/office/drawing/2014/main" id="{0A96986C-9EC0-45B2-8184-7DDCB5ED8C35}"/>
               </a:ext>
             </a:extLst>
           </p:cNvPr>
@@ -4832,7 +4839,7 @@
           <p:cNvPr id="17" name="">
             <a:extLst xmlns:a="http://schemas.openxmlformats.org/drawingml/2006/main">
               <a:ext uri="{FF2B5EF4-FFF2-40B4-BE49-F238E27FC236}">
-                <a16:creationId xmlns:a16="http://schemas.microsoft.com/office/drawing/2014/main" id="{17C724FF-6D0C-462A-807E-9DF847D13E7A}"/>
+                <a16:creationId xmlns:a16="http://schemas.microsoft.com/office/drawing/2014/main" id="{ADF591D5-DD9A-4882-8725-3E0FBB0481F9}"/>
               </a:ext>
             </a:extLst>
           </p:cNvPr>
@@ -4896,7 +4903,7 @@
           <p:cNvPr id="18" name="">
             <a:extLst xmlns:a="http://schemas.openxmlformats.org/drawingml/2006/main">
               <a:ext uri="{FF2B5EF4-FFF2-40B4-BE49-F238E27FC236}">
-                <a16:creationId xmlns:a16="http://schemas.microsoft.com/office/drawing/2014/main" id="{37467BED-3092-4243-96FC-9E0093098AED}"/>
+                <a16:creationId xmlns:a16="http://schemas.microsoft.com/office/drawing/2014/main" id="{2DD41E38-9BB3-4BDC-8D63-109E2253DE65}"/>
               </a:ext>
             </a:extLst>
           </p:cNvPr>
@@ -4931,7 +4938,7 @@
           <p:cNvPr id="19" name="">
             <a:extLst xmlns:a="http://schemas.openxmlformats.org/drawingml/2006/main">
               <a:ext uri="{FF2B5EF4-FFF2-40B4-BE49-F238E27FC236}">
-                <a16:creationId xmlns:a16="http://schemas.microsoft.com/office/drawing/2014/main" id="{29EFD702-2EF1-4D7B-BCB4-3EE61B62369A}"/>
+                <a16:creationId xmlns:a16="http://schemas.microsoft.com/office/drawing/2014/main" id="{D753F445-B4D5-40A5-ACA2-4A43C47823F3}"/>
               </a:ext>
             </a:extLst>
           </p:cNvPr>
@@ -4966,7 +4973,7 @@
           <p:cNvPr id="20" name="">
             <a:extLst xmlns:a="http://schemas.openxmlformats.org/drawingml/2006/main">
               <a:ext uri="{FF2B5EF4-FFF2-40B4-BE49-F238E27FC236}">
-                <a16:creationId xmlns:a16="http://schemas.microsoft.com/office/drawing/2014/main" id="{BCF90931-EA60-4CE0-85C3-EB7D6F93B927}"/>
+                <a16:creationId xmlns:a16="http://schemas.microsoft.com/office/drawing/2014/main" id="{AC852E9C-8173-44C7-B0AA-2EC26EE87C24}"/>
               </a:ext>
             </a:extLst>
           </p:cNvPr>
@@ -5030,7 +5037,7 @@
           <p:cNvPr id="21" name="">
             <a:extLst xmlns:a="http://schemas.openxmlformats.org/drawingml/2006/main">
               <a:ext uri="{FF2B5EF4-FFF2-40B4-BE49-F238E27FC236}">
-                <a16:creationId xmlns:a16="http://schemas.microsoft.com/office/drawing/2014/main" id="{DFB7EA89-86CE-4CFD-9707-444874FF2B7C}"/>
+                <a16:creationId xmlns:a16="http://schemas.microsoft.com/office/drawing/2014/main" id="{61BD7589-10CD-4C58-85C9-0E572F1FCD8E}"/>
               </a:ext>
             </a:extLst>
           </p:cNvPr>
@@ -5094,7 +5101,7 @@
           <p:cNvPr id="22" name="">
             <a:extLst xmlns:a="http://schemas.openxmlformats.org/drawingml/2006/main">
               <a:ext uri="{FF2B5EF4-FFF2-40B4-BE49-F238E27FC236}">
-                <a16:creationId xmlns:a16="http://schemas.microsoft.com/office/drawing/2014/main" id="{22BB7F85-7883-4098-9D1A-5FD9C98B321D}"/>
+                <a16:creationId xmlns:a16="http://schemas.microsoft.com/office/drawing/2014/main" id="{ADC4A6C4-7A0E-4094-A9A9-5C09DBA831B6}"/>
               </a:ext>
             </a:extLst>
           </p:cNvPr>
@@ -5129,7 +5136,7 @@
           <p:cNvPr id="23" name="">
             <a:extLst xmlns:a="http://schemas.openxmlformats.org/drawingml/2006/main">
               <a:ext uri="{FF2B5EF4-FFF2-40B4-BE49-F238E27FC236}">
-                <a16:creationId xmlns:a16="http://schemas.microsoft.com/office/drawing/2014/main" id="{EB9D37A7-5870-48D7-8A34-D15B8A71B140}"/>
+                <a16:creationId xmlns:a16="http://schemas.microsoft.com/office/drawing/2014/main" id="{22180C34-16D5-4A82-A101-CC8EAB0399B4}"/>
               </a:ext>
             </a:extLst>
           </p:cNvPr>
@@ -5164,7 +5171,7 @@
           <p:cNvPr id="24" name="">
             <a:extLst xmlns:a="http://schemas.openxmlformats.org/drawingml/2006/main">
               <a:ext uri="{FF2B5EF4-FFF2-40B4-BE49-F238E27FC236}">
-                <a16:creationId xmlns:a16="http://schemas.microsoft.com/office/drawing/2014/main" id="{64B2B23B-EFAF-4618-AC6E-71983C0B8D4A}"/>
+                <a16:creationId xmlns:a16="http://schemas.microsoft.com/office/drawing/2014/main" id="{30BBB593-3914-4A7C-A42E-C2B2E7C19C32}"/>
               </a:ext>
             </a:extLst>
           </p:cNvPr>
@@ -5228,7 +5235,7 @@
           <p:cNvPr id="25" name="">
             <a:extLst xmlns:a="http://schemas.openxmlformats.org/drawingml/2006/main">
               <a:ext uri="{FF2B5EF4-FFF2-40B4-BE49-F238E27FC236}">
-                <a16:creationId xmlns:a16="http://schemas.microsoft.com/office/drawing/2014/main" id="{1944F8DB-374A-471E-B1AD-FE02548B6DBB}"/>
+                <a16:creationId xmlns:a16="http://schemas.microsoft.com/office/drawing/2014/main" id="{DC48B676-6F5C-45D6-8A0C-5E1AD9994897}"/>
               </a:ext>
             </a:extLst>
           </p:cNvPr>
@@ -5292,7 +5299,7 @@
           <p:cNvPr id="26" name="">
             <a:extLst xmlns:a="http://schemas.openxmlformats.org/drawingml/2006/main">
               <a:ext uri="{FF2B5EF4-FFF2-40B4-BE49-F238E27FC236}">
-                <a16:creationId xmlns:a16="http://schemas.microsoft.com/office/drawing/2014/main" id="{895ECF4D-D770-4098-A973-5C09FBD72E4B}"/>
+                <a16:creationId xmlns:a16="http://schemas.microsoft.com/office/drawing/2014/main" id="{5C5A4C2E-C9AB-4FD3-BC75-F70064847225}"/>
               </a:ext>
             </a:extLst>
           </p:cNvPr>
@@ -5325,7 +5332,7 @@
           <p:cNvPr id="27" name="">
             <a:extLst xmlns:a="http://schemas.openxmlformats.org/drawingml/2006/main">
               <a:ext uri="{FF2B5EF4-FFF2-40B4-BE49-F238E27FC236}">
-                <a16:creationId xmlns:a16="http://schemas.microsoft.com/office/drawing/2014/main" id="{9BED8960-4C36-4C9F-9A2B-6C10DB5AE3F5}"/>
+                <a16:creationId xmlns:a16="http://schemas.microsoft.com/office/drawing/2014/main" id="{9D091368-A2FA-4E08-B9BB-A0B771B3E072}"/>
               </a:ext>
             </a:extLst>
           </p:cNvPr>
@@ -5389,7 +5396,7 @@
           <p:cNvPr id="28" name="">
             <a:extLst xmlns:a="http://schemas.openxmlformats.org/drawingml/2006/main">
               <a:ext uri="{FF2B5EF4-FFF2-40B4-BE49-F238E27FC236}">
-                <a16:creationId xmlns:a16="http://schemas.microsoft.com/office/drawing/2014/main" id="{B4B0F7A1-90CB-42DE-BF16-9800BEA088DF}"/>
+                <a16:creationId xmlns:a16="http://schemas.microsoft.com/office/drawing/2014/main" id="{47576EAB-7EAB-474C-8C7B-076C907C4523}"/>
               </a:ext>
             </a:extLst>
           </p:cNvPr>
@@ -5453,7 +5460,7 @@
           <p:cNvPr id="29" name="">
             <a:extLst xmlns:a="http://schemas.openxmlformats.org/drawingml/2006/main">
               <a:ext uri="{FF2B5EF4-FFF2-40B4-BE49-F238E27FC236}">
-                <a16:creationId xmlns:a16="http://schemas.microsoft.com/office/drawing/2014/main" id="{EB33B281-1408-4F77-B033-4006BA54A796}"/>
+                <a16:creationId xmlns:a16="http://schemas.microsoft.com/office/drawing/2014/main" id="{44DB5906-785D-49AB-B6C3-D6FFCDDBB01B}"/>
               </a:ext>
             </a:extLst>
           </p:cNvPr>
@@ -5488,7 +5495,7 @@
           <p:cNvPr id="30" name="">
             <a:extLst xmlns:a="http://schemas.openxmlformats.org/drawingml/2006/main">
               <a:ext uri="{FF2B5EF4-FFF2-40B4-BE49-F238E27FC236}">
-                <a16:creationId xmlns:a16="http://schemas.microsoft.com/office/drawing/2014/main" id="{05C396B9-52BF-437C-952D-F167FBAF094B}"/>
+                <a16:creationId xmlns:a16="http://schemas.microsoft.com/office/drawing/2014/main" id="{C86BF734-2DD5-4688-A3E0-98D0C370C31B}"/>
               </a:ext>
             </a:extLst>
           </p:cNvPr>
@@ -5552,7 +5559,7 @@
           <p:cNvPr id="31" name="">
             <a:extLst xmlns:a="http://schemas.openxmlformats.org/drawingml/2006/main">
               <a:ext uri="{FF2B5EF4-FFF2-40B4-BE49-F238E27FC236}">
-                <a16:creationId xmlns:a16="http://schemas.microsoft.com/office/drawing/2014/main" id="{366F0796-D16C-41F9-B30A-F493DCB3C432}"/>
+                <a16:creationId xmlns:a16="http://schemas.microsoft.com/office/drawing/2014/main" id="{7E89DECE-286A-4737-AED3-8F381B18024B}"/>
               </a:ext>
             </a:extLst>
           </p:cNvPr>
@@ -5587,7 +5594,7 @@
           <p:cNvPr id="32" name="">
             <a:extLst xmlns:a="http://schemas.openxmlformats.org/drawingml/2006/main">
               <a:ext uri="{FF2B5EF4-FFF2-40B4-BE49-F238E27FC236}">
-                <a16:creationId xmlns:a16="http://schemas.microsoft.com/office/drawing/2014/main" id="{742C9F0F-AA15-41F8-B20B-8C3BF232CF4B}"/>
+                <a16:creationId xmlns:a16="http://schemas.microsoft.com/office/drawing/2014/main" id="{D3F454F9-137D-45FB-96D4-96ABDC730A07}"/>
               </a:ext>
             </a:extLst>
           </p:cNvPr>
@@ -5651,7 +5658,7 @@
           <p:cNvPr id="33" name="">
             <a:extLst xmlns:a="http://schemas.openxmlformats.org/drawingml/2006/main">
               <a:ext uri="{FF2B5EF4-FFF2-40B4-BE49-F238E27FC236}">
-                <a16:creationId xmlns:a16="http://schemas.microsoft.com/office/drawing/2014/main" id="{87E0EDEB-F601-4629-BC81-6047B0C66910}"/>
+                <a16:creationId xmlns:a16="http://schemas.microsoft.com/office/drawing/2014/main" id="{1DA126E8-A044-46FD-983A-E57CFC9D610C}"/>
               </a:ext>
             </a:extLst>
           </p:cNvPr>
@@ -5686,7 +5693,7 @@
           <p:cNvPr id="34" name="">
             <a:extLst xmlns:a="http://schemas.openxmlformats.org/drawingml/2006/main">
               <a:ext uri="{FF2B5EF4-FFF2-40B4-BE49-F238E27FC236}">
-                <a16:creationId xmlns:a16="http://schemas.microsoft.com/office/drawing/2014/main" id="{B44AB6D2-E4AC-44E6-97B8-98C55C23796D}"/>
+                <a16:creationId xmlns:a16="http://schemas.microsoft.com/office/drawing/2014/main" id="{D29C9D93-7B55-449D-AC37-C439A3D439B3}"/>
               </a:ext>
             </a:extLst>
           </p:cNvPr>
@@ -5750,7 +5757,7 @@
           <p:cNvPr id="35" name="">
             <a:extLst xmlns:a="http://schemas.openxmlformats.org/drawingml/2006/main">
               <a:ext uri="{FF2B5EF4-FFF2-40B4-BE49-F238E27FC236}">
-                <a16:creationId xmlns:a16="http://schemas.microsoft.com/office/drawing/2014/main" id="{733A1684-3718-426D-A3F3-D8CB75115860}"/>
+                <a16:creationId xmlns:a16="http://schemas.microsoft.com/office/drawing/2014/main" id="{80C988FD-2BC1-49B6-8504-35FD155287C8}"/>
               </a:ext>
             </a:extLst>
           </p:cNvPr>
@@ -5814,7 +5821,7 @@
           <p:cNvPr id="36" name="">
             <a:extLst xmlns:a="http://schemas.openxmlformats.org/drawingml/2006/main">
               <a:ext uri="{FF2B5EF4-FFF2-40B4-BE49-F238E27FC236}">
-                <a16:creationId xmlns:a16="http://schemas.microsoft.com/office/drawing/2014/main" id="{753BFB7D-5F62-407C-95CD-3EC47978EB21}"/>
+                <a16:creationId xmlns:a16="http://schemas.microsoft.com/office/drawing/2014/main" id="{018099D8-28FB-4902-8221-950B79431F5F}"/>
               </a:ext>
             </a:extLst>
           </p:cNvPr>
@@ -5876,7 +5883,7 @@
     </p:spTree>
     <p:extLst>
       <p:ext uri="{BB962C8B-B14F-4D97-AF65-F5344CB8AC3E}">
-        <p14:creationId xmlns:p14="http://schemas.microsoft.com/office/powerpoint/2010/main" val="1278260011"/>
+        <p14:creationId xmlns:p14="http://schemas.microsoft.com/office/powerpoint/2010/main" val="218335775"/>
       </p:ext>
     </p:extLst>
   </p:cSld>
@@ -5900,7 +5907,7 @@
           <p:cNvPr id="1" name="">
             <a:extLst xmlns:a="http://schemas.openxmlformats.org/drawingml/2006/main">
               <a:ext uri="{FF2B5EF4-FFF2-40B4-BE49-F238E27FC236}">
-                <a16:creationId xmlns:a16="http://schemas.microsoft.com/office/drawing/2014/main" id="{2953C917-74B0-43E4-B455-F03667BAE005}"/>
+                <a16:creationId xmlns:a16="http://schemas.microsoft.com/office/drawing/2014/main" id="{380DFF99-A3CB-435A-AE4B-B6A840151A94}"/>
               </a:ext>
             </a:extLst>
           </p:cNvPr>
@@ -5935,7 +5942,7 @@
           <p:cNvPr id="2" name="">
             <a:extLst xmlns:a="http://schemas.openxmlformats.org/drawingml/2006/main">
               <a:ext uri="{FF2B5EF4-FFF2-40B4-BE49-F238E27FC236}">
-                <a16:creationId xmlns:a16="http://schemas.microsoft.com/office/drawing/2014/main" id="{A52372CD-26D0-45FE-BAB7-75F205515387}"/>
+                <a16:creationId xmlns:a16="http://schemas.microsoft.com/office/drawing/2014/main" id="{BC8947A3-0974-40FC-ADBD-08976CE56C0F}"/>
               </a:ext>
             </a:extLst>
           </p:cNvPr>
@@ -5970,7 +5977,7 @@
           <p:cNvPr id="3" name="">
             <a:extLst xmlns:a="http://schemas.openxmlformats.org/drawingml/2006/main">
               <a:ext uri="{FF2B5EF4-FFF2-40B4-BE49-F238E27FC236}">
-                <a16:creationId xmlns:a16="http://schemas.microsoft.com/office/drawing/2014/main" id="{D00553FE-BBA0-4C5A-A832-E06D773193EF}"/>
+                <a16:creationId xmlns:a16="http://schemas.microsoft.com/office/drawing/2014/main" id="{477F5E96-8400-491C-82EB-5EB5002374E5}"/>
               </a:ext>
             </a:extLst>
           </p:cNvPr>
@@ -6005,7 +6012,7 @@
           <p:cNvPr id="4" name="">
             <a:extLst xmlns:a="http://schemas.openxmlformats.org/drawingml/2006/main">
               <a:ext uri="{FF2B5EF4-FFF2-40B4-BE49-F238E27FC236}">
-                <a16:creationId xmlns:a16="http://schemas.microsoft.com/office/drawing/2014/main" id="{169E0776-FE02-46D6-9658-B26AE5C82948}"/>
+                <a16:creationId xmlns:a16="http://schemas.microsoft.com/office/drawing/2014/main" id="{D796EDA0-A1DC-4798-B71A-AACF6F4CB267}"/>
               </a:ext>
             </a:extLst>
           </p:cNvPr>
@@ -6040,7 +6047,7 @@
           <p:cNvPr id="5" name="">
             <a:extLst xmlns:a="http://schemas.openxmlformats.org/drawingml/2006/main">
               <a:ext uri="{FF2B5EF4-FFF2-40B4-BE49-F238E27FC236}">
-                <a16:creationId xmlns:a16="http://schemas.microsoft.com/office/drawing/2014/main" id="{BB66FCAC-1FE4-40F1-87D0-09D10B3C2873}"/>
+                <a16:creationId xmlns:a16="http://schemas.microsoft.com/office/drawing/2014/main" id="{E6C40861-228A-4639-A9DD-677BDC6472C2}"/>
               </a:ext>
             </a:extLst>
           </p:cNvPr>
@@ -6075,7 +6082,7 @@
           <p:cNvPr id="6" name="">
             <a:extLst xmlns:a="http://schemas.openxmlformats.org/drawingml/2006/main">
               <a:ext uri="{FF2B5EF4-FFF2-40B4-BE49-F238E27FC236}">
-                <a16:creationId xmlns:a16="http://schemas.microsoft.com/office/drawing/2014/main" id="{455524F7-AF65-47C6-833E-DDDB52AB4AF7}"/>
+                <a16:creationId xmlns:a16="http://schemas.microsoft.com/office/drawing/2014/main" id="{3C3DE965-C880-4465-9F45-F9A670F559DF}"/>
               </a:ext>
             </a:extLst>
           </p:cNvPr>
@@ -6139,7 +6146,7 @@
           <p:cNvPr id="7" name="">
             <a:extLst xmlns:a="http://schemas.openxmlformats.org/drawingml/2006/main">
               <a:ext uri="{FF2B5EF4-FFF2-40B4-BE49-F238E27FC236}">
-                <a16:creationId xmlns:a16="http://schemas.microsoft.com/office/drawing/2014/main" id="{D938FD92-EC9C-4620-9878-D63EA0F5BFDA}"/>
+                <a16:creationId xmlns:a16="http://schemas.microsoft.com/office/drawing/2014/main" id="{78621480-CD14-4EC0-89B1-2E4181AF064F}"/>
               </a:ext>
             </a:extLst>
           </p:cNvPr>
@@ -6203,7 +6210,7 @@
           <p:cNvPr id="8" name="">
             <a:extLst xmlns:a="http://schemas.openxmlformats.org/drawingml/2006/main">
               <a:ext uri="{FF2B5EF4-FFF2-40B4-BE49-F238E27FC236}">
-                <a16:creationId xmlns:a16="http://schemas.microsoft.com/office/drawing/2014/main" id="{F5F6E431-223A-45E8-9710-6E365C36D206}"/>
+                <a16:creationId xmlns:a16="http://schemas.microsoft.com/office/drawing/2014/main" id="{10E5FCCB-2781-4102-B87F-46124137754B}"/>
               </a:ext>
             </a:extLst>
           </p:cNvPr>
@@ -6267,7 +6274,7 @@
           <p:cNvPr id="9" name="">
             <a:extLst xmlns:a="http://schemas.openxmlformats.org/drawingml/2006/main">
               <a:ext uri="{FF2B5EF4-FFF2-40B4-BE49-F238E27FC236}">
-                <a16:creationId xmlns:a16="http://schemas.microsoft.com/office/drawing/2014/main" id="{7AA991AF-9D58-4B0D-9F25-AB9A2932667E}"/>
+                <a16:creationId xmlns:a16="http://schemas.microsoft.com/office/drawing/2014/main" id="{3FDDC0FF-47F9-49EF-A5D2-4F3FBE0E4C87}"/>
               </a:ext>
             </a:extLst>
           </p:cNvPr>
@@ -6300,7 +6307,7 @@
           <p:cNvPr id="10" name="">
             <a:extLst xmlns:a="http://schemas.openxmlformats.org/drawingml/2006/main">
               <a:ext uri="{FF2B5EF4-FFF2-40B4-BE49-F238E27FC236}">
-                <a16:creationId xmlns:a16="http://schemas.microsoft.com/office/drawing/2014/main" id="{C664E939-DA1A-436F-9045-D604422FD913}"/>
+                <a16:creationId xmlns:a16="http://schemas.microsoft.com/office/drawing/2014/main" id="{D5B42D23-1D1B-4009-8A30-712D755AC5E1}"/>
               </a:ext>
             </a:extLst>
           </p:cNvPr>
@@ -6364,7 +6371,7 @@
           <p:cNvPr id="11" name="">
             <a:extLst xmlns:a="http://schemas.openxmlformats.org/drawingml/2006/main">
               <a:ext uri="{FF2B5EF4-FFF2-40B4-BE49-F238E27FC236}">
-                <a16:creationId xmlns:a16="http://schemas.microsoft.com/office/drawing/2014/main" id="{03D2651A-968E-4402-A009-AD14517BB273}"/>
+                <a16:creationId xmlns:a16="http://schemas.microsoft.com/office/drawing/2014/main" id="{37EC8428-0C5F-4B9A-84AF-46E6ABC7A768}"/>
               </a:ext>
             </a:extLst>
           </p:cNvPr>
@@ -6451,7 +6458,7 @@
           <p:cNvPr id="12" name="">
             <a:extLst xmlns:a="http://schemas.openxmlformats.org/drawingml/2006/main">
               <a:ext uri="{FF2B5EF4-FFF2-40B4-BE49-F238E27FC236}">
-                <a16:creationId xmlns:a16="http://schemas.microsoft.com/office/drawing/2014/main" id="{4E7EE180-71DA-4A8A-9A57-3A410906C8DD}"/>
+                <a16:creationId xmlns:a16="http://schemas.microsoft.com/office/drawing/2014/main" id="{17E82C53-C329-4498-A4DD-9852E904895C}"/>
               </a:ext>
             </a:extLst>
           </p:cNvPr>
@@ -6484,7 +6491,7 @@
           <p:cNvPr id="13" name="">
             <a:extLst xmlns:a="http://schemas.openxmlformats.org/drawingml/2006/main">
               <a:ext uri="{FF2B5EF4-FFF2-40B4-BE49-F238E27FC236}">
-                <a16:creationId xmlns:a16="http://schemas.microsoft.com/office/drawing/2014/main" id="{0B824C06-7342-4664-80DD-CE5F384DCCD7}"/>
+                <a16:creationId xmlns:a16="http://schemas.microsoft.com/office/drawing/2014/main" id="{4110631E-7238-4D5E-95C1-22B113E559CE}"/>
               </a:ext>
             </a:extLst>
           </p:cNvPr>
@@ -6548,7 +6555,7 @@
           <p:cNvPr id="14" name="">
             <a:extLst xmlns:a="http://schemas.openxmlformats.org/drawingml/2006/main">
               <a:ext uri="{FF2B5EF4-FFF2-40B4-BE49-F238E27FC236}">
-                <a16:creationId xmlns:a16="http://schemas.microsoft.com/office/drawing/2014/main" id="{9456DC4F-089C-4C7D-B468-40E2EA547050}"/>
+                <a16:creationId xmlns:a16="http://schemas.microsoft.com/office/drawing/2014/main" id="{54C93784-B5C3-48FF-9203-DDB07C1B6F1B}"/>
               </a:ext>
             </a:extLst>
           </p:cNvPr>
@@ -6681,7 +6688,7 @@
           <p:cNvPr id="15" name="">
             <a:extLst xmlns:a="http://schemas.openxmlformats.org/drawingml/2006/main">
               <a:ext uri="{FF2B5EF4-FFF2-40B4-BE49-F238E27FC236}">
-                <a16:creationId xmlns:a16="http://schemas.microsoft.com/office/drawing/2014/main" id="{BE063509-D5D1-4CF4-B54C-3E54B0F97C3F}"/>
+                <a16:creationId xmlns:a16="http://schemas.microsoft.com/office/drawing/2014/main" id="{8FE2F00D-E49E-4FF7-B83B-3C615E2CB335}"/>
               </a:ext>
             </a:extLst>
           </p:cNvPr>
@@ -6718,7 +6725,7 @@
           <p:cNvPr id="16" name="">
             <a:extLst xmlns:a="http://schemas.openxmlformats.org/drawingml/2006/main">
               <a:ext uri="{FF2B5EF4-FFF2-40B4-BE49-F238E27FC236}">
-                <a16:creationId xmlns:a16="http://schemas.microsoft.com/office/drawing/2014/main" id="{F25D6E1E-A6AB-4D1B-93F1-811E64C84E5F}"/>
+                <a16:creationId xmlns:a16="http://schemas.microsoft.com/office/drawing/2014/main" id="{B66D7ABB-FECC-4DF5-845D-5377B373DE34}"/>
               </a:ext>
             </a:extLst>
           </p:cNvPr>
@@ -6753,7 +6760,7 @@
           <p:cNvPr id="17" name="">
             <a:extLst xmlns:a="http://schemas.openxmlformats.org/drawingml/2006/main">
               <a:ext uri="{FF2B5EF4-FFF2-40B4-BE49-F238E27FC236}">
-                <a16:creationId xmlns:a16="http://schemas.microsoft.com/office/drawing/2014/main" id="{5DDB9309-0E7C-46A3-BDE9-EC2695517704}"/>
+                <a16:creationId xmlns:a16="http://schemas.microsoft.com/office/drawing/2014/main" id="{B30FE518-597B-4086-8803-F2D3360503C5}"/>
               </a:ext>
             </a:extLst>
           </p:cNvPr>
@@ -6790,7 +6797,7 @@
           <p:cNvPr id="18" name="">
             <a:extLst xmlns:a="http://schemas.openxmlformats.org/drawingml/2006/main">
               <a:ext uri="{FF2B5EF4-FFF2-40B4-BE49-F238E27FC236}">
-                <a16:creationId xmlns:a16="http://schemas.microsoft.com/office/drawing/2014/main" id="{8E6331A6-CBF8-4B05-9435-E2F004208BF7}"/>
+                <a16:creationId xmlns:a16="http://schemas.microsoft.com/office/drawing/2014/main" id="{019E9CB7-176D-4D32-8017-76392B75765B}"/>
               </a:ext>
             </a:extLst>
           </p:cNvPr>
@@ -6825,7 +6832,7 @@
           <p:cNvPr id="19" name="">
             <a:extLst xmlns:a="http://schemas.openxmlformats.org/drawingml/2006/main">
               <a:ext uri="{FF2B5EF4-FFF2-40B4-BE49-F238E27FC236}">
-                <a16:creationId xmlns:a16="http://schemas.microsoft.com/office/drawing/2014/main" id="{8ACFF661-E373-4D1D-A4FF-81C638EC9F38}"/>
+                <a16:creationId xmlns:a16="http://schemas.microsoft.com/office/drawing/2014/main" id="{7FD8EF1D-2284-479F-991A-DCBDDA4794EE}"/>
               </a:ext>
             </a:extLst>
           </p:cNvPr>
@@ -6889,7 +6896,7 @@
           <p:cNvPr id="20" name="">
             <a:extLst xmlns:a="http://schemas.openxmlformats.org/drawingml/2006/main">
               <a:ext uri="{FF2B5EF4-FFF2-40B4-BE49-F238E27FC236}">
-                <a16:creationId xmlns:a16="http://schemas.microsoft.com/office/drawing/2014/main" id="{84A57C1D-9857-48E1-A3B8-AE2EF8D40337}"/>
+                <a16:creationId xmlns:a16="http://schemas.microsoft.com/office/drawing/2014/main" id="{43F74B76-4F1A-46C5-9110-7FF0F9A2F358}"/>
               </a:ext>
             </a:extLst>
           </p:cNvPr>
@@ -6924,7 +6931,7 @@
           <p:cNvPr id="21" name="">
             <a:extLst xmlns:a="http://schemas.openxmlformats.org/drawingml/2006/main">
               <a:ext uri="{FF2B5EF4-FFF2-40B4-BE49-F238E27FC236}">
-                <a16:creationId xmlns:a16="http://schemas.microsoft.com/office/drawing/2014/main" id="{2F804F04-8929-4866-B472-85D2CD0A919D}"/>
+                <a16:creationId xmlns:a16="http://schemas.microsoft.com/office/drawing/2014/main" id="{523F0CBE-5C83-4AE1-9D95-20EA28C94DE2}"/>
               </a:ext>
             </a:extLst>
           </p:cNvPr>
@@ -6988,7 +6995,7 @@
           <p:cNvPr id="22" name="">
             <a:extLst xmlns:a="http://schemas.openxmlformats.org/drawingml/2006/main">
               <a:ext uri="{FF2B5EF4-FFF2-40B4-BE49-F238E27FC236}">
-                <a16:creationId xmlns:a16="http://schemas.microsoft.com/office/drawing/2014/main" id="{CDF903AD-1D48-45A8-875B-7B3DF15C6309}"/>
+                <a16:creationId xmlns:a16="http://schemas.microsoft.com/office/drawing/2014/main" id="{DF5E2AD8-C5EB-4864-99A9-4F8C82DA81FC}"/>
               </a:ext>
             </a:extLst>
           </p:cNvPr>
@@ -7052,7 +7059,7 @@
           <p:cNvPr id="23" name="">
             <a:extLst xmlns:a="http://schemas.openxmlformats.org/drawingml/2006/main">
               <a:ext uri="{FF2B5EF4-FFF2-40B4-BE49-F238E27FC236}">
-                <a16:creationId xmlns:a16="http://schemas.microsoft.com/office/drawing/2014/main" id="{CB2D1FF2-F99E-4B77-91D7-5F7A43F9C13B}"/>
+                <a16:creationId xmlns:a16="http://schemas.microsoft.com/office/drawing/2014/main" id="{65945F79-DB82-4C5B-84DC-D4EED258CC38}"/>
               </a:ext>
             </a:extLst>
           </p:cNvPr>
@@ -7114,7 +7121,7 @@
     </p:spTree>
     <p:extLst>
       <p:ext uri="{BB962C8B-B14F-4D97-AF65-F5344CB8AC3E}">
-        <p14:creationId xmlns:p14="http://schemas.microsoft.com/office/powerpoint/2010/main" val="1727240855"/>
+        <p14:creationId xmlns:p14="http://schemas.microsoft.com/office/powerpoint/2010/main" val="745027399"/>
       </p:ext>
     </p:extLst>
   </p:cSld>
@@ -7138,7 +7145,7 @@
           <p:cNvPr id="1" name="">
             <a:extLst xmlns:a="http://schemas.openxmlformats.org/drawingml/2006/main">
               <a:ext uri="{FF2B5EF4-FFF2-40B4-BE49-F238E27FC236}">
-                <a16:creationId xmlns:a16="http://schemas.microsoft.com/office/drawing/2014/main" id="{142C91DE-BE7E-4545-877A-D86F2BDFFE21}"/>
+                <a16:creationId xmlns:a16="http://schemas.microsoft.com/office/drawing/2014/main" id="{07D25915-6981-4D24-BDB7-782CD158B8AF}"/>
               </a:ext>
             </a:extLst>
           </p:cNvPr>
@@ -7173,7 +7180,7 @@
           <p:cNvPr id="2" name="">
             <a:extLst xmlns:a="http://schemas.openxmlformats.org/drawingml/2006/main">
               <a:ext uri="{FF2B5EF4-FFF2-40B4-BE49-F238E27FC236}">
-                <a16:creationId xmlns:a16="http://schemas.microsoft.com/office/drawing/2014/main" id="{43A68DFF-974B-4354-A7D7-8501055F1E66}"/>
+                <a16:creationId xmlns:a16="http://schemas.microsoft.com/office/drawing/2014/main" id="{04A5D17B-A1A4-443B-97F7-C93E54270CE3}"/>
               </a:ext>
             </a:extLst>
           </p:cNvPr>
@@ -7208,7 +7215,7 @@
           <p:cNvPr id="3" name="">
             <a:extLst xmlns:a="http://schemas.openxmlformats.org/drawingml/2006/main">
               <a:ext uri="{FF2B5EF4-FFF2-40B4-BE49-F238E27FC236}">
-                <a16:creationId xmlns:a16="http://schemas.microsoft.com/office/drawing/2014/main" id="{D25F2BF0-794E-487E-B7A7-588DF0791934}"/>
+                <a16:creationId xmlns:a16="http://schemas.microsoft.com/office/drawing/2014/main" id="{98E81C4E-30BC-4667-BFD7-EB13E7078097}"/>
               </a:ext>
             </a:extLst>
           </p:cNvPr>
@@ -7243,7 +7250,7 @@
           <p:cNvPr id="4" name="">
             <a:extLst xmlns:a="http://schemas.openxmlformats.org/drawingml/2006/main">
               <a:ext uri="{FF2B5EF4-FFF2-40B4-BE49-F238E27FC236}">
-                <a16:creationId xmlns:a16="http://schemas.microsoft.com/office/drawing/2014/main" id="{4D9C9DF0-81B9-4B34-A689-93A266AE5811}"/>
+                <a16:creationId xmlns:a16="http://schemas.microsoft.com/office/drawing/2014/main" id="{7BCA9B09-64D7-4E55-8F51-D8F44DBE79A4}"/>
               </a:ext>
             </a:extLst>
           </p:cNvPr>
@@ -7278,7 +7285,7 @@
           <p:cNvPr id="5" name="">
             <a:extLst xmlns:a="http://schemas.openxmlformats.org/drawingml/2006/main">
               <a:ext uri="{FF2B5EF4-FFF2-40B4-BE49-F238E27FC236}">
-                <a16:creationId xmlns:a16="http://schemas.microsoft.com/office/drawing/2014/main" id="{C7C11B3C-DD49-428B-91AC-18FD137352E1}"/>
+                <a16:creationId xmlns:a16="http://schemas.microsoft.com/office/drawing/2014/main" id="{88FE7F22-AEA1-4AC8-86C5-FBFBF50F5668}"/>
               </a:ext>
             </a:extLst>
           </p:cNvPr>
@@ -7313,7 +7320,7 @@
           <p:cNvPr id="6" name="">
             <a:extLst xmlns:a="http://schemas.openxmlformats.org/drawingml/2006/main">
               <a:ext uri="{FF2B5EF4-FFF2-40B4-BE49-F238E27FC236}">
-                <a16:creationId xmlns:a16="http://schemas.microsoft.com/office/drawing/2014/main" id="{3F2619E4-6804-4BB9-ABA2-7F760CC92B40}"/>
+                <a16:creationId xmlns:a16="http://schemas.microsoft.com/office/drawing/2014/main" id="{5609C0E0-ABA7-44C5-AEE6-1052BE054C38}"/>
               </a:ext>
             </a:extLst>
           </p:cNvPr>
@@ -7377,7 +7384,7 @@
           <p:cNvPr id="7" name="">
             <a:extLst xmlns:a="http://schemas.openxmlformats.org/drawingml/2006/main">
               <a:ext uri="{FF2B5EF4-FFF2-40B4-BE49-F238E27FC236}">
-                <a16:creationId xmlns:a16="http://schemas.microsoft.com/office/drawing/2014/main" id="{97E2EEB8-F518-4830-84D6-D81503F37AC8}"/>
+                <a16:creationId xmlns:a16="http://schemas.microsoft.com/office/drawing/2014/main" id="{853A6031-0635-48E3-BA5C-3BA0CE435FFD}"/>
               </a:ext>
             </a:extLst>
           </p:cNvPr>
@@ -7441,7 +7448,7 @@
           <p:cNvPr id="8" name="">
             <a:extLst xmlns:a="http://schemas.openxmlformats.org/drawingml/2006/main">
               <a:ext uri="{FF2B5EF4-FFF2-40B4-BE49-F238E27FC236}">
-                <a16:creationId xmlns:a16="http://schemas.microsoft.com/office/drawing/2014/main" id="{47CD4C10-583B-4B5B-8DA4-09CD91A4B48E}"/>
+                <a16:creationId xmlns:a16="http://schemas.microsoft.com/office/drawing/2014/main" id="{39C0B6BB-A736-498C-8A9F-C837541C21DE}"/>
               </a:ext>
             </a:extLst>
           </p:cNvPr>
@@ -7505,7 +7512,7 @@
           <p:cNvPr id="9" name="">
             <a:extLst xmlns:a="http://schemas.openxmlformats.org/drawingml/2006/main">
               <a:ext uri="{FF2B5EF4-FFF2-40B4-BE49-F238E27FC236}">
-                <a16:creationId xmlns:a16="http://schemas.microsoft.com/office/drawing/2014/main" id="{20E7A5A8-78F2-48A4-841A-221FC2C12167}"/>
+                <a16:creationId xmlns:a16="http://schemas.microsoft.com/office/drawing/2014/main" id="{A727458F-861D-4153-9A54-2C05B18073F3}"/>
               </a:ext>
             </a:extLst>
           </p:cNvPr>
@@ -7538,7 +7545,7 @@
           <p:cNvPr id="10" name="">
             <a:extLst xmlns:a="http://schemas.openxmlformats.org/drawingml/2006/main">
               <a:ext uri="{FF2B5EF4-FFF2-40B4-BE49-F238E27FC236}">
-                <a16:creationId xmlns:a16="http://schemas.microsoft.com/office/drawing/2014/main" id="{030517B3-5D50-4A1D-95F9-217673B15BB0}"/>
+                <a16:creationId xmlns:a16="http://schemas.microsoft.com/office/drawing/2014/main" id="{00692172-FB95-430D-A106-3AB48E88B64F}"/>
               </a:ext>
             </a:extLst>
           </p:cNvPr>
@@ -7602,7 +7609,7 @@
           <p:cNvPr id="11" name="">
             <a:extLst xmlns:a="http://schemas.openxmlformats.org/drawingml/2006/main">
               <a:ext uri="{FF2B5EF4-FFF2-40B4-BE49-F238E27FC236}">
-                <a16:creationId xmlns:a16="http://schemas.microsoft.com/office/drawing/2014/main" id="{9AE5574C-85D3-4DD3-9BB2-4A8452D3F557}"/>
+                <a16:creationId xmlns:a16="http://schemas.microsoft.com/office/drawing/2014/main" id="{CB6A0DA4-20F2-4242-AB73-630475F66774}"/>
               </a:ext>
             </a:extLst>
           </p:cNvPr>
@@ -7666,7 +7673,7 @@
           <p:cNvPr id="12" name="">
             <a:extLst xmlns:a="http://schemas.openxmlformats.org/drawingml/2006/main">
               <a:ext uri="{FF2B5EF4-FFF2-40B4-BE49-F238E27FC236}">
-                <a16:creationId xmlns:a16="http://schemas.microsoft.com/office/drawing/2014/main" id="{7A22307B-EEEA-4E48-852E-AD9CB3AE8246}"/>
+                <a16:creationId xmlns:a16="http://schemas.microsoft.com/office/drawing/2014/main" id="{608F6831-CFD5-47DD-9C95-033844F66CC4}"/>
               </a:ext>
             </a:extLst>
           </p:cNvPr>
@@ -7699,7 +7706,7 @@
           <p:cNvPr id="13" name="">
             <a:extLst xmlns:a="http://schemas.openxmlformats.org/drawingml/2006/main">
               <a:ext uri="{FF2B5EF4-FFF2-40B4-BE49-F238E27FC236}">
-                <a16:creationId xmlns:a16="http://schemas.microsoft.com/office/drawing/2014/main" id="{370510B6-6DE1-4C25-9209-D3C9868C8D35}"/>
+                <a16:creationId xmlns:a16="http://schemas.microsoft.com/office/drawing/2014/main" id="{304D4076-C0D8-4D9D-94C1-7E50A6612B78}"/>
               </a:ext>
             </a:extLst>
           </p:cNvPr>
@@ -7763,7 +7770,7 @@
           <p:cNvPr id="14" name="">
             <a:extLst xmlns:a="http://schemas.openxmlformats.org/drawingml/2006/main">
               <a:ext uri="{FF2B5EF4-FFF2-40B4-BE49-F238E27FC236}">
-                <a16:creationId xmlns:a16="http://schemas.microsoft.com/office/drawing/2014/main" id="{0E0A9FC4-74DB-49BE-8591-128281656268}"/>
+                <a16:creationId xmlns:a16="http://schemas.microsoft.com/office/drawing/2014/main" id="{436D7D10-A1C9-43EE-B729-EBCD57F396CF}"/>
               </a:ext>
             </a:extLst>
           </p:cNvPr>
@@ -7827,7 +7834,7 @@
           <p:cNvPr id="15" name="">
             <a:extLst xmlns:a="http://schemas.openxmlformats.org/drawingml/2006/main">
               <a:ext uri="{FF2B5EF4-FFF2-40B4-BE49-F238E27FC236}">
-                <a16:creationId xmlns:a16="http://schemas.microsoft.com/office/drawing/2014/main" id="{9758393B-AE9E-4B6E-ACB4-A424AA0E6683}"/>
+                <a16:creationId xmlns:a16="http://schemas.microsoft.com/office/drawing/2014/main" id="{72B27236-1C0D-4F29-BCC9-ED1C95673807}"/>
               </a:ext>
             </a:extLst>
           </p:cNvPr>
@@ -7860,7 +7867,7 @@
           <p:cNvPr id="16" name="">
             <a:extLst xmlns:a="http://schemas.openxmlformats.org/drawingml/2006/main">
               <a:ext uri="{FF2B5EF4-FFF2-40B4-BE49-F238E27FC236}">
-                <a16:creationId xmlns:a16="http://schemas.microsoft.com/office/drawing/2014/main" id="{43FBEA19-DED1-4F87-B2A1-BF3334557152}"/>
+                <a16:creationId xmlns:a16="http://schemas.microsoft.com/office/drawing/2014/main" id="{BF7F5488-F5D3-430B-937F-4F13D760DEDD}"/>
               </a:ext>
             </a:extLst>
           </p:cNvPr>
@@ -7924,7 +7931,7 @@
           <p:cNvPr id="17" name="">
             <a:extLst xmlns:a="http://schemas.openxmlformats.org/drawingml/2006/main">
               <a:ext uri="{FF2B5EF4-FFF2-40B4-BE49-F238E27FC236}">
-                <a16:creationId xmlns:a16="http://schemas.microsoft.com/office/drawing/2014/main" id="{48CD715D-62A7-473E-9C2F-CB86675573C0}"/>
+                <a16:creationId xmlns:a16="http://schemas.microsoft.com/office/drawing/2014/main" id="{31F515CE-F1A5-479E-9038-645AA6D87610}"/>
               </a:ext>
             </a:extLst>
           </p:cNvPr>
@@ -7988,7 +7995,7 @@
           <p:cNvPr id="18" name="">
             <a:extLst xmlns:a="http://schemas.openxmlformats.org/drawingml/2006/main">
               <a:ext uri="{FF2B5EF4-FFF2-40B4-BE49-F238E27FC236}">
-                <a16:creationId xmlns:a16="http://schemas.microsoft.com/office/drawing/2014/main" id="{66E8F44B-5527-4C64-9472-02C9040D9E51}"/>
+                <a16:creationId xmlns:a16="http://schemas.microsoft.com/office/drawing/2014/main" id="{BD44E243-BFAB-4B26-82A7-6553DFFD4113}"/>
               </a:ext>
             </a:extLst>
           </p:cNvPr>
@@ -8021,7 +8028,7 @@
           <p:cNvPr id="19" name="">
             <a:extLst xmlns:a="http://schemas.openxmlformats.org/drawingml/2006/main">
               <a:ext uri="{FF2B5EF4-FFF2-40B4-BE49-F238E27FC236}">
-                <a16:creationId xmlns:a16="http://schemas.microsoft.com/office/drawing/2014/main" id="{4072F8F2-03A1-4D23-90B3-9AEC52E14AF8}"/>
+                <a16:creationId xmlns:a16="http://schemas.microsoft.com/office/drawing/2014/main" id="{E7A12303-714D-429B-A9F5-E56DBD828A6C}"/>
               </a:ext>
             </a:extLst>
           </p:cNvPr>
@@ -8085,7 +8092,7 @@
           <p:cNvPr id="20" name="">
             <a:extLst xmlns:a="http://schemas.openxmlformats.org/drawingml/2006/main">
               <a:ext uri="{FF2B5EF4-FFF2-40B4-BE49-F238E27FC236}">
-                <a16:creationId xmlns:a16="http://schemas.microsoft.com/office/drawing/2014/main" id="{30B2A597-4911-48F7-A607-B6F4455C9783}"/>
+                <a16:creationId xmlns:a16="http://schemas.microsoft.com/office/drawing/2014/main" id="{53094404-9EDF-4D64-8AE9-C9AA86A293C8}"/>
               </a:ext>
             </a:extLst>
           </p:cNvPr>
@@ -8149,7 +8156,7 @@
           <p:cNvPr id="21" name="">
             <a:extLst xmlns:a="http://schemas.openxmlformats.org/drawingml/2006/main">
               <a:ext uri="{FF2B5EF4-FFF2-40B4-BE49-F238E27FC236}">
-                <a16:creationId xmlns:a16="http://schemas.microsoft.com/office/drawing/2014/main" id="{104BDFFA-D68F-4D40-AEAF-ECFC1B6BF723}"/>
+                <a16:creationId xmlns:a16="http://schemas.microsoft.com/office/drawing/2014/main" id="{EAC6EC66-5DB6-40E4-9486-B9D41F610848}"/>
               </a:ext>
             </a:extLst>
           </p:cNvPr>
@@ -8182,7 +8189,7 @@
           <p:cNvPr id="22" name="">
             <a:extLst xmlns:a="http://schemas.openxmlformats.org/drawingml/2006/main">
               <a:ext uri="{FF2B5EF4-FFF2-40B4-BE49-F238E27FC236}">
-                <a16:creationId xmlns:a16="http://schemas.microsoft.com/office/drawing/2014/main" id="{AA526ED5-E07F-4664-B245-B37B8D278F6B}"/>
+                <a16:creationId xmlns:a16="http://schemas.microsoft.com/office/drawing/2014/main" id="{1F39752B-9FB8-41BA-A0BA-49D8AFD03E30}"/>
               </a:ext>
             </a:extLst>
           </p:cNvPr>
@@ -8246,7 +8253,7 @@
           <p:cNvPr id="23" name="">
             <a:extLst xmlns:a="http://schemas.openxmlformats.org/drawingml/2006/main">
               <a:ext uri="{FF2B5EF4-FFF2-40B4-BE49-F238E27FC236}">
-                <a16:creationId xmlns:a16="http://schemas.microsoft.com/office/drawing/2014/main" id="{26237431-18A7-4697-9C82-DACAA70125AB}"/>
+                <a16:creationId xmlns:a16="http://schemas.microsoft.com/office/drawing/2014/main" id="{55D3467F-2248-4825-8558-BD331C8F616A}"/>
               </a:ext>
             </a:extLst>
           </p:cNvPr>
@@ -8310,7 +8317,7 @@
           <p:cNvPr id="24" name="">
             <a:extLst xmlns:a="http://schemas.openxmlformats.org/drawingml/2006/main">
               <a:ext uri="{FF2B5EF4-FFF2-40B4-BE49-F238E27FC236}">
-                <a16:creationId xmlns:a16="http://schemas.microsoft.com/office/drawing/2014/main" id="{FE92572C-9D9E-4362-BADC-5E9EF1939BEB}"/>
+                <a16:creationId xmlns:a16="http://schemas.microsoft.com/office/drawing/2014/main" id="{6E7E3651-D5F4-427B-A8B3-F2B81C493941}"/>
               </a:ext>
             </a:extLst>
           </p:cNvPr>
@@ -8347,7 +8354,7 @@
           <p:cNvPr id="25" name="">
             <a:extLst xmlns:a="http://schemas.openxmlformats.org/drawingml/2006/main">
               <a:ext uri="{FF2B5EF4-FFF2-40B4-BE49-F238E27FC236}">
-                <a16:creationId xmlns:a16="http://schemas.microsoft.com/office/drawing/2014/main" id="{DCFD42C8-686C-40DD-B5D7-2BB3FECAFED9}"/>
+                <a16:creationId xmlns:a16="http://schemas.microsoft.com/office/drawing/2014/main" id="{D406A756-ACB6-43D9-AA2A-230957F23FD1}"/>
               </a:ext>
             </a:extLst>
           </p:cNvPr>
@@ -8382,7 +8389,7 @@
           <p:cNvPr id="26" name="">
             <a:extLst xmlns:a="http://schemas.openxmlformats.org/drawingml/2006/main">
               <a:ext uri="{FF2B5EF4-FFF2-40B4-BE49-F238E27FC236}">
-                <a16:creationId xmlns:a16="http://schemas.microsoft.com/office/drawing/2014/main" id="{DB85BA9B-53C9-4C5E-8EDB-7CA7F925061F}"/>
+                <a16:creationId xmlns:a16="http://schemas.microsoft.com/office/drawing/2014/main" id="{E0FA1C8B-D5F5-4760-A680-D3F71C60B47B}"/>
               </a:ext>
             </a:extLst>
           </p:cNvPr>
@@ -8419,7 +8426,7 @@
           <p:cNvPr id="27" name="">
             <a:extLst xmlns:a="http://schemas.openxmlformats.org/drawingml/2006/main">
               <a:ext uri="{FF2B5EF4-FFF2-40B4-BE49-F238E27FC236}">
-                <a16:creationId xmlns:a16="http://schemas.microsoft.com/office/drawing/2014/main" id="{11653229-E7CE-4674-A1DE-49B70297917D}"/>
+                <a16:creationId xmlns:a16="http://schemas.microsoft.com/office/drawing/2014/main" id="{9F1616C5-BC84-4CD2-BC4B-059528E67405}"/>
               </a:ext>
             </a:extLst>
           </p:cNvPr>
@@ -8454,7 +8461,7 @@
           <p:cNvPr id="28" name="">
             <a:extLst xmlns:a="http://schemas.openxmlformats.org/drawingml/2006/main">
               <a:ext uri="{FF2B5EF4-FFF2-40B4-BE49-F238E27FC236}">
-                <a16:creationId xmlns:a16="http://schemas.microsoft.com/office/drawing/2014/main" id="{8EF55007-8073-4F32-8A55-AF9983C0F7AC}"/>
+                <a16:creationId xmlns:a16="http://schemas.microsoft.com/office/drawing/2014/main" id="{8EA37E7A-2E81-437A-B9BB-A193AD741AAA}"/>
               </a:ext>
             </a:extLst>
           </p:cNvPr>
@@ -8518,7 +8525,7 @@
           <p:cNvPr id="29" name="">
             <a:extLst xmlns:a="http://schemas.openxmlformats.org/drawingml/2006/main">
               <a:ext uri="{FF2B5EF4-FFF2-40B4-BE49-F238E27FC236}">
-                <a16:creationId xmlns:a16="http://schemas.microsoft.com/office/drawing/2014/main" id="{6B5DC425-4E1C-430E-895F-BCE8D7E7D2FE}"/>
+                <a16:creationId xmlns:a16="http://schemas.microsoft.com/office/drawing/2014/main" id="{33C899FA-42FE-4F89-A00B-D34A1B9AEE72}"/>
               </a:ext>
             </a:extLst>
           </p:cNvPr>
@@ -8582,7 +8589,7 @@
           <p:cNvPr id="30" name="">
             <a:extLst xmlns:a="http://schemas.openxmlformats.org/drawingml/2006/main">
               <a:ext uri="{FF2B5EF4-FFF2-40B4-BE49-F238E27FC236}">
-                <a16:creationId xmlns:a16="http://schemas.microsoft.com/office/drawing/2014/main" id="{56A4AAC3-6936-456A-9111-A79912DAF5B8}"/>
+                <a16:creationId xmlns:a16="http://schemas.microsoft.com/office/drawing/2014/main" id="{68D8ABA6-C165-49F6-B4C6-FA018D8222CC}"/>
               </a:ext>
             </a:extLst>
           </p:cNvPr>
@@ -8644,7 +8651,7 @@
     </p:spTree>
     <p:extLst>
       <p:ext uri="{BB962C8B-B14F-4D97-AF65-F5344CB8AC3E}">
-        <p14:creationId xmlns:p14="http://schemas.microsoft.com/office/powerpoint/2010/main" val="1654938256"/>
+        <p14:creationId xmlns:p14="http://schemas.microsoft.com/office/powerpoint/2010/main" val="1068455997"/>
       </p:ext>
     </p:extLst>
   </p:cSld>
@@ -8668,7 +8675,7 @@
           <p:cNvPr id="1" name="">
             <a:extLst xmlns:a="http://schemas.openxmlformats.org/drawingml/2006/main">
               <a:ext uri="{FF2B5EF4-FFF2-40B4-BE49-F238E27FC236}">
-                <a16:creationId xmlns:a16="http://schemas.microsoft.com/office/drawing/2014/main" id="{C3DBB7AA-BE77-46F7-8C7B-B1D72824F1CF}"/>
+                <a16:creationId xmlns:a16="http://schemas.microsoft.com/office/drawing/2014/main" id="{CC02F2B8-1DBF-4100-B4E3-54BE13EC000F}"/>
               </a:ext>
             </a:extLst>
           </p:cNvPr>
@@ -8703,7 +8710,7 @@
           <p:cNvPr id="2" name="">
             <a:extLst xmlns:a="http://schemas.openxmlformats.org/drawingml/2006/main">
               <a:ext uri="{FF2B5EF4-FFF2-40B4-BE49-F238E27FC236}">
-                <a16:creationId xmlns:a16="http://schemas.microsoft.com/office/drawing/2014/main" id="{493DCB7A-85AC-498D-A286-460876DE75C9}"/>
+                <a16:creationId xmlns:a16="http://schemas.microsoft.com/office/drawing/2014/main" id="{3D69C955-2A2D-4748-8012-20A033AE76E4}"/>
               </a:ext>
             </a:extLst>
           </p:cNvPr>
@@ -8738,7 +8745,7 @@
           <p:cNvPr id="3" name="">
             <a:extLst xmlns:a="http://schemas.openxmlformats.org/drawingml/2006/main">
               <a:ext uri="{FF2B5EF4-FFF2-40B4-BE49-F238E27FC236}">
-                <a16:creationId xmlns:a16="http://schemas.microsoft.com/office/drawing/2014/main" id="{125F466F-5656-441F-87AC-52F518F9EE82}"/>
+                <a16:creationId xmlns:a16="http://schemas.microsoft.com/office/drawing/2014/main" id="{9B437826-FFAE-4278-93C5-51F1D7AD4EBB}"/>
               </a:ext>
             </a:extLst>
           </p:cNvPr>
@@ -8773,7 +8780,7 @@
           <p:cNvPr id="4" name="">
             <a:extLst xmlns:a="http://schemas.openxmlformats.org/drawingml/2006/main">
               <a:ext uri="{FF2B5EF4-FFF2-40B4-BE49-F238E27FC236}">
-                <a16:creationId xmlns:a16="http://schemas.microsoft.com/office/drawing/2014/main" id="{7CE8412F-1D8C-4E3A-BE34-78592FAEB5E5}"/>
+                <a16:creationId xmlns:a16="http://schemas.microsoft.com/office/drawing/2014/main" id="{EA2A5156-889E-4984-AEC6-5964BE2FB378}"/>
               </a:ext>
             </a:extLst>
           </p:cNvPr>
@@ -8808,7 +8815,7 @@
           <p:cNvPr id="5" name="">
             <a:extLst xmlns:a="http://schemas.openxmlformats.org/drawingml/2006/main">
               <a:ext uri="{FF2B5EF4-FFF2-40B4-BE49-F238E27FC236}">
-                <a16:creationId xmlns:a16="http://schemas.microsoft.com/office/drawing/2014/main" id="{3F737568-2CEE-4248-A698-0BD265F93165}"/>
+                <a16:creationId xmlns:a16="http://schemas.microsoft.com/office/drawing/2014/main" id="{265305C8-C30B-4A6D-9348-213F039804DE}"/>
               </a:ext>
             </a:extLst>
           </p:cNvPr>
@@ -8843,7 +8850,7 @@
           <p:cNvPr id="6" name="">
             <a:extLst xmlns:a="http://schemas.openxmlformats.org/drawingml/2006/main">
               <a:ext uri="{FF2B5EF4-FFF2-40B4-BE49-F238E27FC236}">
-                <a16:creationId xmlns:a16="http://schemas.microsoft.com/office/drawing/2014/main" id="{F5E49AB8-FF6A-4B14-B75B-562C65B78830}"/>
+                <a16:creationId xmlns:a16="http://schemas.microsoft.com/office/drawing/2014/main" id="{746DEBE0-B752-4538-9C72-3EAB1F71EDBD}"/>
               </a:ext>
             </a:extLst>
           </p:cNvPr>
@@ -8897,7 +8904,7 @@
                 <a:ea typeface="Aptos Mono"/>
                 <a:cs typeface="Aptos Mono"/>
               </a:rPr>
-              <a:t>90 SECOND DEMO</a:t>
+              <a:t>2 MIN SOLO DEMO</a:t>
             </a:r>
           </a:p>
         </p:txBody>
@@ -8907,7 +8914,7 @@
           <p:cNvPr id="7" name="">
             <a:extLst xmlns:a="http://schemas.openxmlformats.org/drawingml/2006/main">
               <a:ext uri="{FF2B5EF4-FFF2-40B4-BE49-F238E27FC236}">
-                <a16:creationId xmlns:a16="http://schemas.microsoft.com/office/drawing/2014/main" id="{3C1715DF-FFFB-4924-A308-1757E66A2C1D}"/>
+                <a16:creationId xmlns:a16="http://schemas.microsoft.com/office/drawing/2014/main" id="{6F52B0F5-F238-427D-94A0-B8A80C1D90E0}"/>
               </a:ext>
             </a:extLst>
           </p:cNvPr>
@@ -8919,7 +8926,7 @@
         <p:spPr>
           <a:xfrm xmlns:a="http://schemas.openxmlformats.org/drawingml/2006/main">
             <a:off x="685800" y="914400"/>
-            <a:ext cx="7239000" cy="1485900"/>
+            <a:ext cx="7620000" cy="1485900"/>
           </a:xfrm>
           <a:prstGeom xmlns:a="http://schemas.openxmlformats.org/drawingml/2006/main" prst="rect">
             <a:avLst/>
@@ -8943,7 +8950,7 @@
           <a:lstStyle xmlns:a="http://schemas.openxmlformats.org/drawingml/2006/main"/>
           <a:p xmlns:a="http://schemas.openxmlformats.org/drawingml/2006/main">
             <a:pPr algn="l">
-              <a:defRPr sz="3750" b="1">
+              <a:defRPr sz="3600" b="1">
                 <a:solidFill>
                   <a:srgbClr val="F4EFE5"/>
                 </a:solidFill>
@@ -8953,7 +8960,7 @@
               </a:defRPr>
             </a:pPr>
             <a:r>
-              <a:rPr sz="3750" b="1">
+              <a:rPr sz="3600" b="1">
                 <a:solidFill>
                   <a:srgbClr val="F4EFE5"/>
                 </a:solidFill>
@@ -8961,7 +8968,7 @@
                 <a:ea typeface="Aptos Display"/>
                 <a:cs typeface="Aptos Display"/>
               </a:rPr>
-              <a:t>Silence becomes a gentle conversation.</a:t>
+              <a:t>A solo-safe slice judges can see in two minutes.</a:t>
             </a:r>
           </a:p>
         </p:txBody>
@@ -8971,7 +8978,7 @@
           <p:cNvPr id="8" name="">
             <a:extLst xmlns:a="http://schemas.openxmlformats.org/drawingml/2006/main">
               <a:ext uri="{FF2B5EF4-FFF2-40B4-BE49-F238E27FC236}">
-                <a16:creationId xmlns:a16="http://schemas.microsoft.com/office/drawing/2014/main" id="{328408F5-8CC9-46CF-A530-6D0B5BE04E50}"/>
+                <a16:creationId xmlns:a16="http://schemas.microsoft.com/office/drawing/2014/main" id="{459E10E4-27D2-4941-956D-9DBD399B5FCB}"/>
               </a:ext>
             </a:extLst>
           </p:cNvPr>
@@ -9025,7 +9032,7 @@
                 <a:ea typeface="Aptos"/>
                 <a:cs typeface="Aptos"/>
               </a:rPr>
-              <a:t>The demo starts without menus: a medicine box on the table, a quiet orb, a respectful Japanese prompt, and a human handoff.</a:t>
+              <a:t>One builder, one stable loop: ambient orb, Gemini vision, Google Cloud voice, semantic event, and human handoff.</a:t>
             </a:r>
           </a:p>
         </p:txBody>
@@ -9035,7 +9042,7 @@
           <p:cNvPr id="9" name="">
             <a:extLst xmlns:a="http://schemas.openxmlformats.org/drawingml/2006/main">
               <a:ext uri="{FF2B5EF4-FFF2-40B4-BE49-F238E27FC236}">
-                <a16:creationId xmlns:a16="http://schemas.microsoft.com/office/drawing/2014/main" id="{DAB00FCA-426B-4489-85C6-48D6B34898DA}"/>
+                <a16:creationId xmlns:a16="http://schemas.microsoft.com/office/drawing/2014/main" id="{7C422ED3-ECF3-4D95-B51E-A402BD71C88A}"/>
               </a:ext>
             </a:extLst>
           </p:cNvPr>
@@ -9068,7 +9075,7 @@
           <p:cNvPr id="10" name="">
             <a:extLst xmlns:a="http://schemas.openxmlformats.org/drawingml/2006/main">
               <a:ext uri="{FF2B5EF4-FFF2-40B4-BE49-F238E27FC236}">
-                <a16:creationId xmlns:a16="http://schemas.microsoft.com/office/drawing/2014/main" id="{5C543C35-4016-47B8-AAE3-4BE84DA042E1}"/>
+                <a16:creationId xmlns:a16="http://schemas.microsoft.com/office/drawing/2014/main" id="{39C3A55E-DA97-48CA-AFA8-28FE9E6FB13B}"/>
               </a:ext>
             </a:extLst>
           </p:cNvPr>
@@ -9132,7 +9139,7 @@
           <p:cNvPr id="11" name="">
             <a:extLst xmlns:a="http://schemas.openxmlformats.org/drawingml/2006/main">
               <a:ext uri="{FF2B5EF4-FFF2-40B4-BE49-F238E27FC236}">
-                <a16:creationId xmlns:a16="http://schemas.microsoft.com/office/drawing/2014/main" id="{5BE2C4E5-1DCC-4F05-9222-EE47759EADB6}"/>
+                <a16:creationId xmlns:a16="http://schemas.microsoft.com/office/drawing/2014/main" id="{11CF3E33-CC06-4233-AF8E-328007F022EB}"/>
               </a:ext>
             </a:extLst>
           </p:cNvPr>
@@ -9186,7 +9193,7 @@
                 <a:ea typeface="Aptos"/>
                 <a:cs typeface="Aptos"/>
               </a:rPr>
-              <a:t>Silence</a:t>
+              <a:t>Category</a:t>
             </a:r>
           </a:p>
         </p:txBody>
@@ -9196,7 +9203,7 @@
           <p:cNvPr id="12" name="">
             <a:extLst xmlns:a="http://schemas.openxmlformats.org/drawingml/2006/main">
               <a:ext uri="{FF2B5EF4-FFF2-40B4-BE49-F238E27FC236}">
-                <a16:creationId xmlns:a16="http://schemas.microsoft.com/office/drawing/2014/main" id="{A6404E6D-6425-4739-9ADB-0C5CD38716FC}"/>
+                <a16:creationId xmlns:a16="http://schemas.microsoft.com/office/drawing/2014/main" id="{06365443-F4E8-43B1-A5D5-22DA03DB66EC}"/>
               </a:ext>
             </a:extLst>
           </p:cNvPr>
@@ -9250,7 +9257,7 @@
                 <a:ea typeface="Aptos"/>
                 <a:cs typeface="Aptos"/>
               </a:rPr>
-              <a:t>No tap, no search, no request for help.</a:t>
+              <a:t>Ambient Family Intelligence, not another senior app.</a:t>
             </a:r>
           </a:p>
         </p:txBody>
@@ -9260,7 +9267,7 @@
           <p:cNvPr id="13" name="">
             <a:extLst xmlns:a="http://schemas.openxmlformats.org/drawingml/2006/main">
               <a:ext uri="{FF2B5EF4-FFF2-40B4-BE49-F238E27FC236}">
-                <a16:creationId xmlns:a16="http://schemas.microsoft.com/office/drawing/2014/main" id="{F559714F-DE7F-458B-8F9A-937757EAE6E5}"/>
+                <a16:creationId xmlns:a16="http://schemas.microsoft.com/office/drawing/2014/main" id="{1345ACDB-3C47-46EE-8640-64984D404784}"/>
               </a:ext>
             </a:extLst>
           </p:cNvPr>
@@ -9293,7 +9300,7 @@
           <p:cNvPr id="14" name="">
             <a:extLst xmlns:a="http://schemas.openxmlformats.org/drawingml/2006/main">
               <a:ext uri="{FF2B5EF4-FFF2-40B4-BE49-F238E27FC236}">
-                <a16:creationId xmlns:a16="http://schemas.microsoft.com/office/drawing/2014/main" id="{0276749E-6224-4D8E-AAAB-DEFA61EF380A}"/>
+                <a16:creationId xmlns:a16="http://schemas.microsoft.com/office/drawing/2014/main" id="{6C128453-7DCC-4C10-8A2A-DB81775A252E}"/>
               </a:ext>
             </a:extLst>
           </p:cNvPr>
@@ -9347,7 +9354,7 @@
                 <a:ea typeface="Aptos Mono"/>
                 <a:cs typeface="Aptos Mono"/>
               </a:rPr>
-              <a:t>15-35s</a:t>
+              <a:t>15-40s</a:t>
             </a:r>
           </a:p>
         </p:txBody>
@@ -9357,7 +9364,7 @@
           <p:cNvPr id="15" name="">
             <a:extLst xmlns:a="http://schemas.openxmlformats.org/drawingml/2006/main">
               <a:ext uri="{FF2B5EF4-FFF2-40B4-BE49-F238E27FC236}">
-                <a16:creationId xmlns:a16="http://schemas.microsoft.com/office/drawing/2014/main" id="{9715A484-91C3-4C82-A053-3AFE44271E02}"/>
+                <a16:creationId xmlns:a16="http://schemas.microsoft.com/office/drawing/2014/main" id="{2ADA0BC7-548D-4507-AE3C-6CC8E6F6F1F5}"/>
               </a:ext>
             </a:extLst>
           </p:cNvPr>
@@ -9411,7 +9418,7 @@
                 <a:ea typeface="Aptos"/>
                 <a:cs typeface="Aptos"/>
               </a:rPr>
-              <a:t>Ambient sense</a:t>
+              <a:t>Gemini vision</a:t>
             </a:r>
           </a:p>
         </p:txBody>
@@ -9421,7 +9428,7 @@
           <p:cNvPr id="16" name="">
             <a:extLst xmlns:a="http://schemas.openxmlformats.org/drawingml/2006/main">
               <a:ext uri="{FF2B5EF4-FFF2-40B4-BE49-F238E27FC236}">
-                <a16:creationId xmlns:a16="http://schemas.microsoft.com/office/drawing/2014/main" id="{67FAFF0C-3BE6-4CBF-B5BF-470427E5D5F6}"/>
+                <a16:creationId xmlns:a16="http://schemas.microsoft.com/office/drawing/2014/main" id="{D7F0F540-7EE2-4E01-B50C-57E75A60A938}"/>
               </a:ext>
             </a:extLst>
           </p:cNvPr>
@@ -9475,7 +9482,7 @@
                 <a:ea typeface="Aptos"/>
                 <a:cs typeface="Aptos"/>
               </a:rPr>
-              <a:t>Medicine box, water cup, no confirmation.</a:t>
+              <a:t>Medicine image becomes a structured card.</a:t>
             </a:r>
           </a:p>
         </p:txBody>
@@ -9485,7 +9492,7 @@
           <p:cNvPr id="17" name="">
             <a:extLst xmlns:a="http://schemas.openxmlformats.org/drawingml/2006/main">
               <a:ext uri="{FF2B5EF4-FFF2-40B4-BE49-F238E27FC236}">
-                <a16:creationId xmlns:a16="http://schemas.microsoft.com/office/drawing/2014/main" id="{FB3B19EA-D186-4339-AD1F-D72FBE8CE5B3}"/>
+                <a16:creationId xmlns:a16="http://schemas.microsoft.com/office/drawing/2014/main" id="{9077BB33-9B45-45C9-86C4-5BFCC16AD267}"/>
               </a:ext>
             </a:extLst>
           </p:cNvPr>
@@ -9518,7 +9525,7 @@
           <p:cNvPr id="18" name="">
             <a:extLst xmlns:a="http://schemas.openxmlformats.org/drawingml/2006/main">
               <a:ext uri="{FF2B5EF4-FFF2-40B4-BE49-F238E27FC236}">
-                <a16:creationId xmlns:a16="http://schemas.microsoft.com/office/drawing/2014/main" id="{C7C3943D-1C2C-4B62-888A-B84054CAF5F0}"/>
+                <a16:creationId xmlns:a16="http://schemas.microsoft.com/office/drawing/2014/main" id="{9B11A7CA-DDDA-4636-A658-B895871D04FC}"/>
               </a:ext>
             </a:extLst>
           </p:cNvPr>
@@ -9572,7 +9579,7 @@
                 <a:ea typeface="Aptos Mono"/>
                 <a:cs typeface="Aptos Mono"/>
               </a:rPr>
-              <a:t>35-55s</a:t>
+              <a:t>40-65s</a:t>
             </a:r>
           </a:p>
         </p:txBody>
@@ -9582,7 +9589,7 @@
           <p:cNvPr id="19" name="">
             <a:extLst xmlns:a="http://schemas.openxmlformats.org/drawingml/2006/main">
               <a:ext uri="{FF2B5EF4-FFF2-40B4-BE49-F238E27FC236}">
-                <a16:creationId xmlns:a16="http://schemas.microsoft.com/office/drawing/2014/main" id="{81CF121C-9D4E-4795-A537-5D0B4D0BC3C1}"/>
+                <a16:creationId xmlns:a16="http://schemas.microsoft.com/office/drawing/2014/main" id="{12AE2AC0-7FD6-4CEB-B033-66968DE5BE14}"/>
               </a:ext>
             </a:extLst>
           </p:cNvPr>
@@ -9636,7 +9643,7 @@
                 <a:ea typeface="Aptos"/>
                 <a:cs typeface="Aptos"/>
               </a:rPr>
-              <a:t>Gentle voice</a:t>
+              <a:t>Cloud voice</a:t>
             </a:r>
           </a:p>
         </p:txBody>
@@ -9646,7 +9653,7 @@
           <p:cNvPr id="20" name="">
             <a:extLst xmlns:a="http://schemas.openxmlformats.org/drawingml/2006/main">
               <a:ext uri="{FF2B5EF4-FFF2-40B4-BE49-F238E27FC236}">
-                <a16:creationId xmlns:a16="http://schemas.microsoft.com/office/drawing/2014/main" id="{00FAEF32-350B-4C87-A1E7-CBA612925031}"/>
+                <a16:creationId xmlns:a16="http://schemas.microsoft.com/office/drawing/2014/main" id="{CF91556B-8231-4332-8979-590D27DE02DB}"/>
               </a:ext>
             </a:extLst>
           </p:cNvPr>
@@ -9700,7 +9707,7 @@
                 <a:ea typeface="Aptos"/>
                 <a:cs typeface="Aptos"/>
               </a:rPr>
-              <a:t>「一緒に確認しましょうか。」</a:t>
+              <a:t>Chirp 3 HD or device fallback.</a:t>
             </a:r>
           </a:p>
         </p:txBody>
@@ -9710,7 +9717,7 @@
           <p:cNvPr id="21" name="">
             <a:extLst xmlns:a="http://schemas.openxmlformats.org/drawingml/2006/main">
               <a:ext uri="{FF2B5EF4-FFF2-40B4-BE49-F238E27FC236}">
-                <a16:creationId xmlns:a16="http://schemas.microsoft.com/office/drawing/2014/main" id="{55CD1D19-EDC2-4391-B723-95027D61F018}"/>
+                <a16:creationId xmlns:a16="http://schemas.microsoft.com/office/drawing/2014/main" id="{8FFDA321-888A-4D6D-980F-42510F9388A0}"/>
               </a:ext>
             </a:extLst>
           </p:cNvPr>
@@ -9743,7 +9750,7 @@
           <p:cNvPr id="22" name="">
             <a:extLst xmlns:a="http://schemas.openxmlformats.org/drawingml/2006/main">
               <a:ext uri="{FF2B5EF4-FFF2-40B4-BE49-F238E27FC236}">
-                <a16:creationId xmlns:a16="http://schemas.microsoft.com/office/drawing/2014/main" id="{7B129DFF-69D8-450B-98CC-14D64B2F54F7}"/>
+                <a16:creationId xmlns:a16="http://schemas.microsoft.com/office/drawing/2014/main" id="{AEAF2F26-FBB5-405A-AF4E-3EE1BE942E56}"/>
               </a:ext>
             </a:extLst>
           </p:cNvPr>
@@ -9797,7 +9804,7 @@
                 <a:ea typeface="Aptos Mono"/>
                 <a:cs typeface="Aptos Mono"/>
               </a:rPr>
-              <a:t>55-75s</a:t>
+              <a:t>65-95s</a:t>
             </a:r>
           </a:p>
         </p:txBody>
@@ -9807,7 +9814,7 @@
           <p:cNvPr id="23" name="">
             <a:extLst xmlns:a="http://schemas.openxmlformats.org/drawingml/2006/main">
               <a:ext uri="{FF2B5EF4-FFF2-40B4-BE49-F238E27FC236}">
-                <a16:creationId xmlns:a16="http://schemas.microsoft.com/office/drawing/2014/main" id="{126FFC58-8BF6-4C43-A11E-576C73BDA138}"/>
+                <a16:creationId xmlns:a16="http://schemas.microsoft.com/office/drawing/2014/main" id="{3D8880C4-7586-4C6E-BE2C-140BADEC37EC}"/>
               </a:ext>
             </a:extLst>
           </p:cNvPr>
@@ -9861,7 +9868,7 @@
                 <a:ea typeface="Aptos"/>
                 <a:cs typeface="Aptos"/>
               </a:rPr>
-              <a:t>Memory</a:t>
+              <a:t>Signal</a:t>
             </a:r>
           </a:p>
         </p:txBody>
@@ -9871,7 +9878,7 @@
           <p:cNvPr id="24" name="">
             <a:extLst xmlns:a="http://schemas.openxmlformats.org/drawingml/2006/main">
               <a:ext uri="{FF2B5EF4-FFF2-40B4-BE49-F238E27FC236}">
-                <a16:creationId xmlns:a16="http://schemas.microsoft.com/office/drawing/2014/main" id="{A2533539-12BF-4630-8939-7E1CDEE5959F}"/>
+                <a16:creationId xmlns:a16="http://schemas.microsoft.com/office/drawing/2014/main" id="{7C01D6E3-347E-4997-8B50-8DE60D1915FD}"/>
               </a:ext>
             </a:extLst>
           </p:cNvPr>
@@ -9925,7 +9932,30 @@
                 <a:ea typeface="Aptos"/>
                 <a:cs typeface="Aptos"/>
               </a:rPr>
-              <a:t>Yesterday: dizzy. Today: go slowly.</a:t>
+              <a:t>semantic token,</a:t>
+            </a:r>
+          </a:p>
+          <a:p xmlns:a="http://schemas.openxmlformats.org/drawingml/2006/main">
+            <a:pPr algn="l">
+              <a:defRPr sz="1125" b="0">
+                <a:solidFill>
+                  <a:srgbClr val="AEB8C8"/>
+                </a:solidFill>
+                <a:latin typeface="Aptos"/>
+                <a:ea typeface="Aptos"/>
+                <a:cs typeface="Aptos"/>
+              </a:defRPr>
+            </a:pPr>
+            <a:r>
+              <a:rPr sz="1125" b="0">
+                <a:solidFill>
+                  <a:srgbClr val="AEB8C8"/>
+                </a:solidFill>
+                <a:latin typeface="Aptos"/>
+                <a:ea typeface="Aptos"/>
+                <a:cs typeface="Aptos"/>
+              </a:rPr>
+              <a:t>no raw stream.</a:t>
             </a:r>
           </a:p>
         </p:txBody>
@@ -9935,7 +9965,7 @@
           <p:cNvPr id="25" name="">
             <a:extLst xmlns:a="http://schemas.openxmlformats.org/drawingml/2006/main">
               <a:ext uri="{FF2B5EF4-FFF2-40B4-BE49-F238E27FC236}">
-                <a16:creationId xmlns:a16="http://schemas.microsoft.com/office/drawing/2014/main" id="{94047B6B-1DF5-4698-BBFF-0B4B6A659CCB}"/>
+                <a16:creationId xmlns:a16="http://schemas.microsoft.com/office/drawing/2014/main" id="{493B6C6C-9EBB-4AA6-A0A9-8D5675D3AF90}"/>
               </a:ext>
             </a:extLst>
           </p:cNvPr>
@@ -9970,7 +10000,7 @@
           <p:cNvPr id="26" name="">
             <a:extLst xmlns:a="http://schemas.openxmlformats.org/drawingml/2006/main">
               <a:ext uri="{FF2B5EF4-FFF2-40B4-BE49-F238E27FC236}">
-                <a16:creationId xmlns:a16="http://schemas.microsoft.com/office/drawing/2014/main" id="{6A69AA39-2785-4195-922F-85105309964D}"/>
+                <a16:creationId xmlns:a16="http://schemas.microsoft.com/office/drawing/2014/main" id="{8C9FA512-3CA9-48E4-95EF-D1D5DA3763DB}"/>
               </a:ext>
             </a:extLst>
           </p:cNvPr>
@@ -10024,7 +10054,7 @@
                 <a:ea typeface="Aptos"/>
                 <a:cs typeface="Aptos"/>
               </a:rPr>
-              <a:t>75-90s | Family summary: no emergency; pharmacist confirmation recommended.</a:t>
+              <a:t>95-120s | Copy handoff memo, then close: no diagnosis, no dosage change.</a:t>
             </a:r>
           </a:p>
         </p:txBody>
@@ -10034,7 +10064,7 @@
           <p:cNvPr id="27" name="">
             <a:extLst xmlns:a="http://schemas.openxmlformats.org/drawingml/2006/main">
               <a:ext uri="{FF2B5EF4-FFF2-40B4-BE49-F238E27FC236}">
-                <a16:creationId xmlns:a16="http://schemas.microsoft.com/office/drawing/2014/main" id="{9C667583-6849-4B58-9F58-D3851FC9079A}"/>
+                <a16:creationId xmlns:a16="http://schemas.microsoft.com/office/drawing/2014/main" id="{7A526723-67DF-4028-A0B2-3F85C162F01B}"/>
               </a:ext>
             </a:extLst>
           </p:cNvPr>
@@ -10067,7 +10097,7 @@
           <p:cNvPr id="28" name="">
             <a:extLst xmlns:a="http://schemas.openxmlformats.org/drawingml/2006/main">
               <a:ext uri="{FF2B5EF4-FFF2-40B4-BE49-F238E27FC236}">
-                <a16:creationId xmlns:a16="http://schemas.microsoft.com/office/drawing/2014/main" id="{014B9876-18B8-49BF-9C0B-1B05D84DE4DD}"/>
+                <a16:creationId xmlns:a16="http://schemas.microsoft.com/office/drawing/2014/main" id="{CB9C67EF-509C-42B4-94C2-8607283462D9}"/>
               </a:ext>
             </a:extLst>
           </p:cNvPr>
@@ -10100,7 +10130,7 @@
           <p:cNvPr id="29" name="">
             <a:extLst xmlns:a="http://schemas.openxmlformats.org/drawingml/2006/main">
               <a:ext uri="{FF2B5EF4-FFF2-40B4-BE49-F238E27FC236}">
-                <a16:creationId xmlns:a16="http://schemas.microsoft.com/office/drawing/2014/main" id="{56E8F4AA-C566-4A0D-AC18-E664A0FE5175}"/>
+                <a16:creationId xmlns:a16="http://schemas.microsoft.com/office/drawing/2014/main" id="{88866F59-7099-4A48-8E8A-4CDF09D83B00}"/>
               </a:ext>
             </a:extLst>
           </p:cNvPr>
@@ -10135,7 +10165,7 @@
           <p:cNvPr id="30" name="">
             <a:extLst xmlns:a="http://schemas.openxmlformats.org/drawingml/2006/main">
               <a:ext uri="{FF2B5EF4-FFF2-40B4-BE49-F238E27FC236}">
-                <a16:creationId xmlns:a16="http://schemas.microsoft.com/office/drawing/2014/main" id="{656B91E0-7BAF-422A-8CD3-E35AE902DF8D}"/>
+                <a16:creationId xmlns:a16="http://schemas.microsoft.com/office/drawing/2014/main" id="{91A60283-3FEA-4473-8355-730E9626F8BB}"/>
               </a:ext>
             </a:extLst>
           </p:cNvPr>
@@ -10199,7 +10229,7 @@
           <p:cNvPr id="31" name="">
             <a:extLst xmlns:a="http://schemas.openxmlformats.org/drawingml/2006/main">
               <a:ext uri="{FF2B5EF4-FFF2-40B4-BE49-F238E27FC236}">
-                <a16:creationId xmlns:a16="http://schemas.microsoft.com/office/drawing/2014/main" id="{4B1A7E34-48CA-4E8B-9C51-56E520C75571}"/>
+                <a16:creationId xmlns:a16="http://schemas.microsoft.com/office/drawing/2014/main" id="{75FFB0EB-8A4C-4293-9355-3204877ADB3F}"/>
               </a:ext>
             </a:extLst>
           </p:cNvPr>
@@ -10232,7 +10262,7 @@
           <p:cNvPr id="32" name="">
             <a:extLst xmlns:a="http://schemas.openxmlformats.org/drawingml/2006/main">
               <a:ext uri="{FF2B5EF4-FFF2-40B4-BE49-F238E27FC236}">
-                <a16:creationId xmlns:a16="http://schemas.microsoft.com/office/drawing/2014/main" id="{D809978F-9D8C-4C4B-9D6C-316C2E199E31}"/>
+                <a16:creationId xmlns:a16="http://schemas.microsoft.com/office/drawing/2014/main" id="{8F596494-C5D4-4A98-A397-88BA086A4BD7}"/>
               </a:ext>
             </a:extLst>
           </p:cNvPr>
@@ -10296,7 +10326,7 @@
           <p:cNvPr id="33" name="">
             <a:extLst xmlns:a="http://schemas.openxmlformats.org/drawingml/2006/main">
               <a:ext uri="{FF2B5EF4-FFF2-40B4-BE49-F238E27FC236}">
-                <a16:creationId xmlns:a16="http://schemas.microsoft.com/office/drawing/2014/main" id="{5A5562F9-3C43-49B8-A6EB-5E26F689E9AF}"/>
+                <a16:creationId xmlns:a16="http://schemas.microsoft.com/office/drawing/2014/main" id="{DE297DDE-CC27-48F7-B71A-D36C25CDEB2B}"/>
               </a:ext>
             </a:extLst>
           </p:cNvPr>
@@ -10360,7 +10390,7 @@
           <p:cNvPr id="34" name="">
             <a:extLst xmlns:a="http://schemas.openxmlformats.org/drawingml/2006/main">
               <a:ext uri="{FF2B5EF4-FFF2-40B4-BE49-F238E27FC236}">
-                <a16:creationId xmlns:a16="http://schemas.microsoft.com/office/drawing/2014/main" id="{3D39484D-5705-434B-B98B-28F0C3749586}"/>
+                <a16:creationId xmlns:a16="http://schemas.microsoft.com/office/drawing/2014/main" id="{BEADF04F-F428-4BF2-B6D2-C6D8BA33D65E}"/>
               </a:ext>
             </a:extLst>
           </p:cNvPr>
@@ -10393,7 +10423,7 @@
           <p:cNvPr id="35" name="">
             <a:extLst xmlns:a="http://schemas.openxmlformats.org/drawingml/2006/main">
               <a:ext uri="{FF2B5EF4-FFF2-40B4-BE49-F238E27FC236}">
-                <a16:creationId xmlns:a16="http://schemas.microsoft.com/office/drawing/2014/main" id="{0124642F-DDF5-4566-ABDC-EA21D37C1C90}"/>
+                <a16:creationId xmlns:a16="http://schemas.microsoft.com/office/drawing/2014/main" id="{9BAFAC3F-293F-4C27-B4A3-3287DC1D2399}"/>
               </a:ext>
             </a:extLst>
           </p:cNvPr>
@@ -10457,7 +10487,7 @@
           <p:cNvPr id="36" name="">
             <a:extLst xmlns:a="http://schemas.openxmlformats.org/drawingml/2006/main">
               <a:ext uri="{FF2B5EF4-FFF2-40B4-BE49-F238E27FC236}">
-                <a16:creationId xmlns:a16="http://schemas.microsoft.com/office/drawing/2014/main" id="{01AC995C-0EEB-4B9B-86CB-3A453CCEBCCC}"/>
+                <a16:creationId xmlns:a16="http://schemas.microsoft.com/office/drawing/2014/main" id="{18D39081-D853-4D54-809A-886A5FDB8458}"/>
               </a:ext>
             </a:extLst>
           </p:cNvPr>
@@ -10469,7 +10499,7 @@
         <p:spPr>
           <a:xfrm xmlns:a="http://schemas.openxmlformats.org/drawingml/2006/main">
             <a:off x="723900" y="5905500"/>
-            <a:ext cx="2057400" cy="266700"/>
+            <a:ext cx="1619250" cy="266700"/>
           </a:xfrm>
           <a:prstGeom xmlns:a="http://schemas.openxmlformats.org/drawingml/2006/main" prst="rect">
             <a:avLst/>
@@ -10492,7 +10522,7 @@
           <p:cNvPr id="37" name="">
             <a:extLst xmlns:a="http://schemas.openxmlformats.org/drawingml/2006/main">
               <a:ext uri="{FF2B5EF4-FFF2-40B4-BE49-F238E27FC236}">
-                <a16:creationId xmlns:a16="http://schemas.microsoft.com/office/drawing/2014/main" id="{13CE42D2-E23F-45BC-BBFB-74575649FB13}"/>
+                <a16:creationId xmlns:a16="http://schemas.microsoft.com/office/drawing/2014/main" id="{B4B1DE24-3D33-4189-94DF-971AC1AD258A}"/>
               </a:ext>
             </a:extLst>
           </p:cNvPr>
@@ -10504,7 +10534,7 @@
         <p:spPr>
           <a:xfrm xmlns:a="http://schemas.openxmlformats.org/drawingml/2006/main">
             <a:off x="819150" y="5953125"/>
-            <a:ext cx="1866900" cy="171450"/>
+            <a:ext cx="1428750" cy="171450"/>
           </a:xfrm>
           <a:prstGeom xmlns:a="http://schemas.openxmlformats.org/drawingml/2006/main" prst="rect">
             <a:avLst/>
@@ -10546,7 +10576,7 @@
                 <a:ea typeface="Aptos Mono"/>
                 <a:cs typeface="Aptos Mono"/>
               </a:rPr>
-              <a:t>not another senior app</a:t>
+              <a:t>solo executable</a:t>
             </a:r>
           </a:p>
         </p:txBody>
@@ -10556,31 +10586,31 @@
           <p:cNvPr id="38" name="">
             <a:extLst xmlns:a="http://schemas.openxmlformats.org/drawingml/2006/main">
               <a:ext uri="{FF2B5EF4-FFF2-40B4-BE49-F238E27FC236}">
-                <a16:creationId xmlns:a16="http://schemas.microsoft.com/office/drawing/2014/main" id="{EB0D41C1-CFA5-447F-8405-0C09655D9237}"/>
-              </a:ext>
-            </a:extLst>
-          </p:cNvPr>
-          <p:cNvSpPr>
-            <a:spLocks xmlns:a="http://schemas.openxmlformats.org/drawingml/2006/main" noGrp="1"/>
-          </p:cNvSpPr>
-          <p:nvPr/>
-        </p:nvSpPr>
-        <p:spPr>
-          <a:xfrm xmlns:a="http://schemas.openxmlformats.org/drawingml/2006/main">
-            <a:off x="2971800" y="5905500"/>
-            <a:ext cx="2857500" cy="266700"/>
-          </a:xfrm>
-          <a:prstGeom xmlns:a="http://schemas.openxmlformats.org/drawingml/2006/main" prst="rect">
-            <a:avLst/>
-          </a:prstGeom>
-          <a:solidFill xmlns:a="http://schemas.openxmlformats.org/drawingml/2006/main">
-            <a:srgbClr val="7CD6C4">
+                <a16:creationId xmlns:a16="http://schemas.microsoft.com/office/drawing/2014/main" id="{991966C1-A01C-4FD7-92B9-99EAF1885529}"/>
+              </a:ext>
+            </a:extLst>
+          </p:cNvPr>
+          <p:cNvSpPr>
+            <a:spLocks xmlns:a="http://schemas.openxmlformats.org/drawingml/2006/main" noGrp="1"/>
+          </p:cNvSpPr>
+          <p:nvPr/>
+        </p:nvSpPr>
+        <p:spPr>
+          <a:xfrm xmlns:a="http://schemas.openxmlformats.org/drawingml/2006/main">
+            <a:off x="2533650" y="5905500"/>
+            <a:ext cx="2000250" cy="266700"/>
+          </a:xfrm>
+          <a:prstGeom xmlns:a="http://schemas.openxmlformats.org/drawingml/2006/main" prst="rect">
+            <a:avLst/>
+          </a:prstGeom>
+          <a:solidFill xmlns:a="http://schemas.openxmlformats.org/drawingml/2006/main">
+            <a:srgbClr val="8CA7FF">
               <a:alpha val="13333"/>
             </a:srgbClr>
           </a:solidFill>
           <a:ln xmlns:a="http://schemas.openxmlformats.org/drawingml/2006/main" w="9525">
             <a:solidFill>
-              <a:srgbClr val="7CD6C4"/>
+              <a:srgbClr val="8CA7FF"/>
             </a:solidFill>
             <a:prstDash val="solid"/>
           </a:ln>
@@ -10591,19 +10621,19 @@
           <p:cNvPr id="39" name="">
             <a:extLst xmlns:a="http://schemas.openxmlformats.org/drawingml/2006/main">
               <a:ext uri="{FF2B5EF4-FFF2-40B4-BE49-F238E27FC236}">
-                <a16:creationId xmlns:a16="http://schemas.microsoft.com/office/drawing/2014/main" id="{3030271C-97C7-4989-80A6-929C11A33194}"/>
-              </a:ext>
-            </a:extLst>
-          </p:cNvPr>
-          <p:cNvSpPr>
-            <a:spLocks xmlns:a="http://schemas.openxmlformats.org/drawingml/2006/main" noGrp="1"/>
-          </p:cNvSpPr>
-          <p:nvPr/>
-        </p:nvSpPr>
-        <p:spPr>
-          <a:xfrm xmlns:a="http://schemas.openxmlformats.org/drawingml/2006/main">
-            <a:off x="3067050" y="5953125"/>
-            <a:ext cx="2667000" cy="171450"/>
+                <a16:creationId xmlns:a16="http://schemas.microsoft.com/office/drawing/2014/main" id="{3B780366-D133-472D-B428-ED6EC007D909}"/>
+              </a:ext>
+            </a:extLst>
+          </p:cNvPr>
+          <p:cNvSpPr>
+            <a:spLocks xmlns:a="http://schemas.openxmlformats.org/drawingml/2006/main" noGrp="1"/>
+          </p:cNvSpPr>
+          <p:nvPr/>
+        </p:nvSpPr>
+        <p:spPr>
+          <a:xfrm xmlns:a="http://schemas.openxmlformats.org/drawingml/2006/main">
+            <a:off x="2628900" y="5953125"/>
+            <a:ext cx="1809750" cy="171450"/>
           </a:xfrm>
           <a:prstGeom xmlns:a="http://schemas.openxmlformats.org/drawingml/2006/main" prst="rect">
             <a:avLst/>
@@ -10629,7 +10659,7 @@
             <a:pPr algn="ctr">
               <a:defRPr sz="900" b="1">
                 <a:solidFill>
-                  <a:srgbClr val="7CD6C4"/>
+                  <a:srgbClr val="8CA7FF"/>
                 </a:solidFill>
                 <a:latin typeface="Aptos Mono"/>
                 <a:ea typeface="Aptos Mono"/>
@@ -10639,13 +10669,13 @@
             <a:r>
               <a:rPr sz="900" b="1">
                 <a:solidFill>
-                  <a:srgbClr val="7CD6C4"/>
+                  <a:srgbClr val="8CA7FF"/>
                 </a:solidFill>
                 <a:latin typeface="Aptos Mono"/>
                 <a:ea typeface="Aptos Mono"/>
                 <a:cs typeface="Aptos Mono"/>
               </a:rPr>
-              <a:t>ambient family intelligence layer</a:t>
+              <a:t>Google Cloud visible</a:t>
             </a:r>
           </a:p>
         </p:txBody>
@@ -10655,19 +10685,54 @@
           <p:cNvPr id="40" name="">
             <a:extLst xmlns:a="http://schemas.openxmlformats.org/drawingml/2006/main">
               <a:ext uri="{FF2B5EF4-FFF2-40B4-BE49-F238E27FC236}">
-                <a16:creationId xmlns:a16="http://schemas.microsoft.com/office/drawing/2014/main" id="{954FF294-D5DD-429B-905F-CC670DBD09AA}"/>
-              </a:ext>
-            </a:extLst>
-          </p:cNvPr>
-          <p:cNvSpPr>
-            <a:spLocks xmlns:a="http://schemas.openxmlformats.org/drawingml/2006/main" noGrp="1"/>
-          </p:cNvSpPr>
-          <p:nvPr/>
-        </p:nvSpPr>
-        <p:spPr>
-          <a:xfrm xmlns:a="http://schemas.openxmlformats.org/drawingml/2006/main">
-            <a:off x="495300" y="6477000"/>
-            <a:ext cx="4762500" cy="171450"/>
+                <a16:creationId xmlns:a16="http://schemas.microsoft.com/office/drawing/2014/main" id="{9292BB13-7170-4DC8-BA91-197E42786B39}"/>
+              </a:ext>
+            </a:extLst>
+          </p:cNvPr>
+          <p:cNvSpPr>
+            <a:spLocks xmlns:a="http://schemas.openxmlformats.org/drawingml/2006/main" noGrp="1"/>
+          </p:cNvSpPr>
+          <p:nvPr/>
+        </p:nvSpPr>
+        <p:spPr>
+          <a:xfrm xmlns:a="http://schemas.openxmlformats.org/drawingml/2006/main">
+            <a:off x="4724400" y="5905500"/>
+            <a:ext cx="2476500" cy="266700"/>
+          </a:xfrm>
+          <a:prstGeom xmlns:a="http://schemas.openxmlformats.org/drawingml/2006/main" prst="rect">
+            <a:avLst/>
+          </a:prstGeom>
+          <a:solidFill xmlns:a="http://schemas.openxmlformats.org/drawingml/2006/main">
+            <a:srgbClr val="7CD6C4">
+              <a:alpha val="13333"/>
+            </a:srgbClr>
+          </a:solidFill>
+          <a:ln xmlns:a="http://schemas.openxmlformats.org/drawingml/2006/main" w="9525">
+            <a:solidFill>
+              <a:srgbClr val="7CD6C4"/>
+            </a:solidFill>
+            <a:prstDash val="solid"/>
+          </a:ln>
+        </p:spPr>
+      </p:sp>
+      <p:sp>
+        <p:nvSpPr>
+          <p:cNvPr id="41" name="">
+            <a:extLst xmlns:a="http://schemas.openxmlformats.org/drawingml/2006/main">
+              <a:ext uri="{FF2B5EF4-FFF2-40B4-BE49-F238E27FC236}">
+                <a16:creationId xmlns:a16="http://schemas.microsoft.com/office/drawing/2014/main" id="{5BFF26CC-7C43-4797-B603-727B1C85B2A8}"/>
+              </a:ext>
+            </a:extLst>
+          </p:cNvPr>
+          <p:cNvSpPr>
+            <a:spLocks xmlns:a="http://schemas.openxmlformats.org/drawingml/2006/main" noGrp="1"/>
+          </p:cNvSpPr>
+          <p:nvPr/>
+        </p:nvSpPr>
+        <p:spPr>
+          <a:xfrm xmlns:a="http://schemas.openxmlformats.org/drawingml/2006/main">
+            <a:off x="4819650" y="5953125"/>
+            <a:ext cx="2286000" cy="171450"/>
           </a:xfrm>
           <a:prstGeom xmlns:a="http://schemas.openxmlformats.org/drawingml/2006/main" prst="rect">
             <a:avLst/>
@@ -10690,74 +10755,10 @@
           <a:bodyPr xmlns:a="http://schemas.openxmlformats.org/drawingml/2006/main" lIns="0" tIns="0" rIns="0" bIns="0" anchor="t"/>
           <a:lstStyle xmlns:a="http://schemas.openxmlformats.org/drawingml/2006/main"/>
           <a:p xmlns:a="http://schemas.openxmlformats.org/drawingml/2006/main">
-            <a:pPr algn="l">
-              <a:defRPr sz="900" b="0">
-                <a:solidFill>
-                  <a:srgbClr val="5E6978"/>
-                </a:solidFill>
-                <a:latin typeface="Aptos"/>
-                <a:ea typeface="Aptos"/>
-                <a:cs typeface="Aptos"/>
-              </a:defRPr>
-            </a:pPr>
-            <a:r>
-              <a:rPr sz="900" b="0">
-                <a:solidFill>
-                  <a:srgbClr val="5E6978"/>
-                </a:solidFill>
-                <a:latin typeface="Aptos"/>
-                <a:ea typeface="Aptos"/>
-                <a:cs typeface="Aptos"/>
-              </a:rPr>
-              <a:t>SilverLink Ambient Agent | Gemini Hackathon Tokyo 2026</a:t>
-            </a:r>
-          </a:p>
-        </p:txBody>
-      </p:sp>
-      <p:sp>
-        <p:nvSpPr>
-          <p:cNvPr id="41" name="">
-            <a:extLst xmlns:a="http://schemas.openxmlformats.org/drawingml/2006/main">
-              <a:ext uri="{FF2B5EF4-FFF2-40B4-BE49-F238E27FC236}">
-                <a16:creationId xmlns:a16="http://schemas.microsoft.com/office/drawing/2014/main" id="{841DF4FD-4390-4440-A4AA-42E1611B0BB8}"/>
-              </a:ext>
-            </a:extLst>
-          </p:cNvPr>
-          <p:cNvSpPr>
-            <a:spLocks xmlns:a="http://schemas.openxmlformats.org/drawingml/2006/main" noGrp="1"/>
-          </p:cNvSpPr>
-          <p:nvPr/>
-        </p:nvSpPr>
-        <p:spPr>
-          <a:xfrm xmlns:a="http://schemas.openxmlformats.org/drawingml/2006/main">
-            <a:off x="11239500" y="6419850"/>
-            <a:ext cx="457200" cy="228600"/>
-          </a:xfrm>
-          <a:prstGeom xmlns:a="http://schemas.openxmlformats.org/drawingml/2006/main" prst="rect">
-            <a:avLst/>
-          </a:prstGeom>
-          <a:solidFill xmlns:a="http://schemas.openxmlformats.org/drawingml/2006/main">
-            <a:srgbClr val="000000">
-              <a:alpha val="0"/>
-            </a:srgbClr>
-          </a:solidFill>
-          <a:ln xmlns:a="http://schemas.openxmlformats.org/drawingml/2006/main" w="0">
-            <a:solidFill>
-              <a:srgbClr val="000000">
-                <a:alpha val="0"/>
-              </a:srgbClr>
-            </a:solidFill>
-            <a:prstDash val="solid"/>
-          </a:ln>
-        </p:spPr>
-        <p:txBody>
-          <a:bodyPr xmlns:a="http://schemas.openxmlformats.org/drawingml/2006/main" lIns="0" tIns="0" rIns="0" bIns="0" anchor="t"/>
-          <a:lstStyle xmlns:a="http://schemas.openxmlformats.org/drawingml/2006/main"/>
-          <a:p xmlns:a="http://schemas.openxmlformats.org/drawingml/2006/main">
-            <a:pPr algn="r">
-              <a:defRPr sz="1050" b="0">
-                <a:solidFill>
-                  <a:srgbClr val="5E6978"/>
+            <a:pPr algn="ctr">
+              <a:defRPr sz="900" b="1">
+                <a:solidFill>
+                  <a:srgbClr val="7CD6C4"/>
                 </a:solidFill>
                 <a:latin typeface="Aptos Mono"/>
                 <a:ea typeface="Aptos Mono"/>
@@ -10765,6 +10766,134 @@
               </a:defRPr>
             </a:pPr>
             <a:r>
+              <a:rPr sz="900" b="1">
+                <a:solidFill>
+                  <a:srgbClr val="7CD6C4"/>
+                </a:solidFill>
+                <a:latin typeface="Aptos Mono"/>
+                <a:ea typeface="Aptos Mono"/>
+                <a:cs typeface="Aptos Mono"/>
+              </a:rPr>
+              <a:t>ambient family intelligence</a:t>
+            </a:r>
+          </a:p>
+        </p:txBody>
+      </p:sp>
+      <p:sp>
+        <p:nvSpPr>
+          <p:cNvPr id="42" name="">
+            <a:extLst xmlns:a="http://schemas.openxmlformats.org/drawingml/2006/main">
+              <a:ext uri="{FF2B5EF4-FFF2-40B4-BE49-F238E27FC236}">
+                <a16:creationId xmlns:a16="http://schemas.microsoft.com/office/drawing/2014/main" id="{DDC396DE-044C-48C3-8F5C-E7435D8C0894}"/>
+              </a:ext>
+            </a:extLst>
+          </p:cNvPr>
+          <p:cNvSpPr>
+            <a:spLocks xmlns:a="http://schemas.openxmlformats.org/drawingml/2006/main" noGrp="1"/>
+          </p:cNvSpPr>
+          <p:nvPr/>
+        </p:nvSpPr>
+        <p:spPr>
+          <a:xfrm xmlns:a="http://schemas.openxmlformats.org/drawingml/2006/main">
+            <a:off x="495300" y="6477000"/>
+            <a:ext cx="4762500" cy="171450"/>
+          </a:xfrm>
+          <a:prstGeom xmlns:a="http://schemas.openxmlformats.org/drawingml/2006/main" prst="rect">
+            <a:avLst/>
+          </a:prstGeom>
+          <a:solidFill xmlns:a="http://schemas.openxmlformats.org/drawingml/2006/main">
+            <a:srgbClr val="000000">
+              <a:alpha val="0"/>
+            </a:srgbClr>
+          </a:solidFill>
+          <a:ln xmlns:a="http://schemas.openxmlformats.org/drawingml/2006/main" w="0">
+            <a:solidFill>
+              <a:srgbClr val="000000">
+                <a:alpha val="0"/>
+              </a:srgbClr>
+            </a:solidFill>
+            <a:prstDash val="solid"/>
+          </a:ln>
+        </p:spPr>
+        <p:txBody>
+          <a:bodyPr xmlns:a="http://schemas.openxmlformats.org/drawingml/2006/main" lIns="0" tIns="0" rIns="0" bIns="0" anchor="t"/>
+          <a:lstStyle xmlns:a="http://schemas.openxmlformats.org/drawingml/2006/main"/>
+          <a:p xmlns:a="http://schemas.openxmlformats.org/drawingml/2006/main">
+            <a:pPr algn="l">
+              <a:defRPr sz="900" b="0">
+                <a:solidFill>
+                  <a:srgbClr val="5E6978"/>
+                </a:solidFill>
+                <a:latin typeface="Aptos"/>
+                <a:ea typeface="Aptos"/>
+                <a:cs typeface="Aptos"/>
+              </a:defRPr>
+            </a:pPr>
+            <a:r>
+              <a:rPr sz="900" b="0">
+                <a:solidFill>
+                  <a:srgbClr val="5E6978"/>
+                </a:solidFill>
+                <a:latin typeface="Aptos"/>
+                <a:ea typeface="Aptos"/>
+                <a:cs typeface="Aptos"/>
+              </a:rPr>
+              <a:t>SilverLink Ambient Agent | Gemini Hackathon Tokyo 2026</a:t>
+            </a:r>
+          </a:p>
+        </p:txBody>
+      </p:sp>
+      <p:sp>
+        <p:nvSpPr>
+          <p:cNvPr id="43" name="">
+            <a:extLst xmlns:a="http://schemas.openxmlformats.org/drawingml/2006/main">
+              <a:ext uri="{FF2B5EF4-FFF2-40B4-BE49-F238E27FC236}">
+                <a16:creationId xmlns:a16="http://schemas.microsoft.com/office/drawing/2014/main" id="{E4BC15FB-679B-463B-9249-283FB78E9B18}"/>
+              </a:ext>
+            </a:extLst>
+          </p:cNvPr>
+          <p:cNvSpPr>
+            <a:spLocks xmlns:a="http://schemas.openxmlformats.org/drawingml/2006/main" noGrp="1"/>
+          </p:cNvSpPr>
+          <p:nvPr/>
+        </p:nvSpPr>
+        <p:spPr>
+          <a:xfrm xmlns:a="http://schemas.openxmlformats.org/drawingml/2006/main">
+            <a:off x="11239500" y="6419850"/>
+            <a:ext cx="457200" cy="228600"/>
+          </a:xfrm>
+          <a:prstGeom xmlns:a="http://schemas.openxmlformats.org/drawingml/2006/main" prst="rect">
+            <a:avLst/>
+          </a:prstGeom>
+          <a:solidFill xmlns:a="http://schemas.openxmlformats.org/drawingml/2006/main">
+            <a:srgbClr val="000000">
+              <a:alpha val="0"/>
+            </a:srgbClr>
+          </a:solidFill>
+          <a:ln xmlns:a="http://schemas.openxmlformats.org/drawingml/2006/main" w="0">
+            <a:solidFill>
+              <a:srgbClr val="000000">
+                <a:alpha val="0"/>
+              </a:srgbClr>
+            </a:solidFill>
+            <a:prstDash val="solid"/>
+          </a:ln>
+        </p:spPr>
+        <p:txBody>
+          <a:bodyPr xmlns:a="http://schemas.openxmlformats.org/drawingml/2006/main" lIns="0" tIns="0" rIns="0" bIns="0" anchor="t"/>
+          <a:lstStyle xmlns:a="http://schemas.openxmlformats.org/drawingml/2006/main"/>
+          <a:p xmlns:a="http://schemas.openxmlformats.org/drawingml/2006/main">
+            <a:pPr algn="r">
+              <a:defRPr sz="1050" b="0">
+                <a:solidFill>
+                  <a:srgbClr val="5E6978"/>
+                </a:solidFill>
+                <a:latin typeface="Aptos Mono"/>
+                <a:ea typeface="Aptos Mono"/>
+                <a:cs typeface="Aptos Mono"/>
+              </a:defRPr>
+            </a:pPr>
+            <a:r>
               <a:rPr sz="1050" b="0">
                 <a:solidFill>
                   <a:srgbClr val="5E6978"/>
@@ -10781,7 +10910,7 @@
     </p:spTree>
     <p:extLst>
       <p:ext uri="{BB962C8B-B14F-4D97-AF65-F5344CB8AC3E}">
-        <p14:creationId xmlns:p14="http://schemas.microsoft.com/office/powerpoint/2010/main" val="536771383"/>
+        <p14:creationId xmlns:p14="http://schemas.microsoft.com/office/powerpoint/2010/main" val="1884017350"/>
       </p:ext>
     </p:extLst>
   </p:cSld>
@@ -10805,7 +10934,7 @@
           <p:cNvPr id="1" name="">
             <a:extLst xmlns:a="http://schemas.openxmlformats.org/drawingml/2006/main">
               <a:ext uri="{FF2B5EF4-FFF2-40B4-BE49-F238E27FC236}">
-                <a16:creationId xmlns:a16="http://schemas.microsoft.com/office/drawing/2014/main" id="{D0297144-FCBA-4829-9DDB-12E5F7085F4C}"/>
+                <a16:creationId xmlns:a16="http://schemas.microsoft.com/office/drawing/2014/main" id="{965DF5CE-C790-4180-8FEF-489FFC967972}"/>
               </a:ext>
             </a:extLst>
           </p:cNvPr>
@@ -10840,7 +10969,7 @@
           <p:cNvPr id="2" name="">
             <a:extLst xmlns:a="http://schemas.openxmlformats.org/drawingml/2006/main">
               <a:ext uri="{FF2B5EF4-FFF2-40B4-BE49-F238E27FC236}">
-                <a16:creationId xmlns:a16="http://schemas.microsoft.com/office/drawing/2014/main" id="{81875203-67E8-4CEC-8441-C136283E88F3}"/>
+                <a16:creationId xmlns:a16="http://schemas.microsoft.com/office/drawing/2014/main" id="{FEC42641-411E-44EA-9CCA-E65FE9F0CE5D}"/>
               </a:ext>
             </a:extLst>
           </p:cNvPr>
@@ -10875,7 +11004,7 @@
           <p:cNvPr id="3" name="">
             <a:extLst xmlns:a="http://schemas.openxmlformats.org/drawingml/2006/main">
               <a:ext uri="{FF2B5EF4-FFF2-40B4-BE49-F238E27FC236}">
-                <a16:creationId xmlns:a16="http://schemas.microsoft.com/office/drawing/2014/main" id="{CC06860D-8C18-4CA1-8BBC-7A4300674B14}"/>
+                <a16:creationId xmlns:a16="http://schemas.microsoft.com/office/drawing/2014/main" id="{A938D53D-466F-4B27-AC96-C06DE202E15F}"/>
               </a:ext>
             </a:extLst>
           </p:cNvPr>
@@ -10910,7 +11039,7 @@
           <p:cNvPr id="4" name="">
             <a:extLst xmlns:a="http://schemas.openxmlformats.org/drawingml/2006/main">
               <a:ext uri="{FF2B5EF4-FFF2-40B4-BE49-F238E27FC236}">
-                <a16:creationId xmlns:a16="http://schemas.microsoft.com/office/drawing/2014/main" id="{19D50382-314E-40A0-BC4B-3D717B8FBE8E}"/>
+                <a16:creationId xmlns:a16="http://schemas.microsoft.com/office/drawing/2014/main" id="{61ECD038-9A23-472C-9831-AAAF29228C31}"/>
               </a:ext>
             </a:extLst>
           </p:cNvPr>
@@ -10945,7 +11074,7 @@
           <p:cNvPr id="5" name="">
             <a:extLst xmlns:a="http://schemas.openxmlformats.org/drawingml/2006/main">
               <a:ext uri="{FF2B5EF4-FFF2-40B4-BE49-F238E27FC236}">
-                <a16:creationId xmlns:a16="http://schemas.microsoft.com/office/drawing/2014/main" id="{F0835AE1-AEC1-4D22-A267-243B1460A95F}"/>
+                <a16:creationId xmlns:a16="http://schemas.microsoft.com/office/drawing/2014/main" id="{D08873FD-29BE-45CD-87E0-DB43B1B22C71}"/>
               </a:ext>
             </a:extLst>
           </p:cNvPr>
@@ -10980,7 +11109,7 @@
           <p:cNvPr id="6" name="">
             <a:extLst xmlns:a="http://schemas.openxmlformats.org/drawingml/2006/main">
               <a:ext uri="{FF2B5EF4-FFF2-40B4-BE49-F238E27FC236}">
-                <a16:creationId xmlns:a16="http://schemas.microsoft.com/office/drawing/2014/main" id="{07E30220-D7FA-4CD6-89EA-9CC384D1BB38}"/>
+                <a16:creationId xmlns:a16="http://schemas.microsoft.com/office/drawing/2014/main" id="{7A673C96-05B6-42BA-BCC8-B113CCBE67A8}"/>
               </a:ext>
             </a:extLst>
           </p:cNvPr>
@@ -11044,7 +11173,7 @@
           <p:cNvPr id="7" name="">
             <a:extLst xmlns:a="http://schemas.openxmlformats.org/drawingml/2006/main">
               <a:ext uri="{FF2B5EF4-FFF2-40B4-BE49-F238E27FC236}">
-                <a16:creationId xmlns:a16="http://schemas.microsoft.com/office/drawing/2014/main" id="{2CB9A2E2-A342-43CD-8C24-B193559253B2}"/>
+                <a16:creationId xmlns:a16="http://schemas.microsoft.com/office/drawing/2014/main" id="{F0F10521-CBFC-429E-A49D-B9354E4FE010}"/>
               </a:ext>
             </a:extLst>
           </p:cNvPr>
@@ -11108,7 +11237,7 @@
           <p:cNvPr id="8" name="">
             <a:extLst xmlns:a="http://schemas.openxmlformats.org/drawingml/2006/main">
               <a:ext uri="{FF2B5EF4-FFF2-40B4-BE49-F238E27FC236}">
-                <a16:creationId xmlns:a16="http://schemas.microsoft.com/office/drawing/2014/main" id="{D4984840-140B-4290-B5E0-835DEBEB0BDA}"/>
+                <a16:creationId xmlns:a16="http://schemas.microsoft.com/office/drawing/2014/main" id="{6DACFD49-FF86-491D-86A8-1B9AB2C87C7E}"/>
               </a:ext>
             </a:extLst>
           </p:cNvPr>
@@ -11172,7 +11301,7 @@
           <p:cNvPr id="9" name="">
             <a:extLst xmlns:a="http://schemas.openxmlformats.org/drawingml/2006/main">
               <a:ext uri="{FF2B5EF4-FFF2-40B4-BE49-F238E27FC236}">
-                <a16:creationId xmlns:a16="http://schemas.microsoft.com/office/drawing/2014/main" id="{8F7B1048-7E05-4A57-8D5D-1306B1F729F1}"/>
+                <a16:creationId xmlns:a16="http://schemas.microsoft.com/office/drawing/2014/main" id="{CAEA9374-2EDE-44E0-8325-C37937A9E7C3}"/>
               </a:ext>
             </a:extLst>
           </p:cNvPr>
@@ -11205,7 +11334,7 @@
           <p:cNvPr id="10" name="">
             <a:extLst xmlns:a="http://schemas.openxmlformats.org/drawingml/2006/main">
               <a:ext uri="{FF2B5EF4-FFF2-40B4-BE49-F238E27FC236}">
-                <a16:creationId xmlns:a16="http://schemas.microsoft.com/office/drawing/2014/main" id="{9291DFCA-80D7-4DC0-B340-0CF1605B8BAE}"/>
+                <a16:creationId xmlns:a16="http://schemas.microsoft.com/office/drawing/2014/main" id="{7A632550-A1E9-4D64-9720-2B740792E081}"/>
               </a:ext>
             </a:extLst>
           </p:cNvPr>
@@ -11269,7 +11398,7 @@
           <p:cNvPr id="11" name="">
             <a:extLst xmlns:a="http://schemas.openxmlformats.org/drawingml/2006/main">
               <a:ext uri="{FF2B5EF4-FFF2-40B4-BE49-F238E27FC236}">
-                <a16:creationId xmlns:a16="http://schemas.microsoft.com/office/drawing/2014/main" id="{194B284E-31EF-4FED-81EB-7CCBBE5D5999}"/>
+                <a16:creationId xmlns:a16="http://schemas.microsoft.com/office/drawing/2014/main" id="{FCEE7280-A659-4470-AF58-93180A9A108B}"/>
               </a:ext>
             </a:extLst>
           </p:cNvPr>
@@ -11306,7 +11435,7 @@
           <p:cNvPr id="12" name="">
             <a:extLst xmlns:a="http://schemas.openxmlformats.org/drawingml/2006/main">
               <a:ext uri="{FF2B5EF4-FFF2-40B4-BE49-F238E27FC236}">
-                <a16:creationId xmlns:a16="http://schemas.microsoft.com/office/drawing/2014/main" id="{A859ED7E-2CEF-4AF3-812A-D35FA709615D}"/>
+                <a16:creationId xmlns:a16="http://schemas.microsoft.com/office/drawing/2014/main" id="{A0DB440F-8FA5-46B3-AE45-57DDCCBC1938}"/>
               </a:ext>
             </a:extLst>
           </p:cNvPr>
@@ -11370,7 +11499,7 @@
           <p:cNvPr id="13" name="">
             <a:extLst xmlns:a="http://schemas.openxmlformats.org/drawingml/2006/main">
               <a:ext uri="{FF2B5EF4-FFF2-40B4-BE49-F238E27FC236}">
-                <a16:creationId xmlns:a16="http://schemas.microsoft.com/office/drawing/2014/main" id="{43D4189C-8995-475F-8915-B6741CB28B71}"/>
+                <a16:creationId xmlns:a16="http://schemas.microsoft.com/office/drawing/2014/main" id="{F49A4334-9626-45F9-9B6B-8DDFEBC0D456}"/>
               </a:ext>
             </a:extLst>
           </p:cNvPr>
@@ -11407,7 +11536,7 @@
           <p:cNvPr id="14" name="">
             <a:extLst xmlns:a="http://schemas.openxmlformats.org/drawingml/2006/main">
               <a:ext uri="{FF2B5EF4-FFF2-40B4-BE49-F238E27FC236}">
-                <a16:creationId xmlns:a16="http://schemas.microsoft.com/office/drawing/2014/main" id="{95FCC08A-AE0D-42FF-9C24-FD044130F323}"/>
+                <a16:creationId xmlns:a16="http://schemas.microsoft.com/office/drawing/2014/main" id="{46FF0ABF-A6F0-48D6-8193-F8E4C0389C69}"/>
               </a:ext>
             </a:extLst>
           </p:cNvPr>
@@ -11471,7 +11600,7 @@
           <p:cNvPr id="15" name="">
             <a:extLst xmlns:a="http://schemas.openxmlformats.org/drawingml/2006/main">
               <a:ext uri="{FF2B5EF4-FFF2-40B4-BE49-F238E27FC236}">
-                <a16:creationId xmlns:a16="http://schemas.microsoft.com/office/drawing/2014/main" id="{523BF356-40F4-42BD-863C-B8D74BC14655}"/>
+                <a16:creationId xmlns:a16="http://schemas.microsoft.com/office/drawing/2014/main" id="{77FBBE93-7FE3-470A-A14F-3BB2D40926DF}"/>
               </a:ext>
             </a:extLst>
           </p:cNvPr>
@@ -11508,7 +11637,7 @@
           <p:cNvPr id="16" name="">
             <a:extLst xmlns:a="http://schemas.openxmlformats.org/drawingml/2006/main">
               <a:ext uri="{FF2B5EF4-FFF2-40B4-BE49-F238E27FC236}">
-                <a16:creationId xmlns:a16="http://schemas.microsoft.com/office/drawing/2014/main" id="{1000C8D6-E4C6-4D8E-B89B-09D0F738A3A5}"/>
+                <a16:creationId xmlns:a16="http://schemas.microsoft.com/office/drawing/2014/main" id="{B159C232-4D7A-49CB-98E9-C4B683BB8E76}"/>
               </a:ext>
             </a:extLst>
           </p:cNvPr>
@@ -11572,7 +11701,7 @@
           <p:cNvPr id="17" name="">
             <a:extLst xmlns:a="http://schemas.openxmlformats.org/drawingml/2006/main">
               <a:ext uri="{FF2B5EF4-FFF2-40B4-BE49-F238E27FC236}">
-                <a16:creationId xmlns:a16="http://schemas.microsoft.com/office/drawing/2014/main" id="{72564D51-337E-4441-B273-93DDF8298B66}"/>
+                <a16:creationId xmlns:a16="http://schemas.microsoft.com/office/drawing/2014/main" id="{DD5F44D7-DB04-456E-B636-5ABFFE6D3A30}"/>
               </a:ext>
             </a:extLst>
           </p:cNvPr>
@@ -11636,7 +11765,7 @@
           <p:cNvPr id="18" name="">
             <a:extLst xmlns:a="http://schemas.openxmlformats.org/drawingml/2006/main">
               <a:ext uri="{FF2B5EF4-FFF2-40B4-BE49-F238E27FC236}">
-                <a16:creationId xmlns:a16="http://schemas.microsoft.com/office/drawing/2014/main" id="{5BB78216-3FDD-441E-948C-F9B1F86F8055}"/>
+                <a16:creationId xmlns:a16="http://schemas.microsoft.com/office/drawing/2014/main" id="{61781517-4C18-43AF-9B33-D0DB26B2D391}"/>
               </a:ext>
             </a:extLst>
           </p:cNvPr>
@@ -11669,7 +11798,7 @@
           <p:cNvPr id="19" name="">
             <a:extLst xmlns:a="http://schemas.openxmlformats.org/drawingml/2006/main">
               <a:ext uri="{FF2B5EF4-FFF2-40B4-BE49-F238E27FC236}">
-                <a16:creationId xmlns:a16="http://schemas.microsoft.com/office/drawing/2014/main" id="{352689E1-6811-4E69-A8C0-FAB3392ECEBB}"/>
+                <a16:creationId xmlns:a16="http://schemas.microsoft.com/office/drawing/2014/main" id="{3590676B-846E-478C-A558-77D33E18823A}"/>
               </a:ext>
             </a:extLst>
           </p:cNvPr>
@@ -11733,7 +11862,7 @@
           <p:cNvPr id="20" name="">
             <a:extLst xmlns:a="http://schemas.openxmlformats.org/drawingml/2006/main">
               <a:ext uri="{FF2B5EF4-FFF2-40B4-BE49-F238E27FC236}">
-                <a16:creationId xmlns:a16="http://schemas.microsoft.com/office/drawing/2014/main" id="{8A7B4869-E376-4C77-A94C-1894BEE20331}"/>
+                <a16:creationId xmlns:a16="http://schemas.microsoft.com/office/drawing/2014/main" id="{6F691B51-34C8-4F90-9BF0-7AE83B5C237D}"/>
               </a:ext>
             </a:extLst>
           </p:cNvPr>
@@ -11770,7 +11899,7 @@
           <p:cNvPr id="21" name="">
             <a:extLst xmlns:a="http://schemas.openxmlformats.org/drawingml/2006/main">
               <a:ext uri="{FF2B5EF4-FFF2-40B4-BE49-F238E27FC236}">
-                <a16:creationId xmlns:a16="http://schemas.microsoft.com/office/drawing/2014/main" id="{926F2603-E264-40B4-970A-D80CB13F3D54}"/>
+                <a16:creationId xmlns:a16="http://schemas.microsoft.com/office/drawing/2014/main" id="{9F14CA64-A20A-48DC-8E98-BF44EA69AE5A}"/>
               </a:ext>
             </a:extLst>
           </p:cNvPr>
@@ -11834,7 +11963,7 @@
           <p:cNvPr id="22" name="">
             <a:extLst xmlns:a="http://schemas.openxmlformats.org/drawingml/2006/main">
               <a:ext uri="{FF2B5EF4-FFF2-40B4-BE49-F238E27FC236}">
-                <a16:creationId xmlns:a16="http://schemas.microsoft.com/office/drawing/2014/main" id="{9A39CEC6-FC27-406E-A9E0-357C86706438}"/>
+                <a16:creationId xmlns:a16="http://schemas.microsoft.com/office/drawing/2014/main" id="{4901DBC7-2559-46A6-9129-A87C73C02C0C}"/>
               </a:ext>
             </a:extLst>
           </p:cNvPr>
@@ -11871,7 +12000,7 @@
           <p:cNvPr id="23" name="">
             <a:extLst xmlns:a="http://schemas.openxmlformats.org/drawingml/2006/main">
               <a:ext uri="{FF2B5EF4-FFF2-40B4-BE49-F238E27FC236}">
-                <a16:creationId xmlns:a16="http://schemas.microsoft.com/office/drawing/2014/main" id="{1A87B7EF-2655-4268-B4F5-65A06976DB8B}"/>
+                <a16:creationId xmlns:a16="http://schemas.microsoft.com/office/drawing/2014/main" id="{1C91E6C1-C67F-453C-A105-5E19962EC37E}"/>
               </a:ext>
             </a:extLst>
           </p:cNvPr>
@@ -11935,7 +12064,7 @@
           <p:cNvPr id="24" name="">
             <a:extLst xmlns:a="http://schemas.openxmlformats.org/drawingml/2006/main">
               <a:ext uri="{FF2B5EF4-FFF2-40B4-BE49-F238E27FC236}">
-                <a16:creationId xmlns:a16="http://schemas.microsoft.com/office/drawing/2014/main" id="{71FCA2F7-16DD-426E-B536-ED9EFB50EB39}"/>
+                <a16:creationId xmlns:a16="http://schemas.microsoft.com/office/drawing/2014/main" id="{889E4775-86F1-4965-B69B-66F46F4CCB52}"/>
               </a:ext>
             </a:extLst>
           </p:cNvPr>
@@ -11972,7 +12101,7 @@
           <p:cNvPr id="25" name="">
             <a:extLst xmlns:a="http://schemas.openxmlformats.org/drawingml/2006/main">
               <a:ext uri="{FF2B5EF4-FFF2-40B4-BE49-F238E27FC236}">
-                <a16:creationId xmlns:a16="http://schemas.microsoft.com/office/drawing/2014/main" id="{30674D39-4502-4514-B386-37B7B52F4ABA}"/>
+                <a16:creationId xmlns:a16="http://schemas.microsoft.com/office/drawing/2014/main" id="{128826F1-8DB6-4FD2-84FA-30973030AD37}"/>
               </a:ext>
             </a:extLst>
           </p:cNvPr>
@@ -12036,7 +12165,7 @@
           <p:cNvPr id="26" name="">
             <a:extLst xmlns:a="http://schemas.openxmlformats.org/drawingml/2006/main">
               <a:ext uri="{FF2B5EF4-FFF2-40B4-BE49-F238E27FC236}">
-                <a16:creationId xmlns:a16="http://schemas.microsoft.com/office/drawing/2014/main" id="{F634A98A-BB9D-4557-8E68-7C00044AE5DF}"/>
+                <a16:creationId xmlns:a16="http://schemas.microsoft.com/office/drawing/2014/main" id="{FD4B7A28-D774-4BDD-B486-66D2D6E0A704}"/>
               </a:ext>
             </a:extLst>
           </p:cNvPr>
@@ -12100,7 +12229,7 @@
           <p:cNvPr id="27" name="">
             <a:extLst xmlns:a="http://schemas.openxmlformats.org/drawingml/2006/main">
               <a:ext uri="{FF2B5EF4-FFF2-40B4-BE49-F238E27FC236}">
-                <a16:creationId xmlns:a16="http://schemas.microsoft.com/office/drawing/2014/main" id="{556A208D-1D1F-446F-A84A-F256DA873568}"/>
+                <a16:creationId xmlns:a16="http://schemas.microsoft.com/office/drawing/2014/main" id="{0A86DFFD-9F89-44B4-BA44-28AC816EAD19}"/>
               </a:ext>
             </a:extLst>
           </p:cNvPr>
@@ -12133,7 +12262,7 @@
           <p:cNvPr id="28" name="">
             <a:extLst xmlns:a="http://schemas.openxmlformats.org/drawingml/2006/main">
               <a:ext uri="{FF2B5EF4-FFF2-40B4-BE49-F238E27FC236}">
-                <a16:creationId xmlns:a16="http://schemas.microsoft.com/office/drawing/2014/main" id="{34F871B2-D210-4568-B6D8-1F620D08296C}"/>
+                <a16:creationId xmlns:a16="http://schemas.microsoft.com/office/drawing/2014/main" id="{69A83E89-279D-4DBD-AEC8-779C7E2F3CC4}"/>
               </a:ext>
             </a:extLst>
           </p:cNvPr>
@@ -12197,7 +12326,7 @@
           <p:cNvPr id="29" name="">
             <a:extLst xmlns:a="http://schemas.openxmlformats.org/drawingml/2006/main">
               <a:ext uri="{FF2B5EF4-FFF2-40B4-BE49-F238E27FC236}">
-                <a16:creationId xmlns:a16="http://schemas.microsoft.com/office/drawing/2014/main" id="{0726EAB4-6349-4E02-A6FA-F91407C04EEF}"/>
+                <a16:creationId xmlns:a16="http://schemas.microsoft.com/office/drawing/2014/main" id="{6E183CA5-BF58-4DD8-A952-16B00CBA0317}"/>
               </a:ext>
             </a:extLst>
           </p:cNvPr>
@@ -12234,7 +12363,7 @@
           <p:cNvPr id="30" name="">
             <a:extLst xmlns:a="http://schemas.openxmlformats.org/drawingml/2006/main">
               <a:ext uri="{FF2B5EF4-FFF2-40B4-BE49-F238E27FC236}">
-                <a16:creationId xmlns:a16="http://schemas.microsoft.com/office/drawing/2014/main" id="{E2779F40-3040-44C4-A030-86DABED5D8D3}"/>
+                <a16:creationId xmlns:a16="http://schemas.microsoft.com/office/drawing/2014/main" id="{9A6B4F46-D4C7-4004-A503-A29CA4B88A62}"/>
               </a:ext>
             </a:extLst>
           </p:cNvPr>
@@ -12298,7 +12427,7 @@
           <p:cNvPr id="31" name="">
             <a:extLst xmlns:a="http://schemas.openxmlformats.org/drawingml/2006/main">
               <a:ext uri="{FF2B5EF4-FFF2-40B4-BE49-F238E27FC236}">
-                <a16:creationId xmlns:a16="http://schemas.microsoft.com/office/drawing/2014/main" id="{ECD395AD-9329-4C28-9A49-D9FF27E08A46}"/>
+                <a16:creationId xmlns:a16="http://schemas.microsoft.com/office/drawing/2014/main" id="{EC216A84-B119-4CA9-AF9F-AE2EE356129D}"/>
               </a:ext>
             </a:extLst>
           </p:cNvPr>
@@ -12335,7 +12464,7 @@
           <p:cNvPr id="32" name="">
             <a:extLst xmlns:a="http://schemas.openxmlformats.org/drawingml/2006/main">
               <a:ext uri="{FF2B5EF4-FFF2-40B4-BE49-F238E27FC236}">
-                <a16:creationId xmlns:a16="http://schemas.microsoft.com/office/drawing/2014/main" id="{00E5D810-54D1-4966-9B12-013319E111B3}"/>
+                <a16:creationId xmlns:a16="http://schemas.microsoft.com/office/drawing/2014/main" id="{65CED613-163F-4996-A433-6B3DE0E8281B}"/>
               </a:ext>
             </a:extLst>
           </p:cNvPr>
@@ -12399,7 +12528,7 @@
           <p:cNvPr id="33" name="">
             <a:extLst xmlns:a="http://schemas.openxmlformats.org/drawingml/2006/main">
               <a:ext uri="{FF2B5EF4-FFF2-40B4-BE49-F238E27FC236}">
-                <a16:creationId xmlns:a16="http://schemas.microsoft.com/office/drawing/2014/main" id="{58571FD2-4429-4AB2-B706-E48B64829A47}"/>
+                <a16:creationId xmlns:a16="http://schemas.microsoft.com/office/drawing/2014/main" id="{063B983F-D7ED-4C3F-A169-8AD003FA604C}"/>
               </a:ext>
             </a:extLst>
           </p:cNvPr>
@@ -12436,7 +12565,7 @@
           <p:cNvPr id="34" name="">
             <a:extLst xmlns:a="http://schemas.openxmlformats.org/drawingml/2006/main">
               <a:ext uri="{FF2B5EF4-FFF2-40B4-BE49-F238E27FC236}">
-                <a16:creationId xmlns:a16="http://schemas.microsoft.com/office/drawing/2014/main" id="{1F94F8DC-A150-497D-A18A-C26F18C9278F}"/>
+                <a16:creationId xmlns:a16="http://schemas.microsoft.com/office/drawing/2014/main" id="{06E2B5A8-EF08-4D96-B4AE-06A15D9C3A48}"/>
               </a:ext>
             </a:extLst>
           </p:cNvPr>
@@ -12500,7 +12629,7 @@
           <p:cNvPr id="35" name="">
             <a:extLst xmlns:a="http://schemas.openxmlformats.org/drawingml/2006/main">
               <a:ext uri="{FF2B5EF4-FFF2-40B4-BE49-F238E27FC236}">
-                <a16:creationId xmlns:a16="http://schemas.microsoft.com/office/drawing/2014/main" id="{D3B02755-0FCC-4DC0-B1D7-4CD69C5A006A}"/>
+                <a16:creationId xmlns:a16="http://schemas.microsoft.com/office/drawing/2014/main" id="{8C0F2A16-BC5B-4859-92D8-DD73DCD15573}"/>
               </a:ext>
             </a:extLst>
           </p:cNvPr>
@@ -12564,7 +12693,7 @@
           <p:cNvPr id="36" name="">
             <a:extLst xmlns:a="http://schemas.openxmlformats.org/drawingml/2006/main">
               <a:ext uri="{FF2B5EF4-FFF2-40B4-BE49-F238E27FC236}">
-                <a16:creationId xmlns:a16="http://schemas.microsoft.com/office/drawing/2014/main" id="{CA2D4026-7E6A-4E9D-9DBF-389453F3FC09}"/>
+                <a16:creationId xmlns:a16="http://schemas.microsoft.com/office/drawing/2014/main" id="{EDB0C4E6-8346-4A41-A2D2-DFA882C95207}"/>
               </a:ext>
             </a:extLst>
           </p:cNvPr>
@@ -12597,7 +12726,7 @@
           <p:cNvPr id="37" name="">
             <a:extLst xmlns:a="http://schemas.openxmlformats.org/drawingml/2006/main">
               <a:ext uri="{FF2B5EF4-FFF2-40B4-BE49-F238E27FC236}">
-                <a16:creationId xmlns:a16="http://schemas.microsoft.com/office/drawing/2014/main" id="{29C692A8-67D8-4EEA-B668-5200D7665299}"/>
+                <a16:creationId xmlns:a16="http://schemas.microsoft.com/office/drawing/2014/main" id="{4745AD1C-34FF-40A0-B08E-006DA277AD9D}"/>
               </a:ext>
             </a:extLst>
           </p:cNvPr>
@@ -12661,7 +12790,7 @@
           <p:cNvPr id="38" name="">
             <a:extLst xmlns:a="http://schemas.openxmlformats.org/drawingml/2006/main">
               <a:ext uri="{FF2B5EF4-FFF2-40B4-BE49-F238E27FC236}">
-                <a16:creationId xmlns:a16="http://schemas.microsoft.com/office/drawing/2014/main" id="{0F420348-3414-4733-922B-4685AD71E9E4}"/>
+                <a16:creationId xmlns:a16="http://schemas.microsoft.com/office/drawing/2014/main" id="{8B2361CA-092A-4B05-AB46-0A298536AB89}"/>
               </a:ext>
             </a:extLst>
           </p:cNvPr>
@@ -12698,7 +12827,7 @@
           <p:cNvPr id="39" name="">
             <a:extLst xmlns:a="http://schemas.openxmlformats.org/drawingml/2006/main">
               <a:ext uri="{FF2B5EF4-FFF2-40B4-BE49-F238E27FC236}">
-                <a16:creationId xmlns:a16="http://schemas.microsoft.com/office/drawing/2014/main" id="{937A4D35-C801-4D4F-B826-CE9AE5C39F90}"/>
+                <a16:creationId xmlns:a16="http://schemas.microsoft.com/office/drawing/2014/main" id="{EBCCB6FC-491B-4B21-9EE9-480871577D85}"/>
               </a:ext>
             </a:extLst>
           </p:cNvPr>
@@ -12762,7 +12891,7 @@
           <p:cNvPr id="40" name="">
             <a:extLst xmlns:a="http://schemas.openxmlformats.org/drawingml/2006/main">
               <a:ext uri="{FF2B5EF4-FFF2-40B4-BE49-F238E27FC236}">
-                <a16:creationId xmlns:a16="http://schemas.microsoft.com/office/drawing/2014/main" id="{AABD2067-7078-4332-BBE5-F5507C918F30}"/>
+                <a16:creationId xmlns:a16="http://schemas.microsoft.com/office/drawing/2014/main" id="{75FE684C-E48C-4458-8974-3F24C28E89B2}"/>
               </a:ext>
             </a:extLst>
           </p:cNvPr>
@@ -12799,7 +12928,7 @@
           <p:cNvPr id="41" name="">
             <a:extLst xmlns:a="http://schemas.openxmlformats.org/drawingml/2006/main">
               <a:ext uri="{FF2B5EF4-FFF2-40B4-BE49-F238E27FC236}">
-                <a16:creationId xmlns:a16="http://schemas.microsoft.com/office/drawing/2014/main" id="{C6ED3284-DE00-4DCC-8E3E-FF3D8CAD593D}"/>
+                <a16:creationId xmlns:a16="http://schemas.microsoft.com/office/drawing/2014/main" id="{1213CEB4-4B22-4BF6-A42C-4DCCE4C853FB}"/>
               </a:ext>
             </a:extLst>
           </p:cNvPr>
@@ -12863,7 +12992,7 @@
           <p:cNvPr id="42" name="">
             <a:extLst xmlns:a="http://schemas.openxmlformats.org/drawingml/2006/main">
               <a:ext uri="{FF2B5EF4-FFF2-40B4-BE49-F238E27FC236}">
-                <a16:creationId xmlns:a16="http://schemas.microsoft.com/office/drawing/2014/main" id="{FAB54267-8407-4DA0-AB82-D7FC2F269874}"/>
+                <a16:creationId xmlns:a16="http://schemas.microsoft.com/office/drawing/2014/main" id="{B13E228C-8944-48FA-A794-FDA24AB5EE05}"/>
               </a:ext>
             </a:extLst>
           </p:cNvPr>
@@ -12900,7 +13029,7 @@
           <p:cNvPr id="43" name="">
             <a:extLst xmlns:a="http://schemas.openxmlformats.org/drawingml/2006/main">
               <a:ext uri="{FF2B5EF4-FFF2-40B4-BE49-F238E27FC236}">
-                <a16:creationId xmlns:a16="http://schemas.microsoft.com/office/drawing/2014/main" id="{20395F4A-597A-4CCF-B41C-B93833D1766C}"/>
+                <a16:creationId xmlns:a16="http://schemas.microsoft.com/office/drawing/2014/main" id="{F3001B60-3CED-492F-8E1C-E6E08E57C5F4}"/>
               </a:ext>
             </a:extLst>
           </p:cNvPr>
@@ -12964,7 +13093,7 @@
           <p:cNvPr id="44" name="">
             <a:extLst xmlns:a="http://schemas.openxmlformats.org/drawingml/2006/main">
               <a:ext uri="{FF2B5EF4-FFF2-40B4-BE49-F238E27FC236}">
-                <a16:creationId xmlns:a16="http://schemas.microsoft.com/office/drawing/2014/main" id="{32F0299B-0F38-406B-A191-8F5AAB556684}"/>
+                <a16:creationId xmlns:a16="http://schemas.microsoft.com/office/drawing/2014/main" id="{39E0411D-81A8-44B9-820F-2DAB7B0CC9B0}"/>
               </a:ext>
             </a:extLst>
           </p:cNvPr>
@@ -13028,7 +13157,7 @@
           <p:cNvPr id="45" name="">
             <a:extLst xmlns:a="http://schemas.openxmlformats.org/drawingml/2006/main">
               <a:ext uri="{FF2B5EF4-FFF2-40B4-BE49-F238E27FC236}">
-                <a16:creationId xmlns:a16="http://schemas.microsoft.com/office/drawing/2014/main" id="{E178443C-5931-431F-AAF7-E02E5F004A0F}"/>
+                <a16:creationId xmlns:a16="http://schemas.microsoft.com/office/drawing/2014/main" id="{F83BB7AA-8A36-4F20-A207-8CB3B5AD84B8}"/>
               </a:ext>
             </a:extLst>
           </p:cNvPr>
@@ -13061,7 +13190,7 @@
           <p:cNvPr id="46" name="">
             <a:extLst xmlns:a="http://schemas.openxmlformats.org/drawingml/2006/main">
               <a:ext uri="{FF2B5EF4-FFF2-40B4-BE49-F238E27FC236}">
-                <a16:creationId xmlns:a16="http://schemas.microsoft.com/office/drawing/2014/main" id="{7752B7A3-C279-438F-9B81-574A122B3399}"/>
+                <a16:creationId xmlns:a16="http://schemas.microsoft.com/office/drawing/2014/main" id="{69F7ED05-A3FF-4664-AFFE-CAE7D4926A98}"/>
               </a:ext>
             </a:extLst>
           </p:cNvPr>
@@ -13125,7 +13254,7 @@
           <p:cNvPr id="47" name="">
             <a:extLst xmlns:a="http://schemas.openxmlformats.org/drawingml/2006/main">
               <a:ext uri="{FF2B5EF4-FFF2-40B4-BE49-F238E27FC236}">
-                <a16:creationId xmlns:a16="http://schemas.microsoft.com/office/drawing/2014/main" id="{1BE6BE0D-4755-4540-80D4-1E1CD50E553C}"/>
+                <a16:creationId xmlns:a16="http://schemas.microsoft.com/office/drawing/2014/main" id="{CDBF1014-6D76-4826-B4B0-6384189FAA6F}"/>
               </a:ext>
             </a:extLst>
           </p:cNvPr>
@@ -13162,7 +13291,7 @@
           <p:cNvPr id="48" name="">
             <a:extLst xmlns:a="http://schemas.openxmlformats.org/drawingml/2006/main">
               <a:ext uri="{FF2B5EF4-FFF2-40B4-BE49-F238E27FC236}">
-                <a16:creationId xmlns:a16="http://schemas.microsoft.com/office/drawing/2014/main" id="{579A18EC-7A05-47F4-8178-6DB91FBFAA55}"/>
+                <a16:creationId xmlns:a16="http://schemas.microsoft.com/office/drawing/2014/main" id="{DBED0680-E9C7-4D1F-B797-64859E55A400}"/>
               </a:ext>
             </a:extLst>
           </p:cNvPr>
@@ -13226,7 +13355,7 @@
           <p:cNvPr id="49" name="">
             <a:extLst xmlns:a="http://schemas.openxmlformats.org/drawingml/2006/main">
               <a:ext uri="{FF2B5EF4-FFF2-40B4-BE49-F238E27FC236}">
-                <a16:creationId xmlns:a16="http://schemas.microsoft.com/office/drawing/2014/main" id="{1D65C14C-6DBC-43A2-A3D1-E57B5C311C98}"/>
+                <a16:creationId xmlns:a16="http://schemas.microsoft.com/office/drawing/2014/main" id="{2726BAAA-D6E3-43E3-961A-A6E570BA0ACC}"/>
               </a:ext>
             </a:extLst>
           </p:cNvPr>
@@ -13263,7 +13392,7 @@
           <p:cNvPr id="50" name="">
             <a:extLst xmlns:a="http://schemas.openxmlformats.org/drawingml/2006/main">
               <a:ext uri="{FF2B5EF4-FFF2-40B4-BE49-F238E27FC236}">
-                <a16:creationId xmlns:a16="http://schemas.microsoft.com/office/drawing/2014/main" id="{34CC70C8-047B-44EB-8A56-10826F5AEED3}"/>
+                <a16:creationId xmlns:a16="http://schemas.microsoft.com/office/drawing/2014/main" id="{EBAE20BD-EB8C-4EF9-B947-AA18BC6E88E4}"/>
               </a:ext>
             </a:extLst>
           </p:cNvPr>
@@ -13327,7 +13456,7 @@
           <p:cNvPr id="51" name="">
             <a:extLst xmlns:a="http://schemas.openxmlformats.org/drawingml/2006/main">
               <a:ext uri="{FF2B5EF4-FFF2-40B4-BE49-F238E27FC236}">
-                <a16:creationId xmlns:a16="http://schemas.microsoft.com/office/drawing/2014/main" id="{C500C9B5-E283-4833-83B7-38C1F8EF7E0D}"/>
+                <a16:creationId xmlns:a16="http://schemas.microsoft.com/office/drawing/2014/main" id="{9365D0BA-BC72-445E-9B6B-0AEF651E6669}"/>
               </a:ext>
             </a:extLst>
           </p:cNvPr>
@@ -13364,7 +13493,7 @@
           <p:cNvPr id="52" name="">
             <a:extLst xmlns:a="http://schemas.openxmlformats.org/drawingml/2006/main">
               <a:ext uri="{FF2B5EF4-FFF2-40B4-BE49-F238E27FC236}">
-                <a16:creationId xmlns:a16="http://schemas.microsoft.com/office/drawing/2014/main" id="{CFD719D2-93A1-4DAA-A376-F6E4FE149103}"/>
+                <a16:creationId xmlns:a16="http://schemas.microsoft.com/office/drawing/2014/main" id="{067474F2-E2B5-4472-B2E4-544BA3D53548}"/>
               </a:ext>
             </a:extLst>
           </p:cNvPr>
@@ -13428,7 +13557,7 @@
           <p:cNvPr id="53" name="">
             <a:extLst xmlns:a="http://schemas.openxmlformats.org/drawingml/2006/main">
               <a:ext uri="{FF2B5EF4-FFF2-40B4-BE49-F238E27FC236}">
-                <a16:creationId xmlns:a16="http://schemas.microsoft.com/office/drawing/2014/main" id="{C422DCBE-65F0-44FF-9464-36973BCA3F7E}"/>
+                <a16:creationId xmlns:a16="http://schemas.microsoft.com/office/drawing/2014/main" id="{331F12BA-10D8-43BC-8D44-D83E12EF9AFA}"/>
               </a:ext>
             </a:extLst>
           </p:cNvPr>
@@ -13463,7 +13592,7 @@
           <p:cNvPr id="54" name="">
             <a:extLst xmlns:a="http://schemas.openxmlformats.org/drawingml/2006/main">
               <a:ext uri="{FF2B5EF4-FFF2-40B4-BE49-F238E27FC236}">
-                <a16:creationId xmlns:a16="http://schemas.microsoft.com/office/drawing/2014/main" id="{175E4C6B-47FA-473E-A667-FF3AE1958F8E}"/>
+                <a16:creationId xmlns:a16="http://schemas.microsoft.com/office/drawing/2014/main" id="{EE830157-80C8-4D0A-83AF-21BF0796EACC}"/>
               </a:ext>
             </a:extLst>
           </p:cNvPr>
@@ -13527,7 +13656,7 @@
           <p:cNvPr id="55" name="">
             <a:extLst xmlns:a="http://schemas.openxmlformats.org/drawingml/2006/main">
               <a:ext uri="{FF2B5EF4-FFF2-40B4-BE49-F238E27FC236}">
-                <a16:creationId xmlns:a16="http://schemas.microsoft.com/office/drawing/2014/main" id="{CC252599-9000-4F95-B1B7-00B557422073}"/>
+                <a16:creationId xmlns:a16="http://schemas.microsoft.com/office/drawing/2014/main" id="{3F8D2BBC-9C4B-40DE-A20B-8B3A1DD4519C}"/>
               </a:ext>
             </a:extLst>
           </p:cNvPr>
@@ -13591,7 +13720,7 @@
           <p:cNvPr id="56" name="">
             <a:extLst xmlns:a="http://schemas.openxmlformats.org/drawingml/2006/main">
               <a:ext uri="{FF2B5EF4-FFF2-40B4-BE49-F238E27FC236}">
-                <a16:creationId xmlns:a16="http://schemas.microsoft.com/office/drawing/2014/main" id="{DEC5E822-ECD1-4B2C-A24C-332F3F3FB143}"/>
+                <a16:creationId xmlns:a16="http://schemas.microsoft.com/office/drawing/2014/main" id="{1573054B-290F-4CD1-B866-08AD936C7742}"/>
               </a:ext>
             </a:extLst>
           </p:cNvPr>
@@ -13653,7 +13782,7 @@
     </p:spTree>
     <p:extLst>
       <p:ext uri="{BB962C8B-B14F-4D97-AF65-F5344CB8AC3E}">
-        <p14:creationId xmlns:p14="http://schemas.microsoft.com/office/powerpoint/2010/main" val="1293831263"/>
+        <p14:creationId xmlns:p14="http://schemas.microsoft.com/office/powerpoint/2010/main" val="909636595"/>
       </p:ext>
     </p:extLst>
   </p:cSld>
@@ -13677,7 +13806,7 @@
           <p:cNvPr id="1" name="">
             <a:extLst xmlns:a="http://schemas.openxmlformats.org/drawingml/2006/main">
               <a:ext uri="{FF2B5EF4-FFF2-40B4-BE49-F238E27FC236}">
-                <a16:creationId xmlns:a16="http://schemas.microsoft.com/office/drawing/2014/main" id="{B10892B9-9164-4C08-9DEB-2AA3426BFCC8}"/>
+                <a16:creationId xmlns:a16="http://schemas.microsoft.com/office/drawing/2014/main" id="{F7651055-30DF-46E7-96D3-1092A420BF6A}"/>
               </a:ext>
             </a:extLst>
           </p:cNvPr>
@@ -13712,7 +13841,7 @@
           <p:cNvPr id="2" name="">
             <a:extLst xmlns:a="http://schemas.openxmlformats.org/drawingml/2006/main">
               <a:ext uri="{FF2B5EF4-FFF2-40B4-BE49-F238E27FC236}">
-                <a16:creationId xmlns:a16="http://schemas.microsoft.com/office/drawing/2014/main" id="{BF3F1898-C313-470C-AC2C-B4AC631ADF46}"/>
+                <a16:creationId xmlns:a16="http://schemas.microsoft.com/office/drawing/2014/main" id="{359B370D-D109-452F-8B0F-115C8CE73BD4}"/>
               </a:ext>
             </a:extLst>
           </p:cNvPr>
@@ -13747,7 +13876,7 @@
           <p:cNvPr id="3" name="">
             <a:extLst xmlns:a="http://schemas.openxmlformats.org/drawingml/2006/main">
               <a:ext uri="{FF2B5EF4-FFF2-40B4-BE49-F238E27FC236}">
-                <a16:creationId xmlns:a16="http://schemas.microsoft.com/office/drawing/2014/main" id="{222E5F3D-3313-4062-AE94-4A63AD82F4DD}"/>
+                <a16:creationId xmlns:a16="http://schemas.microsoft.com/office/drawing/2014/main" id="{8D350CC4-27EC-4AA2-A10E-BA71207B41AA}"/>
               </a:ext>
             </a:extLst>
           </p:cNvPr>
@@ -13782,7 +13911,7 @@
           <p:cNvPr id="4" name="">
             <a:extLst xmlns:a="http://schemas.openxmlformats.org/drawingml/2006/main">
               <a:ext uri="{FF2B5EF4-FFF2-40B4-BE49-F238E27FC236}">
-                <a16:creationId xmlns:a16="http://schemas.microsoft.com/office/drawing/2014/main" id="{E3E6FE22-A40D-45C6-95EC-1721BCCA3ADD}"/>
+                <a16:creationId xmlns:a16="http://schemas.microsoft.com/office/drawing/2014/main" id="{D9752818-A8A1-4443-9530-51AC2B80AD4E}"/>
               </a:ext>
             </a:extLst>
           </p:cNvPr>
@@ -13817,7 +13946,7 @@
           <p:cNvPr id="5" name="">
             <a:extLst xmlns:a="http://schemas.openxmlformats.org/drawingml/2006/main">
               <a:ext uri="{FF2B5EF4-FFF2-40B4-BE49-F238E27FC236}">
-                <a16:creationId xmlns:a16="http://schemas.microsoft.com/office/drawing/2014/main" id="{0FEF6863-1729-4CE0-99B2-28A387B49127}"/>
+                <a16:creationId xmlns:a16="http://schemas.microsoft.com/office/drawing/2014/main" id="{170B5C96-29D9-42B7-B083-6B372F7DB455}"/>
               </a:ext>
             </a:extLst>
           </p:cNvPr>
@@ -13852,7 +13981,7 @@
           <p:cNvPr id="6" name="">
             <a:extLst xmlns:a="http://schemas.openxmlformats.org/drawingml/2006/main">
               <a:ext uri="{FF2B5EF4-FFF2-40B4-BE49-F238E27FC236}">
-                <a16:creationId xmlns:a16="http://schemas.microsoft.com/office/drawing/2014/main" id="{D7331F25-E7CD-44DE-BE9C-3C16BB102D99}"/>
+                <a16:creationId xmlns:a16="http://schemas.microsoft.com/office/drawing/2014/main" id="{8F87CD84-7AC1-4FC6-9040-9FA392774BA7}"/>
               </a:ext>
             </a:extLst>
           </p:cNvPr>
@@ -13906,7 +14035,7 @@
                 <a:ea typeface="Aptos Mono"/>
                 <a:cs typeface="Aptos Mono"/>
               </a:rPr>
-              <a:t>WHY GEMINI</a:t>
+              <a:t>WHY GOOGLE CLOUD + GEMINI</a:t>
             </a:r>
           </a:p>
         </p:txBody>
@@ -13916,7 +14045,7 @@
           <p:cNvPr id="7" name="">
             <a:extLst xmlns:a="http://schemas.openxmlformats.org/drawingml/2006/main">
               <a:ext uri="{FF2B5EF4-FFF2-40B4-BE49-F238E27FC236}">
-                <a16:creationId xmlns:a16="http://schemas.microsoft.com/office/drawing/2014/main" id="{1E7921AD-950A-4A8B-85C1-1593B5C39433}"/>
+                <a16:creationId xmlns:a16="http://schemas.microsoft.com/office/drawing/2014/main" id="{DC30ADEB-4C19-4ED5-B6C9-28CBF94DF115}"/>
               </a:ext>
             </a:extLst>
           </p:cNvPr>
@@ -13970,7 +14099,7 @@
                 <a:ea typeface="Aptos Display"/>
                 <a:cs typeface="Aptos Display"/>
               </a:rPr>
-              <a:t>Gemini is the perception and reasoning layer behind the ambient agent.</a:t>
+              <a:t>Google Cloud is visible in the demo, not only in the stack.</a:t>
             </a:r>
           </a:p>
         </p:txBody>
@@ -13980,7 +14109,7 @@
           <p:cNvPr id="8" name="">
             <a:extLst xmlns:a="http://schemas.openxmlformats.org/drawingml/2006/main">
               <a:ext uri="{FF2B5EF4-FFF2-40B4-BE49-F238E27FC236}">
-                <a16:creationId xmlns:a16="http://schemas.microsoft.com/office/drawing/2014/main" id="{A91C14F5-1596-4663-9910-3338E9DEB0B0}"/>
+                <a16:creationId xmlns:a16="http://schemas.microsoft.com/office/drawing/2014/main" id="{22AAA343-FADD-4A22-A394-38744FEE7AFB}"/>
               </a:ext>
             </a:extLst>
           </p:cNvPr>
@@ -14034,7 +14163,7 @@
                 <a:ea typeface="Aptos"/>
                 <a:cs typeface="Aptos"/>
               </a:rPr>
-              <a:t>Not a chatbot. One coherent stack turns weak daily signals into structured, respectful, human-actionable support.</a:t>
+              <a:t>The event has a hard rule: Google Cloud products must be integrated. SilverLink makes that concrete through Gemini and cloud voice.</a:t>
             </a:r>
           </a:p>
         </p:txBody>
@@ -14044,7 +14173,7 @@
           <p:cNvPr id="9" name="">
             <a:extLst xmlns:a="http://schemas.openxmlformats.org/drawingml/2006/main">
               <a:ext uri="{FF2B5EF4-FFF2-40B4-BE49-F238E27FC236}">
-                <a16:creationId xmlns:a16="http://schemas.microsoft.com/office/drawing/2014/main" id="{40FCE788-EFC7-459A-8D28-9C3823EF826E}"/>
+                <a16:creationId xmlns:a16="http://schemas.microsoft.com/office/drawing/2014/main" id="{DEF49632-66A6-44B0-A37D-EC886440B3B9}"/>
               </a:ext>
             </a:extLst>
           </p:cNvPr>
@@ -14077,7 +14206,7 @@
           <p:cNvPr id="10" name="">
             <a:extLst xmlns:a="http://schemas.openxmlformats.org/drawingml/2006/main">
               <a:ext uri="{FF2B5EF4-FFF2-40B4-BE49-F238E27FC236}">
-                <a16:creationId xmlns:a16="http://schemas.microsoft.com/office/drawing/2014/main" id="{5E41C1D8-358C-4138-8664-CEF14618BD08}"/>
+                <a16:creationId xmlns:a16="http://schemas.microsoft.com/office/drawing/2014/main" id="{44C72EDC-3843-46B2-B302-825867402237}"/>
               </a:ext>
             </a:extLst>
           </p:cNvPr>
@@ -14131,7 +14260,7 @@
                 <a:ea typeface="Aptos"/>
                 <a:cs typeface="Aptos"/>
               </a:rPr>
-              <a:t>Vision</a:t>
+              <a:t>Gemini Vision</a:t>
             </a:r>
           </a:p>
         </p:txBody>
@@ -14141,7 +14270,7 @@
           <p:cNvPr id="11" name="">
             <a:extLst xmlns:a="http://schemas.openxmlformats.org/drawingml/2006/main">
               <a:ext uri="{FF2B5EF4-FFF2-40B4-BE49-F238E27FC236}">
-                <a16:creationId xmlns:a16="http://schemas.microsoft.com/office/drawing/2014/main" id="{CBF1DC4C-9BEE-48C6-9A05-324407DEA8A1}"/>
+                <a16:creationId xmlns:a16="http://schemas.microsoft.com/office/drawing/2014/main" id="{CBB705AD-6C04-4473-A1D0-61F08AB0700C}"/>
               </a:ext>
             </a:extLst>
           </p:cNvPr>
@@ -14195,7 +14324,7 @@
                 <a:ea typeface="Aptos"/>
                 <a:cs typeface="Aptos"/>
               </a:rPr>
-              <a:t>medicine box / document understanding</a:t>
+              <a:t>medicine / document understanding</a:t>
             </a:r>
           </a:p>
         </p:txBody>
@@ -14205,7 +14334,7 @@
           <p:cNvPr id="12" name="">
             <a:extLst xmlns:a="http://schemas.openxmlformats.org/drawingml/2006/main">
               <a:ext uri="{FF2B5EF4-FFF2-40B4-BE49-F238E27FC236}">
-                <a16:creationId xmlns:a16="http://schemas.microsoft.com/office/drawing/2014/main" id="{2D3335B5-3A65-42AA-AB0A-FED9E6784412}"/>
+                <a16:creationId xmlns:a16="http://schemas.microsoft.com/office/drawing/2014/main" id="{0ACE8DFF-5630-4CCC-8F84-49E23CF9DD7D}"/>
               </a:ext>
             </a:extLst>
           </p:cNvPr>
@@ -14238,7 +14367,7 @@
           <p:cNvPr id="13" name="">
             <a:extLst xmlns:a="http://schemas.openxmlformats.org/drawingml/2006/main">
               <a:ext uri="{FF2B5EF4-FFF2-40B4-BE49-F238E27FC236}">
-                <a16:creationId xmlns:a16="http://schemas.microsoft.com/office/drawing/2014/main" id="{C464DCC3-05F9-4CE9-9FC7-02CEAAF53BE3}"/>
+                <a16:creationId xmlns:a16="http://schemas.microsoft.com/office/drawing/2014/main" id="{36598378-4F4E-4B2F-B7F9-8AC8E0DB832A}"/>
               </a:ext>
             </a:extLst>
           </p:cNvPr>
@@ -14292,7 +14421,7 @@
                 <a:ea typeface="Aptos"/>
                 <a:cs typeface="Aptos"/>
               </a:rPr>
-              <a:t>Live Voice</a:t>
+              <a:t>Gemini Reasoning</a:t>
             </a:r>
           </a:p>
         </p:txBody>
@@ -14302,7 +14431,7 @@
           <p:cNvPr id="14" name="">
             <a:extLst xmlns:a="http://schemas.openxmlformats.org/drawingml/2006/main">
               <a:ext uri="{FF2B5EF4-FFF2-40B4-BE49-F238E27FC236}">
-                <a16:creationId xmlns:a16="http://schemas.microsoft.com/office/drawing/2014/main" id="{5B7B3E11-C3E4-470A-94F0-10769BCA42E4}"/>
+                <a16:creationId xmlns:a16="http://schemas.microsoft.com/office/drawing/2014/main" id="{CB3BAEA0-7164-4651-AB36-D7D425000AF1}"/>
               </a:ext>
             </a:extLst>
           </p:cNvPr>
@@ -14356,7 +14485,7 @@
                 <a:ea typeface="Aptos"/>
                 <a:cs typeface="Aptos"/>
               </a:rPr>
-              <a:t>low-latency respectful conversation</a:t>
+              <a:t>Observe, reason, decide loop</a:t>
             </a:r>
           </a:p>
         </p:txBody>
@@ -14366,7 +14495,7 @@
           <p:cNvPr id="15" name="">
             <a:extLst xmlns:a="http://schemas.openxmlformats.org/drawingml/2006/main">
               <a:ext uri="{FF2B5EF4-FFF2-40B4-BE49-F238E27FC236}">
-                <a16:creationId xmlns:a16="http://schemas.microsoft.com/office/drawing/2014/main" id="{FD9C1F5A-8CD4-4452-9F73-264ACC4615BD}"/>
+                <a16:creationId xmlns:a16="http://schemas.microsoft.com/office/drawing/2014/main" id="{A0F5D010-3FB7-4916-AB00-341B0A544DB3}"/>
               </a:ext>
             </a:extLst>
           </p:cNvPr>
@@ -14399,7 +14528,7 @@
           <p:cNvPr id="16" name="">
             <a:extLst xmlns:a="http://schemas.openxmlformats.org/drawingml/2006/main">
               <a:ext uri="{FF2B5EF4-FFF2-40B4-BE49-F238E27FC236}">
-                <a16:creationId xmlns:a16="http://schemas.microsoft.com/office/drawing/2014/main" id="{A7548F78-13DC-489F-BE3B-6A92170F181E}"/>
+                <a16:creationId xmlns:a16="http://schemas.microsoft.com/office/drawing/2014/main" id="{064C30E8-A4CE-4F2D-B4B8-E0D8330B6738}"/>
               </a:ext>
             </a:extLst>
           </p:cNvPr>
@@ -14453,7 +14582,7 @@
                 <a:ea typeface="Aptos"/>
                 <a:cs typeface="Aptos"/>
               </a:rPr>
-              <a:t>Function Calling</a:t>
+              <a:t>Structured Output</a:t>
             </a:r>
           </a:p>
         </p:txBody>
@@ -14463,7 +14592,7 @@
           <p:cNvPr id="17" name="">
             <a:extLst xmlns:a="http://schemas.openxmlformats.org/drawingml/2006/main">
               <a:ext uri="{FF2B5EF4-FFF2-40B4-BE49-F238E27FC236}">
-                <a16:creationId xmlns:a16="http://schemas.microsoft.com/office/drawing/2014/main" id="{CBD8FF88-FA97-402C-BB9A-484565CBB114}"/>
+                <a16:creationId xmlns:a16="http://schemas.microsoft.com/office/drawing/2014/main" id="{3A0824F8-DE0D-48BB-9493-E2034A901862}"/>
               </a:ext>
             </a:extLst>
           </p:cNvPr>
@@ -14517,7 +14646,7 @@
                 <a:ea typeface="Aptos"/>
                 <a:cs typeface="Aptos"/>
               </a:rPr>
-              <a:t>record, notify, hand off</a:t>
+              <a:t>cards and handoff memos</a:t>
             </a:r>
           </a:p>
         </p:txBody>
@@ -14527,7 +14656,7 @@
           <p:cNvPr id="18" name="">
             <a:extLst xmlns:a="http://schemas.openxmlformats.org/drawingml/2006/main">
               <a:ext uri="{FF2B5EF4-FFF2-40B4-BE49-F238E27FC236}">
-                <a16:creationId xmlns:a16="http://schemas.microsoft.com/office/drawing/2014/main" id="{79D0BC32-5E49-42F9-8AB3-16423E613991}"/>
+                <a16:creationId xmlns:a16="http://schemas.microsoft.com/office/drawing/2014/main" id="{A86DD74E-0643-4828-9408-0D411E5C4D65}"/>
               </a:ext>
             </a:extLst>
           </p:cNvPr>
@@ -14560,7 +14689,7 @@
           <p:cNvPr id="19" name="">
             <a:extLst xmlns:a="http://schemas.openxmlformats.org/drawingml/2006/main">
               <a:ext uri="{FF2B5EF4-FFF2-40B4-BE49-F238E27FC236}">
-                <a16:creationId xmlns:a16="http://schemas.microsoft.com/office/drawing/2014/main" id="{A9457D38-9D29-476A-BBAC-65502FDC9C73}"/>
+                <a16:creationId xmlns:a16="http://schemas.microsoft.com/office/drawing/2014/main" id="{32DD4ABC-BD28-4E63-A2B9-18F0A540E9A7}"/>
               </a:ext>
             </a:extLst>
           </p:cNvPr>
@@ -14614,7 +14743,7 @@
                 <a:ea typeface="Aptos"/>
                 <a:cs typeface="Aptos"/>
               </a:rPr>
-              <a:t>Context Memory</a:t>
+              <a:t>Cloud TTS</a:t>
             </a:r>
           </a:p>
         </p:txBody>
@@ -14624,7 +14753,7 @@
           <p:cNvPr id="20" name="">
             <a:extLst xmlns:a="http://schemas.openxmlformats.org/drawingml/2006/main">
               <a:ext uri="{FF2B5EF4-FFF2-40B4-BE49-F238E27FC236}">
-                <a16:creationId xmlns:a16="http://schemas.microsoft.com/office/drawing/2014/main" id="{D16B3A5F-23C4-42B2-843B-CD690D79C478}"/>
+                <a16:creationId xmlns:a16="http://schemas.microsoft.com/office/drawing/2014/main" id="{988D5481-E4FF-473A-947D-B34BF66C459C}"/>
               </a:ext>
             </a:extLst>
           </p:cNvPr>
@@ -14678,7 +14807,7 @@
                 <a:ea typeface="Aptos"/>
                 <a:cs typeface="Aptos"/>
               </a:rPr>
-              <a:t>yesterday's dizziness, last check</a:t>
+              <a:t>Chirp 3 HD Japanese voice</a:t>
             </a:r>
           </a:p>
         </p:txBody>
@@ -14688,7 +14817,7 @@
           <p:cNvPr id="21" name="">
             <a:extLst xmlns:a="http://schemas.openxmlformats.org/drawingml/2006/main">
               <a:ext uri="{FF2B5EF4-FFF2-40B4-BE49-F238E27FC236}">
-                <a16:creationId xmlns:a16="http://schemas.microsoft.com/office/drawing/2014/main" id="{34811B06-C4D4-406B-8BD0-9BD1963CBD4F}"/>
+                <a16:creationId xmlns:a16="http://schemas.microsoft.com/office/drawing/2014/main" id="{8BD19ABF-DBFF-4915-9C2C-9FCF30CBE93E}"/>
               </a:ext>
             </a:extLst>
           </p:cNvPr>
@@ -14721,7 +14850,7 @@
           <p:cNvPr id="22" name="">
             <a:extLst xmlns:a="http://schemas.openxmlformats.org/drawingml/2006/main">
               <a:ext uri="{FF2B5EF4-FFF2-40B4-BE49-F238E27FC236}">
-                <a16:creationId xmlns:a16="http://schemas.microsoft.com/office/drawing/2014/main" id="{7C995076-8303-429A-BF68-268B9EEB4736}"/>
+                <a16:creationId xmlns:a16="http://schemas.microsoft.com/office/drawing/2014/main" id="{BAA0BCA0-F116-48FA-BED2-57B42B06A028}"/>
               </a:ext>
             </a:extLst>
           </p:cNvPr>
@@ -14775,7 +14904,7 @@
                 <a:ea typeface="Aptos"/>
                 <a:cs typeface="Aptos"/>
               </a:rPr>
-              <a:t>Structured Output</a:t>
+              <a:t>Cloud Run Next</a:t>
             </a:r>
           </a:p>
         </p:txBody>
@@ -14785,7 +14914,7 @@
           <p:cNvPr id="23" name="">
             <a:extLst xmlns:a="http://schemas.openxmlformats.org/drawingml/2006/main">
               <a:ext uri="{FF2B5EF4-FFF2-40B4-BE49-F238E27FC236}">
-                <a16:creationId xmlns:a16="http://schemas.microsoft.com/office/drawing/2014/main" id="{66902C2A-946B-4ED4-BB8F-7757A8F8938A}"/>
+                <a16:creationId xmlns:a16="http://schemas.microsoft.com/office/drawing/2014/main" id="{82286D80-C2E6-462A-9E65-858460513FC5}"/>
               </a:ext>
             </a:extLst>
           </p:cNvPr>
@@ -14839,7 +14968,7 @@
                 <a:ea typeface="Aptos"/>
                 <a:cs typeface="Aptos"/>
               </a:rPr>
-              <a:t>cards and summaries stay stable</a:t>
+              <a:t>review build and Live tokens</a:t>
             </a:r>
           </a:p>
         </p:txBody>
@@ -14849,7 +14978,7 @@
           <p:cNvPr id="24" name="">
             <a:extLst xmlns:a="http://schemas.openxmlformats.org/drawingml/2006/main">
               <a:ext uri="{FF2B5EF4-FFF2-40B4-BE49-F238E27FC236}">
-                <a16:creationId xmlns:a16="http://schemas.microsoft.com/office/drawing/2014/main" id="{B4A9AE97-C726-4213-BF88-0E00DFAEC865}"/>
+                <a16:creationId xmlns:a16="http://schemas.microsoft.com/office/drawing/2014/main" id="{51D122A8-533A-4899-961C-1D3C88954A89}"/>
               </a:ext>
             </a:extLst>
           </p:cNvPr>
@@ -14886,7 +15015,7 @@
           <p:cNvPr id="25" name="">
             <a:extLst xmlns:a="http://schemas.openxmlformats.org/drawingml/2006/main">
               <a:ext uri="{FF2B5EF4-FFF2-40B4-BE49-F238E27FC236}">
-                <a16:creationId xmlns:a16="http://schemas.microsoft.com/office/drawing/2014/main" id="{E1269901-1828-4BC9-930A-49DFF10EAA6C}"/>
+                <a16:creationId xmlns:a16="http://schemas.microsoft.com/office/drawing/2014/main" id="{617470C2-B045-4FB5-946C-DAEF9583BA6B}"/>
               </a:ext>
             </a:extLst>
           </p:cNvPr>
@@ -14921,7 +15050,7 @@
           <p:cNvPr id="26" name="">
             <a:extLst xmlns:a="http://schemas.openxmlformats.org/drawingml/2006/main">
               <a:ext uri="{FF2B5EF4-FFF2-40B4-BE49-F238E27FC236}">
-                <a16:creationId xmlns:a16="http://schemas.microsoft.com/office/drawing/2014/main" id="{D645C029-EB9C-4B7F-B707-25524165A42E}"/>
+                <a16:creationId xmlns:a16="http://schemas.microsoft.com/office/drawing/2014/main" id="{0A8115D0-C7EE-4900-934C-444DA2D1B4C4}"/>
               </a:ext>
             </a:extLst>
           </p:cNvPr>
@@ -14958,7 +15087,7 @@
           <p:cNvPr id="27" name="">
             <a:extLst xmlns:a="http://schemas.openxmlformats.org/drawingml/2006/main">
               <a:ext uri="{FF2B5EF4-FFF2-40B4-BE49-F238E27FC236}">
-                <a16:creationId xmlns:a16="http://schemas.microsoft.com/office/drawing/2014/main" id="{2B9E8195-5FF1-43CA-B736-FE77F52DC00E}"/>
+                <a16:creationId xmlns:a16="http://schemas.microsoft.com/office/drawing/2014/main" id="{5FD2336B-FAB7-42AF-B904-DCF31C4FCE3F}"/>
               </a:ext>
             </a:extLst>
           </p:cNvPr>
@@ -14970,7 +15099,7 @@
         <p:spPr>
           <a:xfrm xmlns:a="http://schemas.openxmlformats.org/drawingml/2006/main">
             <a:off x="723900" y="5886450"/>
-            <a:ext cx="3600450" cy="266700"/>
+            <a:ext cx="4114800" cy="266700"/>
           </a:xfrm>
           <a:prstGeom xmlns:a="http://schemas.openxmlformats.org/drawingml/2006/main" prst="rect">
             <a:avLst/>
@@ -14993,7 +15122,7 @@
           <p:cNvPr id="28" name="">
             <a:extLst xmlns:a="http://schemas.openxmlformats.org/drawingml/2006/main">
               <a:ext uri="{FF2B5EF4-FFF2-40B4-BE49-F238E27FC236}">
-                <a16:creationId xmlns:a16="http://schemas.microsoft.com/office/drawing/2014/main" id="{CA29FA61-2943-42F3-AF65-4B21946DAAAC}"/>
+                <a16:creationId xmlns:a16="http://schemas.microsoft.com/office/drawing/2014/main" id="{13D09091-28D7-4C02-B965-51EF1510CC17}"/>
               </a:ext>
             </a:extLst>
           </p:cNvPr>
@@ -15005,7 +15134,7 @@
         <p:spPr>
           <a:xfrm xmlns:a="http://schemas.openxmlformats.org/drawingml/2006/main">
             <a:off x="819150" y="5934075"/>
-            <a:ext cx="3409950" cy="171450"/>
+            <a:ext cx="3924300" cy="171450"/>
           </a:xfrm>
           <a:prstGeom xmlns:a="http://schemas.openxmlformats.org/drawingml/2006/main" prst="rect">
             <a:avLst/>
@@ -15047,7 +15176,7 @@
                 <a:ea typeface="Aptos Mono"/>
                 <a:cs typeface="Aptos Mono"/>
               </a:rPr>
-              <a:t>Gemini as ambient intelligence, not chat UI</a:t>
+              <a:t>Prize rule satisfied by visible Cloud integration</a:t>
             </a:r>
           </a:p>
         </p:txBody>
@@ -15057,7 +15186,7 @@
           <p:cNvPr id="29" name="">
             <a:extLst xmlns:a="http://schemas.openxmlformats.org/drawingml/2006/main">
               <a:ext uri="{FF2B5EF4-FFF2-40B4-BE49-F238E27FC236}">
-                <a16:creationId xmlns:a16="http://schemas.microsoft.com/office/drawing/2014/main" id="{DBBF2904-C343-4EB0-8485-FB19AAAADE39}"/>
+                <a16:creationId xmlns:a16="http://schemas.microsoft.com/office/drawing/2014/main" id="{88796B3A-0D0C-4DE4-9B1B-C38C6DEBDFD2}"/>
               </a:ext>
             </a:extLst>
           </p:cNvPr>
@@ -15121,7 +15250,7 @@
           <p:cNvPr id="30" name="">
             <a:extLst xmlns:a="http://schemas.openxmlformats.org/drawingml/2006/main">
               <a:ext uri="{FF2B5EF4-FFF2-40B4-BE49-F238E27FC236}">
-                <a16:creationId xmlns:a16="http://schemas.microsoft.com/office/drawing/2014/main" id="{947C5793-15D2-4206-908F-C6071588EFD1}"/>
+                <a16:creationId xmlns:a16="http://schemas.microsoft.com/office/drawing/2014/main" id="{E94E5709-AF0A-4F0E-B23C-160AC77997F0}"/>
               </a:ext>
             </a:extLst>
           </p:cNvPr>
@@ -15183,7 +15312,7 @@
     </p:spTree>
     <p:extLst>
       <p:ext uri="{BB962C8B-B14F-4D97-AF65-F5344CB8AC3E}">
-        <p14:creationId xmlns:p14="http://schemas.microsoft.com/office/powerpoint/2010/main" val="744542460"/>
+        <p14:creationId xmlns:p14="http://schemas.microsoft.com/office/powerpoint/2010/main" val="1203353346"/>
       </p:ext>
     </p:extLst>
   </p:cSld>
@@ -15207,7 +15336,7 @@
           <p:cNvPr id="1" name="">
             <a:extLst xmlns:a="http://schemas.openxmlformats.org/drawingml/2006/main">
               <a:ext uri="{FF2B5EF4-FFF2-40B4-BE49-F238E27FC236}">
-                <a16:creationId xmlns:a16="http://schemas.microsoft.com/office/drawing/2014/main" id="{EA40B9C1-AEF1-4272-8221-59B24009BB96}"/>
+                <a16:creationId xmlns:a16="http://schemas.microsoft.com/office/drawing/2014/main" id="{62064ED4-E51A-45E3-B4D3-122AD92F30ED}"/>
               </a:ext>
             </a:extLst>
           </p:cNvPr>
@@ -15242,7 +15371,7 @@
           <p:cNvPr id="2" name="">
             <a:extLst xmlns:a="http://schemas.openxmlformats.org/drawingml/2006/main">
               <a:ext uri="{FF2B5EF4-FFF2-40B4-BE49-F238E27FC236}">
-                <a16:creationId xmlns:a16="http://schemas.microsoft.com/office/drawing/2014/main" id="{C1D6DFBD-6732-462F-92C2-ABECFB18FB16}"/>
+                <a16:creationId xmlns:a16="http://schemas.microsoft.com/office/drawing/2014/main" id="{1F127055-1F05-411C-93D5-63B7118065F6}"/>
               </a:ext>
             </a:extLst>
           </p:cNvPr>
@@ -15277,7 +15406,7 @@
           <p:cNvPr id="3" name="">
             <a:extLst xmlns:a="http://schemas.openxmlformats.org/drawingml/2006/main">
               <a:ext uri="{FF2B5EF4-FFF2-40B4-BE49-F238E27FC236}">
-                <a16:creationId xmlns:a16="http://schemas.microsoft.com/office/drawing/2014/main" id="{7B11EC24-9ED0-4E8E-9031-49E63E48AEF9}"/>
+                <a16:creationId xmlns:a16="http://schemas.microsoft.com/office/drawing/2014/main" id="{0C6C64DB-0DE5-47A0-9B40-189E705C45E6}"/>
               </a:ext>
             </a:extLst>
           </p:cNvPr>
@@ -15312,7 +15441,7 @@
           <p:cNvPr id="4" name="">
             <a:extLst xmlns:a="http://schemas.openxmlformats.org/drawingml/2006/main">
               <a:ext uri="{FF2B5EF4-FFF2-40B4-BE49-F238E27FC236}">
-                <a16:creationId xmlns:a16="http://schemas.microsoft.com/office/drawing/2014/main" id="{49C01E9E-0CCB-4833-8EB3-AC559A559EA4}"/>
+                <a16:creationId xmlns:a16="http://schemas.microsoft.com/office/drawing/2014/main" id="{5BA8B3D1-858D-44E0-A5CB-8ECD1F1A446E}"/>
               </a:ext>
             </a:extLst>
           </p:cNvPr>
@@ -15347,7 +15476,7 @@
           <p:cNvPr id="5" name="">
             <a:extLst xmlns:a="http://schemas.openxmlformats.org/drawingml/2006/main">
               <a:ext uri="{FF2B5EF4-FFF2-40B4-BE49-F238E27FC236}">
-                <a16:creationId xmlns:a16="http://schemas.microsoft.com/office/drawing/2014/main" id="{3AC07309-5F0D-4393-8099-62CEEEEE471B}"/>
+                <a16:creationId xmlns:a16="http://schemas.microsoft.com/office/drawing/2014/main" id="{431BC42F-3DFB-4D4D-8E80-3632C745B1BB}"/>
               </a:ext>
             </a:extLst>
           </p:cNvPr>
@@ -15382,7 +15511,7 @@
           <p:cNvPr id="6" name="">
             <a:extLst xmlns:a="http://schemas.openxmlformats.org/drawingml/2006/main">
               <a:ext uri="{FF2B5EF4-FFF2-40B4-BE49-F238E27FC236}">
-                <a16:creationId xmlns:a16="http://schemas.microsoft.com/office/drawing/2014/main" id="{5A967DDB-2248-44A9-BFAA-E8002629471D}"/>
+                <a16:creationId xmlns:a16="http://schemas.microsoft.com/office/drawing/2014/main" id="{6030B828-3DBA-42D1-9D64-A29636716104}"/>
               </a:ext>
             </a:extLst>
           </p:cNvPr>
@@ -15446,7 +15575,7 @@
           <p:cNvPr id="7" name="">
             <a:extLst xmlns:a="http://schemas.openxmlformats.org/drawingml/2006/main">
               <a:ext uri="{FF2B5EF4-FFF2-40B4-BE49-F238E27FC236}">
-                <a16:creationId xmlns:a16="http://schemas.microsoft.com/office/drawing/2014/main" id="{60B5F2E1-A7CA-4D06-BE5F-7EBF4ABEA1E0}"/>
+                <a16:creationId xmlns:a16="http://schemas.microsoft.com/office/drawing/2014/main" id="{461F9D2B-025F-4D03-BCFE-B1D3F480921E}"/>
               </a:ext>
             </a:extLst>
           </p:cNvPr>
@@ -15510,7 +15639,7 @@
           <p:cNvPr id="8" name="">
             <a:extLst xmlns:a="http://schemas.openxmlformats.org/drawingml/2006/main">
               <a:ext uri="{FF2B5EF4-FFF2-40B4-BE49-F238E27FC236}">
-                <a16:creationId xmlns:a16="http://schemas.microsoft.com/office/drawing/2014/main" id="{7B807C61-8681-4CA6-8EE3-9828986B8BEF}"/>
+                <a16:creationId xmlns:a16="http://schemas.microsoft.com/office/drawing/2014/main" id="{CD6435A8-8B4A-4A62-B107-3E16DA2F7C27}"/>
               </a:ext>
             </a:extLst>
           </p:cNvPr>
@@ -15574,7 +15703,7 @@
           <p:cNvPr id="9" name="">
             <a:extLst xmlns:a="http://schemas.openxmlformats.org/drawingml/2006/main">
               <a:ext uri="{FF2B5EF4-FFF2-40B4-BE49-F238E27FC236}">
-                <a16:creationId xmlns:a16="http://schemas.microsoft.com/office/drawing/2014/main" id="{8A40E561-A84F-4689-8CCE-109C87E96137}"/>
+                <a16:creationId xmlns:a16="http://schemas.microsoft.com/office/drawing/2014/main" id="{6B08396C-91E7-46FD-81F0-8242A9456E58}"/>
               </a:ext>
             </a:extLst>
           </p:cNvPr>
@@ -15607,7 +15736,7 @@
           <p:cNvPr id="10" name="">
             <a:extLst xmlns:a="http://schemas.openxmlformats.org/drawingml/2006/main">
               <a:ext uri="{FF2B5EF4-FFF2-40B4-BE49-F238E27FC236}">
-                <a16:creationId xmlns:a16="http://schemas.microsoft.com/office/drawing/2014/main" id="{FAFDAE31-11F5-4519-906E-DEFA1F2B4549}"/>
+                <a16:creationId xmlns:a16="http://schemas.microsoft.com/office/drawing/2014/main" id="{F6482A48-3735-4535-86E9-721DF36CBD01}"/>
               </a:ext>
             </a:extLst>
           </p:cNvPr>
@@ -15671,7 +15800,7 @@
           <p:cNvPr id="11" name="">
             <a:extLst xmlns:a="http://schemas.openxmlformats.org/drawingml/2006/main">
               <a:ext uri="{FF2B5EF4-FFF2-40B4-BE49-F238E27FC236}">
-                <a16:creationId xmlns:a16="http://schemas.microsoft.com/office/drawing/2014/main" id="{2F1737B2-1BA4-443E-B994-97A2F5E6D3FF}"/>
+                <a16:creationId xmlns:a16="http://schemas.microsoft.com/office/drawing/2014/main" id="{742C23FA-8ED7-4753-BEEC-599E2924CFAB}"/>
               </a:ext>
             </a:extLst>
           </p:cNvPr>
@@ -15735,7 +15864,7 @@
           <p:cNvPr id="12" name="">
             <a:extLst xmlns:a="http://schemas.openxmlformats.org/drawingml/2006/main">
               <a:ext uri="{FF2B5EF4-FFF2-40B4-BE49-F238E27FC236}">
-                <a16:creationId xmlns:a16="http://schemas.microsoft.com/office/drawing/2014/main" id="{DE35B791-DEB0-447F-A182-85615CE30499}"/>
+                <a16:creationId xmlns:a16="http://schemas.microsoft.com/office/drawing/2014/main" id="{CF487CB6-6BAC-432C-BE7C-787BE2970108}"/>
               </a:ext>
             </a:extLst>
           </p:cNvPr>
@@ -15768,7 +15897,7 @@
           <p:cNvPr id="13" name="">
             <a:extLst xmlns:a="http://schemas.openxmlformats.org/drawingml/2006/main">
               <a:ext uri="{FF2B5EF4-FFF2-40B4-BE49-F238E27FC236}">
-                <a16:creationId xmlns:a16="http://schemas.microsoft.com/office/drawing/2014/main" id="{07F8A56D-D29C-4F62-87CA-12C313B1E226}"/>
+                <a16:creationId xmlns:a16="http://schemas.microsoft.com/office/drawing/2014/main" id="{178718DB-BBD6-4C6B-91FD-0016940350F0}"/>
               </a:ext>
             </a:extLst>
           </p:cNvPr>
@@ -15832,7 +15961,7 @@
           <p:cNvPr id="14" name="">
             <a:extLst xmlns:a="http://schemas.openxmlformats.org/drawingml/2006/main">
               <a:ext uri="{FF2B5EF4-FFF2-40B4-BE49-F238E27FC236}">
-                <a16:creationId xmlns:a16="http://schemas.microsoft.com/office/drawing/2014/main" id="{9D27A9E5-ECF0-49FC-B93C-5241350AEF45}"/>
+                <a16:creationId xmlns:a16="http://schemas.microsoft.com/office/drawing/2014/main" id="{B2BE982D-387D-4617-B1EF-5F5146F9BAA6}"/>
               </a:ext>
             </a:extLst>
           </p:cNvPr>
@@ -15896,7 +16025,7 @@
           <p:cNvPr id="15" name="">
             <a:extLst xmlns:a="http://schemas.openxmlformats.org/drawingml/2006/main">
               <a:ext uri="{FF2B5EF4-FFF2-40B4-BE49-F238E27FC236}">
-                <a16:creationId xmlns:a16="http://schemas.microsoft.com/office/drawing/2014/main" id="{92EEA811-054D-401E-80C2-41DE58A6D2BB}"/>
+                <a16:creationId xmlns:a16="http://schemas.microsoft.com/office/drawing/2014/main" id="{901B079B-A177-46C6-8714-F029BAD2F524}"/>
               </a:ext>
             </a:extLst>
           </p:cNvPr>
@@ -15929,7 +16058,7 @@
           <p:cNvPr id="16" name="">
             <a:extLst xmlns:a="http://schemas.openxmlformats.org/drawingml/2006/main">
               <a:ext uri="{FF2B5EF4-FFF2-40B4-BE49-F238E27FC236}">
-                <a16:creationId xmlns:a16="http://schemas.microsoft.com/office/drawing/2014/main" id="{2A7C8010-0DEA-4F64-80D2-4683160631A9}"/>
+                <a16:creationId xmlns:a16="http://schemas.microsoft.com/office/drawing/2014/main" id="{706240C0-30B7-47F6-B8BF-97C8B442C62B}"/>
               </a:ext>
             </a:extLst>
           </p:cNvPr>
@@ -15993,7 +16122,7 @@
           <p:cNvPr id="17" name="">
             <a:extLst xmlns:a="http://schemas.openxmlformats.org/drawingml/2006/main">
               <a:ext uri="{FF2B5EF4-FFF2-40B4-BE49-F238E27FC236}">
-                <a16:creationId xmlns:a16="http://schemas.microsoft.com/office/drawing/2014/main" id="{24C9DC27-45A7-4EBF-AF06-AC5821853E27}"/>
+                <a16:creationId xmlns:a16="http://schemas.microsoft.com/office/drawing/2014/main" id="{24434967-F0EB-41EC-8C9A-41F61A51677E}"/>
               </a:ext>
             </a:extLst>
           </p:cNvPr>
@@ -16057,7 +16186,7 @@
           <p:cNvPr id="18" name="">
             <a:extLst xmlns:a="http://schemas.openxmlformats.org/drawingml/2006/main">
               <a:ext uri="{FF2B5EF4-FFF2-40B4-BE49-F238E27FC236}">
-                <a16:creationId xmlns:a16="http://schemas.microsoft.com/office/drawing/2014/main" id="{C015318C-6001-43A5-A49C-F264962B4B17}"/>
+                <a16:creationId xmlns:a16="http://schemas.microsoft.com/office/drawing/2014/main" id="{AA3BCADC-5758-4588-BCC4-1C1AEE3F875E}"/>
               </a:ext>
             </a:extLst>
           </p:cNvPr>
@@ -16090,7 +16219,7 @@
           <p:cNvPr id="19" name="">
             <a:extLst xmlns:a="http://schemas.openxmlformats.org/drawingml/2006/main">
               <a:ext uri="{FF2B5EF4-FFF2-40B4-BE49-F238E27FC236}">
-                <a16:creationId xmlns:a16="http://schemas.microsoft.com/office/drawing/2014/main" id="{D0155B13-2159-4006-B955-5BB963F5F744}"/>
+                <a16:creationId xmlns:a16="http://schemas.microsoft.com/office/drawing/2014/main" id="{5F6EC07C-BAA6-45B9-B2F9-4E50D50C10DE}"/>
               </a:ext>
             </a:extLst>
           </p:cNvPr>
@@ -16154,7 +16283,7 @@
           <p:cNvPr id="20" name="">
             <a:extLst xmlns:a="http://schemas.openxmlformats.org/drawingml/2006/main">
               <a:ext uri="{FF2B5EF4-FFF2-40B4-BE49-F238E27FC236}">
-                <a16:creationId xmlns:a16="http://schemas.microsoft.com/office/drawing/2014/main" id="{A268253B-EFB3-41F4-B626-5C46DDB68CF4}"/>
+                <a16:creationId xmlns:a16="http://schemas.microsoft.com/office/drawing/2014/main" id="{D39966C9-E2DA-40AC-B7F7-EDE8877D7155}"/>
               </a:ext>
             </a:extLst>
           </p:cNvPr>
@@ -16218,7 +16347,7 @@
           <p:cNvPr id="21" name="">
             <a:extLst xmlns:a="http://schemas.openxmlformats.org/drawingml/2006/main">
               <a:ext uri="{FF2B5EF4-FFF2-40B4-BE49-F238E27FC236}">
-                <a16:creationId xmlns:a16="http://schemas.microsoft.com/office/drawing/2014/main" id="{5E6E5AB3-1B43-4234-BA7C-DC565212CABD}"/>
+                <a16:creationId xmlns:a16="http://schemas.microsoft.com/office/drawing/2014/main" id="{79E297FE-42ED-4DAA-A63D-F091C1806545}"/>
               </a:ext>
             </a:extLst>
           </p:cNvPr>
@@ -16253,7 +16382,7 @@
           <p:cNvPr id="22" name="">
             <a:extLst xmlns:a="http://schemas.openxmlformats.org/drawingml/2006/main">
               <a:ext uri="{FF2B5EF4-FFF2-40B4-BE49-F238E27FC236}">
-                <a16:creationId xmlns:a16="http://schemas.microsoft.com/office/drawing/2014/main" id="{C00557E2-9591-4891-B2F7-9805B2094C5D}"/>
+                <a16:creationId xmlns:a16="http://schemas.microsoft.com/office/drawing/2014/main" id="{E59FE577-66B8-4C84-801B-368568492087}"/>
               </a:ext>
             </a:extLst>
           </p:cNvPr>
@@ -16317,7 +16446,7 @@
           <p:cNvPr id="23" name="">
             <a:extLst xmlns:a="http://schemas.openxmlformats.org/drawingml/2006/main">
               <a:ext uri="{FF2B5EF4-FFF2-40B4-BE49-F238E27FC236}">
-                <a16:creationId xmlns:a16="http://schemas.microsoft.com/office/drawing/2014/main" id="{AC9E7E02-2BE0-4C09-BF4A-BE02EC16308D}"/>
+                <a16:creationId xmlns:a16="http://schemas.microsoft.com/office/drawing/2014/main" id="{17D5F53B-1F32-4111-AA82-46934CAB9DEF}"/>
               </a:ext>
             </a:extLst>
           </p:cNvPr>
@@ -16381,7 +16510,7 @@
           <p:cNvPr id="24" name="">
             <a:extLst xmlns:a="http://schemas.openxmlformats.org/drawingml/2006/main">
               <a:ext uri="{FF2B5EF4-FFF2-40B4-BE49-F238E27FC236}">
-                <a16:creationId xmlns:a16="http://schemas.microsoft.com/office/drawing/2014/main" id="{9B78314B-3168-4943-9EFE-05AB342D4F2D}"/>
+                <a16:creationId xmlns:a16="http://schemas.microsoft.com/office/drawing/2014/main" id="{8AB5F736-261E-4B5A-A22E-96FF1D320C39}"/>
               </a:ext>
             </a:extLst>
           </p:cNvPr>
@@ -16443,7 +16572,7 @@
     </p:spTree>
     <p:extLst>
       <p:ext uri="{BB962C8B-B14F-4D97-AF65-F5344CB8AC3E}">
-        <p14:creationId xmlns:p14="http://schemas.microsoft.com/office/powerpoint/2010/main" val="278241763"/>
+        <p14:creationId xmlns:p14="http://schemas.microsoft.com/office/powerpoint/2010/main" val="1016604825"/>
       </p:ext>
     </p:extLst>
   </p:cSld>
@@ -16467,7 +16596,7 @@
           <p:cNvPr id="1" name="">
             <a:extLst xmlns:a="http://schemas.openxmlformats.org/drawingml/2006/main">
               <a:ext uri="{FF2B5EF4-FFF2-40B4-BE49-F238E27FC236}">
-                <a16:creationId xmlns:a16="http://schemas.microsoft.com/office/drawing/2014/main" id="{A78EF7C3-B56A-44EF-A2AF-C7FCC1D3F14D}"/>
+                <a16:creationId xmlns:a16="http://schemas.microsoft.com/office/drawing/2014/main" id="{D76DF360-7083-4092-821C-368B5E6065C4}"/>
               </a:ext>
             </a:extLst>
           </p:cNvPr>
@@ -16502,7 +16631,7 @@
           <p:cNvPr id="2" name="">
             <a:extLst xmlns:a="http://schemas.openxmlformats.org/drawingml/2006/main">
               <a:ext uri="{FF2B5EF4-FFF2-40B4-BE49-F238E27FC236}">
-                <a16:creationId xmlns:a16="http://schemas.microsoft.com/office/drawing/2014/main" id="{95A62187-5B83-47F3-87CE-E6884C67C054}"/>
+                <a16:creationId xmlns:a16="http://schemas.microsoft.com/office/drawing/2014/main" id="{C1BA0ED8-616B-4132-8810-3CECD3365CD8}"/>
               </a:ext>
             </a:extLst>
           </p:cNvPr>
@@ -16537,7 +16666,7 @@
           <p:cNvPr id="3" name="">
             <a:extLst xmlns:a="http://schemas.openxmlformats.org/drawingml/2006/main">
               <a:ext uri="{FF2B5EF4-FFF2-40B4-BE49-F238E27FC236}">
-                <a16:creationId xmlns:a16="http://schemas.microsoft.com/office/drawing/2014/main" id="{BA6B3CF6-A8A1-4FFD-8248-4AE085431CBD}"/>
+                <a16:creationId xmlns:a16="http://schemas.microsoft.com/office/drawing/2014/main" id="{5AD0A40A-9E4B-4967-ADD9-B72FB108D702}"/>
               </a:ext>
             </a:extLst>
           </p:cNvPr>
@@ -16572,7 +16701,7 @@
           <p:cNvPr id="4" name="">
             <a:extLst xmlns:a="http://schemas.openxmlformats.org/drawingml/2006/main">
               <a:ext uri="{FF2B5EF4-FFF2-40B4-BE49-F238E27FC236}">
-                <a16:creationId xmlns:a16="http://schemas.microsoft.com/office/drawing/2014/main" id="{665F077A-D8AD-4314-92F1-2DEB0275EC00}"/>
+                <a16:creationId xmlns:a16="http://schemas.microsoft.com/office/drawing/2014/main" id="{3AABF211-0753-46C2-9148-DCBFDDC338F0}"/>
               </a:ext>
             </a:extLst>
           </p:cNvPr>
@@ -16607,7 +16736,7 @@
           <p:cNvPr id="5" name="">
             <a:extLst xmlns:a="http://schemas.openxmlformats.org/drawingml/2006/main">
               <a:ext uri="{FF2B5EF4-FFF2-40B4-BE49-F238E27FC236}">
-                <a16:creationId xmlns:a16="http://schemas.microsoft.com/office/drawing/2014/main" id="{E8F58C93-D5DE-4D88-A34A-19C92956EC18}"/>
+                <a16:creationId xmlns:a16="http://schemas.microsoft.com/office/drawing/2014/main" id="{546E9082-34DA-40CD-AE71-5F255D286171}"/>
               </a:ext>
             </a:extLst>
           </p:cNvPr>
@@ -16642,7 +16771,7 @@
           <p:cNvPr id="6" name="">
             <a:extLst xmlns:a="http://schemas.openxmlformats.org/drawingml/2006/main">
               <a:ext uri="{FF2B5EF4-FFF2-40B4-BE49-F238E27FC236}">
-                <a16:creationId xmlns:a16="http://schemas.microsoft.com/office/drawing/2014/main" id="{6290E608-E5EC-4412-B270-A75375D84A95}"/>
+                <a16:creationId xmlns:a16="http://schemas.microsoft.com/office/drawing/2014/main" id="{4D5CF17E-9331-483F-9DCE-DF44A204E332}"/>
               </a:ext>
             </a:extLst>
           </p:cNvPr>
@@ -16706,7 +16835,7 @@
           <p:cNvPr id="7" name="">
             <a:extLst xmlns:a="http://schemas.openxmlformats.org/drawingml/2006/main">
               <a:ext uri="{FF2B5EF4-FFF2-40B4-BE49-F238E27FC236}">
-                <a16:creationId xmlns:a16="http://schemas.microsoft.com/office/drawing/2014/main" id="{4529D788-10F4-4387-A3F6-471870C1D422}"/>
+                <a16:creationId xmlns:a16="http://schemas.microsoft.com/office/drawing/2014/main" id="{AEB9CBD4-A9C0-4747-B3CC-B9C74047BB4A}"/>
               </a:ext>
             </a:extLst>
           </p:cNvPr>
@@ -16770,7 +16899,7 @@
           <p:cNvPr id="8" name="">
             <a:extLst xmlns:a="http://schemas.openxmlformats.org/drawingml/2006/main">
               <a:ext uri="{FF2B5EF4-FFF2-40B4-BE49-F238E27FC236}">
-                <a16:creationId xmlns:a16="http://schemas.microsoft.com/office/drawing/2014/main" id="{D3A4925C-28B5-43F2-85B1-98FB589E6303}"/>
+                <a16:creationId xmlns:a16="http://schemas.microsoft.com/office/drawing/2014/main" id="{14F91D7B-D408-4DF7-A044-465A8F2F7D48}"/>
               </a:ext>
             </a:extLst>
           </p:cNvPr>
@@ -16834,7 +16963,7 @@
           <p:cNvPr id="9" name="">
             <a:extLst xmlns:a="http://schemas.openxmlformats.org/drawingml/2006/main">
               <a:ext uri="{FF2B5EF4-FFF2-40B4-BE49-F238E27FC236}">
-                <a16:creationId xmlns:a16="http://schemas.microsoft.com/office/drawing/2014/main" id="{DD77330D-C7E1-4165-9B21-E3F8A92C39BA}"/>
+                <a16:creationId xmlns:a16="http://schemas.microsoft.com/office/drawing/2014/main" id="{73D7FAC5-1D52-4C9E-8312-91CEEFCB651C}"/>
               </a:ext>
             </a:extLst>
           </p:cNvPr>
@@ -16867,7 +16996,7 @@
           <p:cNvPr id="10" name="">
             <a:extLst xmlns:a="http://schemas.openxmlformats.org/drawingml/2006/main">
               <a:ext uri="{FF2B5EF4-FFF2-40B4-BE49-F238E27FC236}">
-                <a16:creationId xmlns:a16="http://schemas.microsoft.com/office/drawing/2014/main" id="{60983F1F-3F26-4490-9100-26174353E778}"/>
+                <a16:creationId xmlns:a16="http://schemas.microsoft.com/office/drawing/2014/main" id="{7EED4689-9A67-4CCC-B68F-A4E8DD7B3C2B}"/>
               </a:ext>
             </a:extLst>
           </p:cNvPr>
@@ -16931,7 +17060,7 @@
           <p:cNvPr id="11" name="">
             <a:extLst xmlns:a="http://schemas.openxmlformats.org/drawingml/2006/main">
               <a:ext uri="{FF2B5EF4-FFF2-40B4-BE49-F238E27FC236}">
-                <a16:creationId xmlns:a16="http://schemas.microsoft.com/office/drawing/2014/main" id="{F12816E3-3824-4867-8987-D0A8C1C3D2F5}"/>
+                <a16:creationId xmlns:a16="http://schemas.microsoft.com/office/drawing/2014/main" id="{A5BBCDDC-CCC8-4F97-B90E-949FD747CF89}"/>
               </a:ext>
             </a:extLst>
           </p:cNvPr>
@@ -16966,7 +17095,7 @@
           <p:cNvPr id="12" name="">
             <a:extLst xmlns:a="http://schemas.openxmlformats.org/drawingml/2006/main">
               <a:ext uri="{FF2B5EF4-FFF2-40B4-BE49-F238E27FC236}">
-                <a16:creationId xmlns:a16="http://schemas.microsoft.com/office/drawing/2014/main" id="{EE7FEF4A-8231-4361-9D88-D8BC6C60B7CB}"/>
+                <a16:creationId xmlns:a16="http://schemas.microsoft.com/office/drawing/2014/main" id="{B3B6BB83-F603-47EE-B5CD-DB2FBA7E4B62}"/>
               </a:ext>
             </a:extLst>
           </p:cNvPr>
@@ -17030,7 +17159,7 @@
           <p:cNvPr id="13" name="">
             <a:extLst xmlns:a="http://schemas.openxmlformats.org/drawingml/2006/main">
               <a:ext uri="{FF2B5EF4-FFF2-40B4-BE49-F238E27FC236}">
-                <a16:creationId xmlns:a16="http://schemas.microsoft.com/office/drawing/2014/main" id="{C484CF19-7A60-4288-A9AF-9E16F6D50ECF}"/>
+                <a16:creationId xmlns:a16="http://schemas.microsoft.com/office/drawing/2014/main" id="{F74BDBAD-43D0-427A-9E21-02FA29FF24E1}"/>
               </a:ext>
             </a:extLst>
           </p:cNvPr>
@@ -17065,7 +17194,7 @@
           <p:cNvPr id="14" name="">
             <a:extLst xmlns:a="http://schemas.openxmlformats.org/drawingml/2006/main">
               <a:ext uri="{FF2B5EF4-FFF2-40B4-BE49-F238E27FC236}">
-                <a16:creationId xmlns:a16="http://schemas.microsoft.com/office/drawing/2014/main" id="{167E7264-586A-4CC0-9FB6-B9DD421BFB8D}"/>
+                <a16:creationId xmlns:a16="http://schemas.microsoft.com/office/drawing/2014/main" id="{4554B338-6A34-4F74-971C-889393CA1921}"/>
               </a:ext>
             </a:extLst>
           </p:cNvPr>
@@ -17129,7 +17258,7 @@
           <p:cNvPr id="15" name="">
             <a:extLst xmlns:a="http://schemas.openxmlformats.org/drawingml/2006/main">
               <a:ext uri="{FF2B5EF4-FFF2-40B4-BE49-F238E27FC236}">
-                <a16:creationId xmlns:a16="http://schemas.microsoft.com/office/drawing/2014/main" id="{F2EF76E8-5584-4DD6-90D4-6444DBF6896B}"/>
+                <a16:creationId xmlns:a16="http://schemas.microsoft.com/office/drawing/2014/main" id="{1B0B7BE7-C701-4629-BE9F-DB25BD71DF0A}"/>
               </a:ext>
             </a:extLst>
           </p:cNvPr>
@@ -17164,7 +17293,7 @@
           <p:cNvPr id="16" name="">
             <a:extLst xmlns:a="http://schemas.openxmlformats.org/drawingml/2006/main">
               <a:ext uri="{FF2B5EF4-FFF2-40B4-BE49-F238E27FC236}">
-                <a16:creationId xmlns:a16="http://schemas.microsoft.com/office/drawing/2014/main" id="{CDEBF077-E433-48C8-8888-A626ECD65792}"/>
+                <a16:creationId xmlns:a16="http://schemas.microsoft.com/office/drawing/2014/main" id="{EC1E43F1-28C3-499F-8CC8-B6BC3A97FF33}"/>
               </a:ext>
             </a:extLst>
           </p:cNvPr>
@@ -17228,7 +17357,7 @@
           <p:cNvPr id="17" name="">
             <a:extLst xmlns:a="http://schemas.openxmlformats.org/drawingml/2006/main">
               <a:ext uri="{FF2B5EF4-FFF2-40B4-BE49-F238E27FC236}">
-                <a16:creationId xmlns:a16="http://schemas.microsoft.com/office/drawing/2014/main" id="{D159C923-B7E2-4D79-BF22-CFC5F7E902EF}"/>
+                <a16:creationId xmlns:a16="http://schemas.microsoft.com/office/drawing/2014/main" id="{F7E6A3C0-F128-4CDC-BCD3-C1BAC66E2202}"/>
               </a:ext>
             </a:extLst>
           </p:cNvPr>
@@ -17263,7 +17392,7 @@
           <p:cNvPr id="18" name="">
             <a:extLst xmlns:a="http://schemas.openxmlformats.org/drawingml/2006/main">
               <a:ext uri="{FF2B5EF4-FFF2-40B4-BE49-F238E27FC236}">
-                <a16:creationId xmlns:a16="http://schemas.microsoft.com/office/drawing/2014/main" id="{08C44C8F-C60D-420C-B458-4B87B87DB8C3}"/>
+                <a16:creationId xmlns:a16="http://schemas.microsoft.com/office/drawing/2014/main" id="{33F2562C-BD56-4658-A531-CEE217958F7A}"/>
               </a:ext>
             </a:extLst>
           </p:cNvPr>
@@ -17327,7 +17456,7 @@
           <p:cNvPr id="19" name="">
             <a:extLst xmlns:a="http://schemas.openxmlformats.org/drawingml/2006/main">
               <a:ext uri="{FF2B5EF4-FFF2-40B4-BE49-F238E27FC236}">
-                <a16:creationId xmlns:a16="http://schemas.microsoft.com/office/drawing/2014/main" id="{DC5B896F-92AD-49CD-A9A5-26503F838A97}"/>
+                <a16:creationId xmlns:a16="http://schemas.microsoft.com/office/drawing/2014/main" id="{C6FDDBEE-0A9B-4F15-BFA1-6DF2C8A20D1B}"/>
               </a:ext>
             </a:extLst>
           </p:cNvPr>
@@ -17360,7 +17489,7 @@
           <p:cNvPr id="20" name="">
             <a:extLst xmlns:a="http://schemas.openxmlformats.org/drawingml/2006/main">
               <a:ext uri="{FF2B5EF4-FFF2-40B4-BE49-F238E27FC236}">
-                <a16:creationId xmlns:a16="http://schemas.microsoft.com/office/drawing/2014/main" id="{5FF17F25-9C36-4582-8308-0F01F9684A47}"/>
+                <a16:creationId xmlns:a16="http://schemas.microsoft.com/office/drawing/2014/main" id="{55BFE034-B75D-434F-8719-FE4A61140117}"/>
               </a:ext>
             </a:extLst>
           </p:cNvPr>
@@ -17424,7 +17553,7 @@
           <p:cNvPr id="21" name="">
             <a:extLst xmlns:a="http://schemas.openxmlformats.org/drawingml/2006/main">
               <a:ext uri="{FF2B5EF4-FFF2-40B4-BE49-F238E27FC236}">
-                <a16:creationId xmlns:a16="http://schemas.microsoft.com/office/drawing/2014/main" id="{20A5E454-B34F-4291-96E9-8BCD6C79FA66}"/>
+                <a16:creationId xmlns:a16="http://schemas.microsoft.com/office/drawing/2014/main" id="{9CB9FB93-8AEB-4E28-A91A-DD9CC6AF74B8}"/>
               </a:ext>
             </a:extLst>
           </p:cNvPr>
@@ -17459,7 +17588,7 @@
           <p:cNvPr id="22" name="">
             <a:extLst xmlns:a="http://schemas.openxmlformats.org/drawingml/2006/main">
               <a:ext uri="{FF2B5EF4-FFF2-40B4-BE49-F238E27FC236}">
-                <a16:creationId xmlns:a16="http://schemas.microsoft.com/office/drawing/2014/main" id="{46694DFA-645C-429E-AD24-C1796D4DECC1}"/>
+                <a16:creationId xmlns:a16="http://schemas.microsoft.com/office/drawing/2014/main" id="{88E0F1B0-56F5-42F4-895A-EBBF1B965157}"/>
               </a:ext>
             </a:extLst>
           </p:cNvPr>
@@ -17523,7 +17652,7 @@
           <p:cNvPr id="23" name="">
             <a:extLst xmlns:a="http://schemas.openxmlformats.org/drawingml/2006/main">
               <a:ext uri="{FF2B5EF4-FFF2-40B4-BE49-F238E27FC236}">
-                <a16:creationId xmlns:a16="http://schemas.microsoft.com/office/drawing/2014/main" id="{3B5352B0-7C3C-4B86-8A96-EA8CC68DF5E0}"/>
+                <a16:creationId xmlns:a16="http://schemas.microsoft.com/office/drawing/2014/main" id="{BEC85C08-7DE5-432E-B2CB-0D9EA3645DBA}"/>
               </a:ext>
             </a:extLst>
           </p:cNvPr>
@@ -17558,7 +17687,7 @@
           <p:cNvPr id="24" name="">
             <a:extLst xmlns:a="http://schemas.openxmlformats.org/drawingml/2006/main">
               <a:ext uri="{FF2B5EF4-FFF2-40B4-BE49-F238E27FC236}">
-                <a16:creationId xmlns:a16="http://schemas.microsoft.com/office/drawing/2014/main" id="{2D0A34AD-08F3-4385-AAE7-84AD4397FBC9}"/>
+                <a16:creationId xmlns:a16="http://schemas.microsoft.com/office/drawing/2014/main" id="{52D6C43A-0ED0-4091-987F-E1D3042487EE}"/>
               </a:ext>
             </a:extLst>
           </p:cNvPr>
@@ -17622,7 +17751,7 @@
           <p:cNvPr id="25" name="">
             <a:extLst xmlns:a="http://schemas.openxmlformats.org/drawingml/2006/main">
               <a:ext uri="{FF2B5EF4-FFF2-40B4-BE49-F238E27FC236}">
-                <a16:creationId xmlns:a16="http://schemas.microsoft.com/office/drawing/2014/main" id="{1F7B8535-2F84-4F85-B9DD-1C92A67C3300}"/>
+                <a16:creationId xmlns:a16="http://schemas.microsoft.com/office/drawing/2014/main" id="{16DE8A83-0B6E-45DC-BC96-196E9C2B2502}"/>
               </a:ext>
             </a:extLst>
           </p:cNvPr>
@@ -17657,7 +17786,7 @@
           <p:cNvPr id="26" name="">
             <a:extLst xmlns:a="http://schemas.openxmlformats.org/drawingml/2006/main">
               <a:ext uri="{FF2B5EF4-FFF2-40B4-BE49-F238E27FC236}">
-                <a16:creationId xmlns:a16="http://schemas.microsoft.com/office/drawing/2014/main" id="{BED18787-ED66-427E-891A-E874D453E86A}"/>
+                <a16:creationId xmlns:a16="http://schemas.microsoft.com/office/drawing/2014/main" id="{974EF0BD-3CAD-4A78-B3DE-829CCE079758}"/>
               </a:ext>
             </a:extLst>
           </p:cNvPr>
@@ -17721,7 +17850,7 @@
           <p:cNvPr id="27" name="">
             <a:extLst xmlns:a="http://schemas.openxmlformats.org/drawingml/2006/main">
               <a:ext uri="{FF2B5EF4-FFF2-40B4-BE49-F238E27FC236}">
-                <a16:creationId xmlns:a16="http://schemas.microsoft.com/office/drawing/2014/main" id="{7E78B1CD-7806-4160-9998-A45969E6BBBB}"/>
+                <a16:creationId xmlns:a16="http://schemas.microsoft.com/office/drawing/2014/main" id="{A3C437CF-D106-408D-8A3F-E88A1B3A120E}"/>
               </a:ext>
             </a:extLst>
           </p:cNvPr>
@@ -17756,7 +17885,7 @@
           <p:cNvPr id="28" name="">
             <a:extLst xmlns:a="http://schemas.openxmlformats.org/drawingml/2006/main">
               <a:ext uri="{FF2B5EF4-FFF2-40B4-BE49-F238E27FC236}">
-                <a16:creationId xmlns:a16="http://schemas.microsoft.com/office/drawing/2014/main" id="{B00280B4-D4A8-448B-8C78-93C0CF7AB4EB}"/>
+                <a16:creationId xmlns:a16="http://schemas.microsoft.com/office/drawing/2014/main" id="{F72C8A28-C41E-4E10-A8E1-C1263E46C6D9}"/>
               </a:ext>
             </a:extLst>
           </p:cNvPr>
@@ -17820,7 +17949,7 @@
           <p:cNvPr id="29" name="">
             <a:extLst xmlns:a="http://schemas.openxmlformats.org/drawingml/2006/main">
               <a:ext uri="{FF2B5EF4-FFF2-40B4-BE49-F238E27FC236}">
-                <a16:creationId xmlns:a16="http://schemas.microsoft.com/office/drawing/2014/main" id="{98CF8932-C625-4E15-B1C8-505B27408E15}"/>
+                <a16:creationId xmlns:a16="http://schemas.microsoft.com/office/drawing/2014/main" id="{238BE224-12D0-4F4B-AF3A-690FC56200C7}"/>
               </a:ext>
             </a:extLst>
           </p:cNvPr>
@@ -17855,7 +17984,7 @@
           <p:cNvPr id="30" name="">
             <a:extLst xmlns:a="http://schemas.openxmlformats.org/drawingml/2006/main">
               <a:ext uri="{FF2B5EF4-FFF2-40B4-BE49-F238E27FC236}">
-                <a16:creationId xmlns:a16="http://schemas.microsoft.com/office/drawing/2014/main" id="{EF0A3A65-9C3F-449F-BAA4-7685C6952C27}"/>
+                <a16:creationId xmlns:a16="http://schemas.microsoft.com/office/drawing/2014/main" id="{C5795B12-5E1D-4E73-80FE-03A565E81AF0}"/>
               </a:ext>
             </a:extLst>
           </p:cNvPr>
@@ -17919,7 +18048,7 @@
           <p:cNvPr id="31" name="">
             <a:extLst xmlns:a="http://schemas.openxmlformats.org/drawingml/2006/main">
               <a:ext uri="{FF2B5EF4-FFF2-40B4-BE49-F238E27FC236}">
-                <a16:creationId xmlns:a16="http://schemas.microsoft.com/office/drawing/2014/main" id="{49018156-9FD1-4F11-9A90-CF5B6EAE7F64}"/>
+                <a16:creationId xmlns:a16="http://schemas.microsoft.com/office/drawing/2014/main" id="{5833AE71-1241-49E4-9A24-AFCA27FECD6A}"/>
               </a:ext>
             </a:extLst>
           </p:cNvPr>
@@ -17983,7 +18112,7 @@
           <p:cNvPr id="32" name="">
             <a:extLst xmlns:a="http://schemas.openxmlformats.org/drawingml/2006/main">
               <a:ext uri="{FF2B5EF4-FFF2-40B4-BE49-F238E27FC236}">
-                <a16:creationId xmlns:a16="http://schemas.microsoft.com/office/drawing/2014/main" id="{6832D9A9-2D26-4AB1-ADE6-78CB8946784C}"/>
+                <a16:creationId xmlns:a16="http://schemas.microsoft.com/office/drawing/2014/main" id="{F49E02D9-AC84-43D9-8B97-05D65234A672}"/>
               </a:ext>
             </a:extLst>
           </p:cNvPr>
@@ -18045,7 +18174,7 @@
     </p:spTree>
     <p:extLst>
       <p:ext uri="{BB962C8B-B14F-4D97-AF65-F5344CB8AC3E}">
-        <p14:creationId xmlns:p14="http://schemas.microsoft.com/office/powerpoint/2010/main" val="461406286"/>
+        <p14:creationId xmlns:p14="http://schemas.microsoft.com/office/powerpoint/2010/main" val="1736894264"/>
       </p:ext>
     </p:extLst>
   </p:cSld>

</xml_diff>